<commit_message>
Added QR code for examples
</commit_message>
<xml_diff>
--- a/poster_rebuilt.pptx
+++ b/poster_rebuilt.pptx
@@ -3870,7 +3870,7 @@
         <p:spPr>
           <a:xfrm>
             <a:off x="609600" y="4038600"/>
-            <a:ext cx="10210800" cy="3937000"/>
+            <a:ext cx="10210800" cy="3022600"/>
           </a:xfrm>
           <a:prstGeom prst="rect">
             <a:avLst/>
@@ -3930,8 +3930,8 @@
         </p:nvSpPr>
         <p:spPr>
           <a:xfrm>
-            <a:off x="609600" y="8305800"/>
-            <a:ext cx="10210800" cy="3530600"/>
+            <a:off x="609600" y="7264400"/>
+            <a:ext cx="10210800" cy="2590800"/>
           </a:xfrm>
           <a:prstGeom prst="rect">
             <a:avLst/>
@@ -3985,14 +3985,62 @@
       </p:sp>
       <p:sp>
         <p:nvSpPr>
-          <p:cNvPr id="6" name="Heading Skip optimizer if gradient is non-finite"/>
+          <p:cNvPr id="6" name="QR quiet zone"/>
+          <p:cNvSpPr/>
+          <p:nvPr/>
+        </p:nvSpPr>
+        <p:spPr>
+          <a:xfrm>
+            <a:off x="323850" y="9848850"/>
+            <a:ext cx="2476500" cy="2476500"/>
+          </a:xfrm>
+          <a:prstGeom prst="rect">
+            <a:avLst/>
+          </a:prstGeom>
+          <a:solidFill>
+            <a:srgbClr val="FFFFFF"/>
+          </a:solidFill>
+          <a:ln>
+            <a:noFill/>
+          </a:ln>
+        </p:spPr>
+      </p:sp>
+      <p:pic>
+        <p:nvPicPr>
+          <p:cNvPr id="7" name="QR: further examples">
+            <a:hlinkClick r:id="rId3"/>
+          </p:cNvPr>
+          <p:cNvPicPr>
+            <a:picLocks noChangeAspect="1"/>
+          </p:cNvPicPr>
+          <p:nvPr/>
+        </p:nvPicPr>
+        <p:blipFill>
+          <a:blip r:embed="rIdImage1"/>
+          <a:stretch>
+            <a:fillRect/>
+          </a:stretch>
+        </p:blipFill>
+        <p:spPr>
+          <a:xfrm>
+            <a:off x="609600" y="10134600"/>
+            <a:ext cx="1905000" cy="1905000"/>
+          </a:xfrm>
+          <a:prstGeom prst="rect">
+            <a:avLst/>
+          </a:prstGeom>
+        </p:spPr>
+      </p:pic>
+      <p:sp>
+        <p:nvSpPr>
+          <p:cNvPr id="8" name="Further examples heading"/>
           <p:cNvSpPr txBox="1"/>
           <p:nvPr/>
         </p:nvSpPr>
         <p:spPr>
           <a:xfrm>
-            <a:off x="11353800" y="4038600"/>
-            <a:ext cx="10210800" cy="476250"/>
+            <a:off x="2895600" y="10134600"/>
+            <a:ext cx="7924800" cy="476250"/>
           </a:xfrm>
           <a:prstGeom prst="rect">
             <a:avLst/>
@@ -4011,22 +4059,12 @@
             <a:r>
               <a:rPr lang="en-US" sz="3000" b="1" dirty="0">
                 <a:solidFill>
-                  <a:srgbClr val="1A6E6F"/>
+                  <a:srgbClr val="C44918"/>
                 </a:solidFill>
                 <a:latin typeface="Arial"/>
                 <a:cs typeface="Arial"/>
               </a:rPr>
-              <a:t>01  </a:t>
-            </a:r>
-            <a:r>
-              <a:rPr lang="en-US" sz="3000" b="1" dirty="0">
-                <a:solidFill>
-                  <a:srgbClr val="222222"/>
-                </a:solidFill>
-                <a:latin typeface="Arial"/>
-                <a:cs typeface="Arial"/>
-              </a:rPr>
-              <a:t>Skip optimizer if gradient is non-finite</a:t>
+              <a:t>Further examples</a:t>
             </a:r>
             <a:endParaRPr lang="en-US" sz="3000" dirty="0"/>
           </a:p>
@@ -4034,14 +4072,14 @@
       </p:sp>
       <p:sp>
         <p:nvSpPr>
-          <p:cNvPr id="7" name="Subline Skip optimizer if gradient is non-finite"/>
+          <p:cNvPr id="9" name="Further example 1"/>
           <p:cNvSpPr txBox="1"/>
           <p:nvPr/>
         </p:nvSpPr>
         <p:spPr>
           <a:xfrm>
-            <a:off x="11353800" y="4572000"/>
-            <a:ext cx="10210800" cy="333375"/>
+            <a:off x="2895600" y="10668000"/>
+            <a:ext cx="7924800" cy="333375"/>
           </a:xfrm>
           <a:prstGeom prst="rect">
             <a:avLst/>
@@ -4058,14 +4096,24 @@
               <a:buNone/>
             </a:pPr>
             <a:r>
+              <a:rPr lang="en-US" sz="2100" b="1" dirty="0">
+                <a:solidFill>
+                  <a:srgbClr val="C44918"/>
+                </a:solidFill>
+                <a:latin typeface="Liberation Mono"/>
+                <a:cs typeface="Liberation Mono"/>
+              </a:rPr>
+              <a:t>cond    </a:t>
+            </a:r>
+            <a:r>
               <a:rPr lang="en-US" sz="2100" b="0" dirty="0">
                 <a:solidFill>
-                  <a:srgbClr val="727070"/>
+                  <a:srgbClr val="222222"/>
                 </a:solidFill>
                 <a:latin typeface="Arial"/>
                 <a:cs typeface="Arial"/>
               </a:rPr>
-              <a:t>torch.cond()  →  IF/ELSE conditional node</a:t>
+              <a:t>optimizer skip</a:t>
             </a:r>
             <a:endParaRPr lang="en-US" sz="2100" dirty="0"/>
           </a:p>
@@ -4073,7 +4121,233 @@
       </p:sp>
       <p:sp>
         <p:nvSpPr>
-          <p:cNvPr id="8" name="Code: safe_sgd highlight"/>
+          <p:cNvPr id="10" name="Further example 2"/>
+          <p:cNvSpPr txBox="1"/>
+          <p:nvPr/>
+        </p:nvSpPr>
+        <p:spPr>
+          <a:xfrm>
+            <a:off x="2895600" y="11010900"/>
+            <a:ext cx="7924800" cy="333375"/>
+          </a:xfrm>
+          <a:prstGeom prst="rect">
+            <a:avLst/>
+          </a:prstGeom>
+          <a:noFill/>
+        </p:spPr>
+        <p:txBody>
+          <a:bodyPr wrap="none" lIns="0" tIns="0" rIns="0" bIns="0" anchor="t">
+            <a:noAutofit/>
+          </a:bodyPr>
+          <a:lstStyle/>
+          <a:p>
+            <a:pPr marL="0" indent="0" algn="l">
+              <a:buNone/>
+            </a:pPr>
+            <a:r>
+              <a:rPr lang="en-US" sz="2100" b="1" dirty="0">
+                <a:solidFill>
+                  <a:srgbClr val="C44918"/>
+                </a:solidFill>
+                <a:latin typeface="Liberation Mono"/>
+                <a:cs typeface="Liberation Mono"/>
+              </a:rPr>
+              <a:t>switch  </a:t>
+            </a:r>
+            <a:r>
+              <a:rPr lang="en-US" sz="2100" b="0" dirty="0">
+                <a:solidFill>
+                  <a:srgbClr val="222222"/>
+                </a:solidFill>
+                <a:latin typeface="Arial"/>
+                <a:cs typeface="Arial"/>
+              </a:rPr>
+              <a:t>embedding buckets</a:t>
+            </a:r>
+            <a:endParaRPr lang="en-US" sz="2100" dirty="0"/>
+          </a:p>
+        </p:txBody>
+      </p:sp>
+      <p:sp>
+        <p:nvSpPr>
+          <p:cNvPr id="11" name="Further example 3"/>
+          <p:cNvSpPr txBox="1"/>
+          <p:nvPr/>
+        </p:nvSpPr>
+        <p:spPr>
+          <a:xfrm>
+            <a:off x="2895600" y="11353800"/>
+            <a:ext cx="7924800" cy="333375"/>
+          </a:xfrm>
+          <a:prstGeom prst="rect">
+            <a:avLst/>
+          </a:prstGeom>
+          <a:noFill/>
+        </p:spPr>
+        <p:txBody>
+          <a:bodyPr wrap="none" lIns="0" tIns="0" rIns="0" bIns="0" anchor="t">
+            <a:noAutofit/>
+          </a:bodyPr>
+          <a:lstStyle/>
+          <a:p>
+            <a:pPr marL="0" indent="0" algn="l">
+              <a:buNone/>
+            </a:pPr>
+            <a:r>
+              <a:rPr lang="en-US" sz="2100" b="1" dirty="0">
+                <a:solidFill>
+                  <a:srgbClr val="C44918"/>
+                </a:solidFill>
+                <a:latin typeface="Liberation Mono"/>
+                <a:cs typeface="Liberation Mono"/>
+              </a:rPr>
+              <a:t>switch  </a:t>
+            </a:r>
+            <a:r>
+              <a:rPr lang="en-US" sz="2100" b="0" dirty="0">
+                <a:solidFill>
+                  <a:srgbClr val="222222"/>
+                </a:solidFill>
+                <a:latin typeface="Arial"/>
+                <a:cs typeface="Arial"/>
+              </a:rPr>
+              <a:t>top-1 MoE</a:t>
+            </a:r>
+            <a:endParaRPr lang="en-US" sz="2100" dirty="0"/>
+          </a:p>
+        </p:txBody>
+      </p:sp>
+      <p:sp>
+        <p:nvSpPr>
+          <p:cNvPr id="12" name="Further examples link"/>
+          <p:cNvSpPr txBox="1"/>
+          <p:nvPr/>
+        </p:nvSpPr>
+        <p:spPr>
+          <a:xfrm>
+            <a:off x="2895600" y="11747500"/>
+            <a:ext cx="7924800" cy="301625"/>
+          </a:xfrm>
+          <a:prstGeom prst="rect">
+            <a:avLst/>
+          </a:prstGeom>
+          <a:noFill/>
+        </p:spPr>
+        <p:txBody>
+          <a:bodyPr wrap="none" lIns="0" tIns="0" rIns="0" bIns="0" anchor="t">
+            <a:noAutofit/>
+          </a:bodyPr>
+          <a:lstStyle/>
+          <a:p>
+            <a:pPr marL="0" indent="0" algn="l">
+              <a:buNone/>
+            </a:pPr>
+            <a:r>
+              <a:rPr lang="en-US" sz="1900" b="0" dirty="0">
+                <a:solidFill>
+                  <a:srgbClr val="295897"/>
+                </a:solidFill>
+                <a:latin typeface="Arial"/>
+                <a:cs typeface="Arial"/>
+                <a:hlinkClick r:id="rId4"/>
+              </a:rPr>
+              <a:t>ibm.biz/controlflow-in-cuda-graphs</a:t>
+            </a:r>
+            <a:endParaRPr lang="en-US" sz="1900" dirty="0"/>
+          </a:p>
+        </p:txBody>
+      </p:sp>
+      <p:sp>
+        <p:nvSpPr>
+          <p:cNvPr id="13" name="Heading Skip optimizer if gradient is non-finite"/>
+          <p:cNvSpPr txBox="1"/>
+          <p:nvPr/>
+        </p:nvSpPr>
+        <p:spPr>
+          <a:xfrm>
+            <a:off x="11353800" y="4038600"/>
+            <a:ext cx="10210800" cy="476250"/>
+          </a:xfrm>
+          <a:prstGeom prst="rect">
+            <a:avLst/>
+          </a:prstGeom>
+          <a:noFill/>
+        </p:spPr>
+        <p:txBody>
+          <a:bodyPr wrap="none" lIns="0" tIns="0" rIns="0" bIns="0" anchor="t">
+            <a:noAutofit/>
+          </a:bodyPr>
+          <a:lstStyle/>
+          <a:p>
+            <a:pPr marL="0" indent="0" algn="l">
+              <a:buNone/>
+            </a:pPr>
+            <a:r>
+              <a:rPr lang="en-US" sz="3000" b="1" dirty="0">
+                <a:solidFill>
+                  <a:srgbClr val="1A6E6F"/>
+                </a:solidFill>
+                <a:latin typeface="Arial"/>
+                <a:cs typeface="Arial"/>
+              </a:rPr>
+              <a:t>01  </a:t>
+            </a:r>
+            <a:r>
+              <a:rPr lang="en-US" sz="3000" b="1" dirty="0">
+                <a:solidFill>
+                  <a:srgbClr val="222222"/>
+                </a:solidFill>
+                <a:latin typeface="Arial"/>
+                <a:cs typeface="Arial"/>
+              </a:rPr>
+              <a:t>Skip optimizer if gradient is non-finite</a:t>
+            </a:r>
+            <a:endParaRPr lang="en-US" sz="3000" dirty="0"/>
+          </a:p>
+        </p:txBody>
+      </p:sp>
+      <p:sp>
+        <p:nvSpPr>
+          <p:cNvPr id="14" name="Subline Skip optimizer if gradient is non-finite"/>
+          <p:cNvSpPr txBox="1"/>
+          <p:nvPr/>
+        </p:nvSpPr>
+        <p:spPr>
+          <a:xfrm>
+            <a:off x="11353800" y="4572000"/>
+            <a:ext cx="10210800" cy="333375"/>
+          </a:xfrm>
+          <a:prstGeom prst="rect">
+            <a:avLst/>
+          </a:prstGeom>
+          <a:noFill/>
+        </p:spPr>
+        <p:txBody>
+          <a:bodyPr wrap="none" lIns="0" tIns="0" rIns="0" bIns="0" anchor="t">
+            <a:noAutofit/>
+          </a:bodyPr>
+          <a:lstStyle/>
+          <a:p>
+            <a:pPr marL="0" indent="0" algn="l">
+              <a:buNone/>
+            </a:pPr>
+            <a:r>
+              <a:rPr lang="en-US" sz="2100" b="0" dirty="0">
+                <a:solidFill>
+                  <a:srgbClr val="727070"/>
+                </a:solidFill>
+                <a:latin typeface="Arial"/>
+                <a:cs typeface="Arial"/>
+              </a:rPr>
+              <a:t>torch.cond()  →  IF/ELSE conditional node</a:t>
+            </a:r>
+            <a:endParaRPr lang="en-US" sz="2100" dirty="0"/>
+          </a:p>
+        </p:txBody>
+      </p:sp>
+      <p:sp>
+        <p:nvSpPr>
+          <p:cNvPr id="15" name="Code: safe_sgd highlight"/>
           <p:cNvSpPr/>
           <p:nvPr/>
         </p:nvSpPr>
@@ -4095,7 +4369,7 @@
       </p:sp>
       <p:sp>
         <p:nvSpPr>
-          <p:cNvPr id="9" name="Code: safe_sgd marker"/>
+          <p:cNvPr id="16" name="Code: safe_sgd marker"/>
           <p:cNvSpPr/>
           <p:nvPr/>
         </p:nvSpPr>
@@ -4117,7 +4391,7 @@
       </p:sp>
       <p:sp>
         <p:nvSpPr>
-          <p:cNvPr id="10" name="Code: safe_sgd"/>
+          <p:cNvPr id="17" name="Code: safe_sgd"/>
           <p:cNvSpPr txBox="1"/>
           <p:nvPr/>
         </p:nvSpPr>
@@ -4863,7 +5137,7 @@
       </p:sp>
       <p:sp>
         <p:nvSpPr>
-          <p:cNvPr id="11" name="Capture label"/>
+          <p:cNvPr id="18" name="Capture label"/>
           <p:cNvSpPr txBox="1"/>
           <p:nvPr/>
         </p:nvSpPr>
@@ -4902,7 +5176,7 @@
       </p:sp>
       <p:sp>
         <p:nvSpPr>
-          <p:cNvPr id="12" name="Code: capture"/>
+          <p:cNvPr id="19" name="Code: capture"/>
           <p:cNvSpPr txBox="1"/>
           <p:nvPr/>
         </p:nvSpPr>
@@ -5233,7 +5507,7 @@
       </p:sp>
       <p:sp>
         <p:nvSpPr>
-          <p:cNvPr id="13" name="Note: cond 1"/>
+          <p:cNvPr id="20" name="Note: cond 1"/>
           <p:cNvSpPr txBox="1"/>
           <p:nvPr/>
         </p:nvSpPr>
@@ -5272,7 +5546,7 @@
       </p:sp>
       <p:sp>
         <p:nvSpPr>
-          <p:cNvPr id="14" name="Note: cond 2"/>
+          <p:cNvPr id="21" name="Note: cond 2"/>
           <p:cNvSpPr txBox="1"/>
           <p:nvPr/>
         </p:nvSpPr>
@@ -5311,7 +5585,7 @@
       </p:sp>
       <p:sp>
         <p:nvSpPr>
-          <p:cNvPr id="15" name="Note: cond 3"/>
+          <p:cNvPr id="22" name="Note: cond 3"/>
           <p:cNvSpPr txBox="1"/>
           <p:nvPr/>
         </p:nvSpPr>
@@ -5350,7 +5624,7 @@
       </p:sp>
       <p:sp>
         <p:nvSpPr>
-          <p:cNvPr id="16" name="Heading The captured CUDA graph"/>
+          <p:cNvPr id="23" name="Heading The captured CUDA graph"/>
           <p:cNvSpPr txBox="1"/>
           <p:nvPr/>
         </p:nvSpPr>
@@ -5389,7 +5663,7 @@
       </p:sp>
       <p:sp>
         <p:nvSpPr>
-          <p:cNvPr id="17" name="Subline The captured CUDA graph"/>
+          <p:cNvPr id="24" name="Subline The captured CUDA graph"/>
           <p:cNvSpPr txBox="1"/>
           <p:nvPr/>
         </p:nvSpPr>
@@ -5428,7 +5702,7 @@
       </p:sp>
       <p:sp>
         <p:nvSpPr>
-          <p:cNvPr id="18" name="Kernel: isfinite"/>
+          <p:cNvPr id="25" name="Kernel: isfinite"/>
           <p:cNvSpPr/>
           <p:nvPr/>
         </p:nvSpPr>
@@ -5477,7 +5751,7 @@
       </p:sp>
       <p:sp>
         <p:nvSpPr>
-          <p:cNvPr id="19" name="Note: kernels"/>
+          <p:cNvPr id="26" name="Note: kernels"/>
           <p:cNvSpPr txBox="1"/>
           <p:nvPr/>
         </p:nvSpPr>
@@ -5516,7 +5790,7 @@
       </p:sp>
       <p:cxnSp>
         <p:nvCxnSpPr>
-          <p:cNvPr id="20" name="Arrow"/>
+          <p:cNvPr id="27" name="Arrow"/>
           <p:cNvCxnSpPr/>
           <p:nvPr/>
         </p:nvCxnSpPr>
@@ -5539,7 +5813,7 @@
       </p:cxnSp>
       <p:sp>
         <p:nvSpPr>
-          <p:cNvPr id="21" name="Kernel: set handle"/>
+          <p:cNvPr id="28" name="Kernel: set handle"/>
           <p:cNvSpPr/>
           <p:nvPr/>
         </p:nvSpPr>
@@ -5588,7 +5862,7 @@
       </p:sp>
       <p:sp>
         <p:nvSpPr>
-          <p:cNvPr id="22" name="Note: handle"/>
+          <p:cNvPr id="29" name="Note: handle"/>
           <p:cNvSpPr txBox="1"/>
           <p:nvPr/>
         </p:nvSpPr>
@@ -5627,7 +5901,7 @@
       </p:sp>
       <p:cxnSp>
         <p:nvCxnSpPr>
-          <p:cNvPr id="23" name="Arrow"/>
+          <p:cNvPr id="30" name="Arrow"/>
           <p:cNvCxnSpPr/>
           <p:nvPr/>
         </p:nvCxnSpPr>
@@ -5650,7 +5924,7 @@
       </p:cxnSp>
       <p:sp>
         <p:nvSpPr>
-          <p:cNvPr id="24" name="IF/ELSE node"/>
+          <p:cNvPr id="31" name="IF/ELSE node"/>
           <p:cNvSpPr/>
           <p:nvPr/>
         </p:nvSpPr>
@@ -5677,7 +5951,7 @@
       </p:sp>
       <p:sp>
         <p:nvSpPr>
-          <p:cNvPr id="25" name="IF/ELSE node title"/>
+          <p:cNvPr id="32" name="IF/ELSE node title"/>
           <p:cNvSpPr txBox="1"/>
           <p:nvPr/>
         </p:nvSpPr>
@@ -5716,7 +5990,7 @@
       </p:sp>
       <p:sp>
         <p:nvSpPr>
-          <p:cNvPr id="26" name="IF/ELSE node handle"/>
+          <p:cNvPr id="33" name="IF/ELSE node handle"/>
           <p:cNvSpPr txBox="1"/>
           <p:nvPr/>
         </p:nvSpPr>
@@ -5755,7 +6029,7 @@
       </p:sp>
       <p:sp>
         <p:nvSpPr>
-          <p:cNvPr id="27" name="Body 0"/>
+          <p:cNvPr id="34" name="Body 0"/>
           <p:cNvSpPr/>
           <p:nvPr/>
         </p:nvSpPr>
@@ -5782,7 +6056,7 @@
       </p:sp>
       <p:sp>
         <p:nvSpPr>
-          <p:cNvPr id="28" name="Body 0 label"/>
+          <p:cNvPr id="35" name="Body 0 label"/>
           <p:cNvSpPr txBox="1"/>
           <p:nvPr/>
         </p:nvSpPr>
@@ -5821,7 +6095,7 @@
       </p:sp>
       <p:sp>
         <p:nvSpPr>
-          <p:cNvPr id="29" name="Body 0 kernel"/>
+          <p:cNvPr id="36" name="Body 0 kernel"/>
           <p:cNvSpPr/>
           <p:nvPr/>
         </p:nvSpPr>
@@ -5870,7 +6144,7 @@
       </p:sp>
       <p:sp>
         <p:nvSpPr>
-          <p:cNvPr id="30" name="Body 0 note"/>
+          <p:cNvPr id="37" name="Body 0 note"/>
           <p:cNvSpPr txBox="1"/>
           <p:nvPr/>
         </p:nvSpPr>
@@ -5909,7 +6183,7 @@
       </p:sp>
       <p:sp>
         <p:nvSpPr>
-          <p:cNvPr id="31" name="Body 1"/>
+          <p:cNvPr id="38" name="Body 1"/>
           <p:cNvSpPr/>
           <p:nvPr/>
         </p:nvSpPr>
@@ -5936,7 +6210,7 @@
       </p:sp>
       <p:sp>
         <p:nvSpPr>
-          <p:cNvPr id="32" name="Body 1 label"/>
+          <p:cNvPr id="39" name="Body 1 label"/>
           <p:cNvSpPr txBox="1"/>
           <p:nvPr/>
         </p:nvSpPr>
@@ -5975,7 +6249,7 @@
       </p:sp>
       <p:sp>
         <p:nvSpPr>
-          <p:cNvPr id="33" name="Body 1 kernel"/>
+          <p:cNvPr id="40" name="Body 1 kernel"/>
           <p:cNvSpPr/>
           <p:nvPr/>
         </p:nvSpPr>
@@ -6024,7 +6298,7 @@
       </p:sp>
       <p:sp>
         <p:nvSpPr>
-          <p:cNvPr id="34" name="Body 1 note"/>
+          <p:cNvPr id="41" name="Body 1 note"/>
           <p:cNvSpPr txBox="1"/>
           <p:nvPr/>
         </p:nvSpPr>
@@ -6063,7 +6337,7 @@
       </p:sp>
       <p:cxnSp>
         <p:nvCxnSpPr>
-          <p:cNvPr id="35" name="Arrow"/>
+          <p:cNvPr id="42" name="Arrow"/>
           <p:cNvCxnSpPr/>
           <p:nvPr/>
         </p:nvCxnSpPr>
@@ -6086,7 +6360,7 @@
       </p:cxnSp>
       <p:sp>
         <p:nvSpPr>
-          <p:cNvPr id="36" name="Parameter buffer"/>
+          <p:cNvPr id="43" name="Parameter buffer"/>
           <p:cNvSpPr/>
           <p:nvPr/>
         </p:nvSpPr>
@@ -6135,14 +6409,14 @@
       </p:sp>
       <p:sp>
         <p:nvSpPr>
-          <p:cNvPr id="37" name="Divider"/>
+          <p:cNvPr id="44" name="Divider"/>
           <p:cNvSpPr/>
           <p:nvPr/>
         </p:nvSpPr>
         <p:spPr>
           <a:xfrm>
             <a:off x="11087100" y="4038600"/>
-            <a:ext cx="12700" cy="7797800"/>
+            <a:ext cx="12700" cy="17551400"/>
           </a:xfrm>
           <a:prstGeom prst="rect">
             <a:avLst/>
@@ -6157,7 +6431,7 @@
       </p:sp>
       <p:sp>
         <p:nvSpPr>
-          <p:cNvPr id="38" name="Divider"/>
+          <p:cNvPr id="45" name="Divider"/>
           <p:cNvSpPr/>
           <p:nvPr/>
         </p:nvSpPr>
@@ -6179,14 +6453,14 @@
       </p:sp>
       <p:sp>
         <p:nvSpPr>
-          <p:cNvPr id="39" name="Rule"/>
+          <p:cNvPr id="46" name="Rule"/>
           <p:cNvSpPr/>
           <p:nvPr/>
         </p:nvSpPr>
         <p:spPr>
           <a:xfrm>
-            <a:off x="609600" y="12090400"/>
-            <a:ext cx="31699200" cy="25400"/>
+            <a:off x="11087100" y="12090400"/>
+            <a:ext cx="21221700" cy="25400"/>
           </a:xfrm>
           <a:prstGeom prst="rect">
             <a:avLst/>
@@ -6201,7 +6475,7 @@
       </p:sp>
       <p:sp>
         <p:nvSpPr>
-          <p:cNvPr id="40" name="Heading Support matrix"/>
+          <p:cNvPr id="47" name="Heading Support matrix"/>
           <p:cNvSpPr txBox="1"/>
           <p:nvPr/>
         </p:nvSpPr>
@@ -6240,7 +6514,7 @@
       </p:sp>
       <p:sp>
         <p:nvSpPr>
-          <p:cNvPr id="41" name="Subline Support matrix"/>
+          <p:cNvPr id="48" name="Subline Support matrix"/>
           <p:cNvSpPr txBox="1"/>
           <p:nvPr/>
         </p:nvSpPr>
@@ -6279,7 +6553,7 @@
       </p:sp>
       <p:sp>
         <p:nvSpPr>
-          <p:cNvPr id="42" name="Matrix op cond"/>
+          <p:cNvPr id="49" name="Matrix op cond"/>
           <p:cNvSpPr txBox="1"/>
           <p:nvPr/>
         </p:nvSpPr>
@@ -6318,7 +6592,7 @@
       </p:sp>
       <p:sp>
         <p:nvSpPr>
-          <p:cNvPr id="43" name="Matrix node cond"/>
+          <p:cNvPr id="50" name="Matrix node cond"/>
           <p:cNvSpPr txBox="1"/>
           <p:nvPr/>
         </p:nvSpPr>
@@ -6357,7 +6631,7 @@
       </p:sp>
       <p:sp>
         <p:nvSpPr>
-          <p:cNvPr id="44" name="Matrix op while_loop"/>
+          <p:cNvPr id="51" name="Matrix op while_loop"/>
           <p:cNvSpPr txBox="1"/>
           <p:nvPr/>
         </p:nvSpPr>
@@ -6396,7 +6670,7 @@
       </p:sp>
       <p:sp>
         <p:nvSpPr>
-          <p:cNvPr id="45" name="Matrix node while_loop"/>
+          <p:cNvPr id="52" name="Matrix node while_loop"/>
           <p:cNvSpPr txBox="1"/>
           <p:nvPr/>
         </p:nvSpPr>
@@ -6435,7 +6709,7 @@
       </p:sp>
       <p:sp>
         <p:nvSpPr>
-          <p:cNvPr id="46" name="Matrix op switch"/>
+          <p:cNvPr id="53" name="Matrix op switch"/>
           <p:cNvSpPr txBox="1"/>
           <p:nvPr/>
         </p:nvSpPr>
@@ -6474,7 +6748,7 @@
       </p:sp>
       <p:sp>
         <p:nvSpPr>
-          <p:cNvPr id="47" name="Matrix node switch"/>
+          <p:cNvPr id="54" name="Matrix node switch"/>
           <p:cNvSpPr txBox="1"/>
           <p:nvPr/>
         </p:nvSpPr>
@@ -6513,7 +6787,7 @@
       </p:sp>
       <p:sp>
         <p:nvSpPr>
-          <p:cNvPr id="48" name="Rule"/>
+          <p:cNvPr id="55" name="Rule"/>
           <p:cNvSpPr/>
           <p:nvPr/>
         </p:nvSpPr>
@@ -6535,7 +6809,7 @@
       </p:sp>
       <p:sp>
         <p:nvSpPr>
-          <p:cNvPr id="49" name="Matrix row PyTorch 2.14"/>
+          <p:cNvPr id="56" name="Matrix row PyTorch 2.14"/>
           <p:cNvSpPr txBox="1"/>
           <p:nvPr/>
         </p:nvSpPr>
@@ -6574,7 +6848,7 @@
       </p:sp>
       <p:sp>
         <p:nvSpPr>
-          <p:cNvPr id="50" name="Tick"/>
+          <p:cNvPr id="57" name="Tick"/>
           <p:cNvSpPr/>
           <p:nvPr/>
         </p:nvSpPr>
@@ -6614,7 +6888,7 @@
       </p:sp>
       <p:sp>
         <p:nvSpPr>
-          <p:cNvPr id="51" name="Tick"/>
+          <p:cNvPr id="58" name="Tick"/>
           <p:cNvSpPr/>
           <p:nvPr/>
         </p:nvSpPr>
@@ -6654,7 +6928,7 @@
       </p:sp>
       <p:sp>
         <p:nvSpPr>
-          <p:cNvPr id="52" name="Tick"/>
+          <p:cNvPr id="59" name="Tick"/>
           <p:cNvSpPr/>
           <p:nvPr/>
         </p:nvSpPr>
@@ -6694,7 +6968,7 @@
       </p:sp>
       <p:sp>
         <p:nvSpPr>
-          <p:cNvPr id="53" name="Matrix shade"/>
+          <p:cNvPr id="60" name="Matrix shade"/>
           <p:cNvSpPr/>
           <p:nvPr/>
         </p:nvSpPr>
@@ -6716,7 +6990,7 @@
       </p:sp>
       <p:sp>
         <p:nvSpPr>
-          <p:cNvPr id="54" name="Matrix row CUDA graph support"/>
+          <p:cNvPr id="61" name="Matrix row CUDA graph support"/>
           <p:cNvSpPr txBox="1"/>
           <p:nvPr/>
         </p:nvSpPr>
@@ -6755,7 +7029,7 @@
       </p:sp>
       <p:sp>
         <p:nvSpPr>
-          <p:cNvPr id="55" name="Tick"/>
+          <p:cNvPr id="62" name="Tick"/>
           <p:cNvSpPr/>
           <p:nvPr/>
         </p:nvSpPr>
@@ -6795,7 +7069,7 @@
       </p:sp>
       <p:sp>
         <p:nvSpPr>
-          <p:cNvPr id="56" name="Tick"/>
+          <p:cNvPr id="63" name="Tick"/>
           <p:cNvSpPr/>
           <p:nvPr/>
         </p:nvSpPr>
@@ -6835,7 +7109,7 @@
       </p:sp>
       <p:sp>
         <p:nvSpPr>
-          <p:cNvPr id="57" name="Barrier leg"/>
+          <p:cNvPr id="64" name="Barrier leg"/>
           <p:cNvSpPr/>
           <p:nvPr/>
         </p:nvSpPr>
@@ -6857,7 +7131,7 @@
       </p:sp>
       <p:sp>
         <p:nvSpPr>
-          <p:cNvPr id="58" name="Barrier leg"/>
+          <p:cNvPr id="65" name="Barrier leg"/>
           <p:cNvSpPr/>
           <p:nvPr/>
         </p:nvSpPr>
@@ -6879,7 +7153,7 @@
       </p:sp>
       <p:sp>
         <p:nvSpPr>
-          <p:cNvPr id="59" name="Barrier board"/>
+          <p:cNvPr id="66" name="Barrier board"/>
           <p:cNvSpPr/>
           <p:nvPr/>
         </p:nvSpPr>
@@ -6901,7 +7175,7 @@
       </p:sp>
       <p:sp>
         <p:nvSpPr>
-          <p:cNvPr id="60" name="Barrier stripes"/>
+          <p:cNvPr id="67" name="Barrier stripes"/>
           <p:cNvSpPr/>
           <p:nvPr/>
         </p:nvSpPr>
@@ -7001,7 +7275,7 @@
       </p:sp>
       <p:sp>
         <p:nvSpPr>
-          <p:cNvPr id="61" name="Barrier outline"/>
+          <p:cNvPr id="68" name="Barrier outline"/>
           <p:cNvSpPr/>
           <p:nvPr/>
         </p:nvSpPr>
@@ -7045,7 +7319,7 @@
       </p:sp>
       <p:sp>
         <p:nvSpPr>
-          <p:cNvPr id="62" name="Matrix row In-place input mutation*"/>
+          <p:cNvPr id="69" name="Matrix row In-place input mutation*"/>
           <p:cNvSpPr txBox="1"/>
           <p:nvPr/>
         </p:nvSpPr>
@@ -7084,7 +7358,7 @@
       </p:sp>
       <p:sp>
         <p:nvSpPr>
-          <p:cNvPr id="63" name="Tick"/>
+          <p:cNvPr id="70" name="Tick"/>
           <p:cNvSpPr/>
           <p:nvPr/>
         </p:nvSpPr>
@@ -7124,7 +7398,7 @@
       </p:sp>
       <p:sp>
         <p:nvSpPr>
-          <p:cNvPr id="64" name="Tick"/>
+          <p:cNvPr id="71" name="Tick"/>
           <p:cNvSpPr/>
           <p:nvPr/>
         </p:nvSpPr>
@@ -7164,7 +7438,7 @@
       </p:sp>
       <p:sp>
         <p:nvSpPr>
-          <p:cNvPr id="65" name="Tick"/>
+          <p:cNvPr id="72" name="Tick"/>
           <p:cNvSpPr/>
           <p:nvPr/>
         </p:nvSpPr>
@@ -7204,7 +7478,7 @@
       </p:sp>
       <p:sp>
         <p:nvSpPr>
-          <p:cNvPr id="66" name="Matrix shade"/>
+          <p:cNvPr id="73" name="Matrix shade"/>
           <p:cNvSpPr/>
           <p:nvPr/>
         </p:nvSpPr>
@@ -7226,7 +7500,7 @@
       </p:sp>
       <p:sp>
         <p:nvSpPr>
-          <p:cNvPr id="67" name="Matrix row Minimum CUDA"/>
+          <p:cNvPr id="74" name="Matrix row Minimum CUDA"/>
           <p:cNvSpPr txBox="1"/>
           <p:nvPr/>
         </p:nvSpPr>
@@ -7265,7 +7539,7 @@
       </p:sp>
       <p:sp>
         <p:nvSpPr>
-          <p:cNvPr id="68" name="Matrix cell Minimum CUDA 0"/>
+          <p:cNvPr id="75" name="Matrix cell Minimum CUDA 0"/>
           <p:cNvSpPr txBox="1"/>
           <p:nvPr/>
         </p:nvSpPr>
@@ -7304,7 +7578,7 @@
       </p:sp>
       <p:sp>
         <p:nvSpPr>
-          <p:cNvPr id="69" name="Matrix cell Minimum CUDA 1"/>
+          <p:cNvPr id="76" name="Matrix cell Minimum CUDA 1"/>
           <p:cNvSpPr txBox="1"/>
           <p:nvPr/>
         </p:nvSpPr>
@@ -7343,7 +7617,7 @@
       </p:sp>
       <p:sp>
         <p:nvSpPr>
-          <p:cNvPr id="70" name="Matrix cell Minimum CUDA 2"/>
+          <p:cNvPr id="77" name="Matrix cell Minimum CUDA 2"/>
           <p:cNvSpPr txBox="1"/>
           <p:nvPr/>
         </p:nvSpPr>
@@ -7382,7 +7656,7 @@
       </p:sp>
       <p:sp>
         <p:nvSpPr>
-          <p:cNvPr id="71" name="Matrix row Inductor backend"/>
+          <p:cNvPr id="78" name="Matrix row Inductor backend"/>
           <p:cNvSpPr txBox="1"/>
           <p:nvPr/>
         </p:nvSpPr>
@@ -7421,7 +7695,7 @@
       </p:sp>
       <p:sp>
         <p:nvSpPr>
-          <p:cNvPr id="72" name="Unsupported X"/>
+          <p:cNvPr id="79" name="Unsupported X"/>
           <p:cNvSpPr/>
           <p:nvPr/>
         </p:nvSpPr>
@@ -7466,7 +7740,7 @@
       </p:sp>
       <p:sp>
         <p:nvSpPr>
-          <p:cNvPr id="73" name="Unsupported X"/>
+          <p:cNvPr id="80" name="Unsupported X"/>
           <p:cNvSpPr/>
           <p:nvPr/>
         </p:nvSpPr>
@@ -7511,7 +7785,7 @@
       </p:sp>
       <p:sp>
         <p:nvSpPr>
-          <p:cNvPr id="74" name="Unsupported X"/>
+          <p:cNvPr id="81" name="Unsupported X"/>
           <p:cNvSpPr/>
           <p:nvPr/>
         </p:nvSpPr>
@@ -7556,7 +7830,7 @@
       </p:sp>
       <p:sp>
         <p:nvSpPr>
-          <p:cNvPr id="75" name="Rule"/>
+          <p:cNvPr id="82" name="Rule"/>
           <p:cNvSpPr/>
           <p:nvPr/>
         </p:nvSpPr>
@@ -7578,7 +7852,7 @@
       </p:sp>
       <p:sp>
         <p:nvSpPr>
-          <p:cNvPr id="76" name="Tick"/>
+          <p:cNvPr id="83" name="Tick"/>
           <p:cNvSpPr/>
           <p:nvPr/>
         </p:nvSpPr>
@@ -7618,7 +7892,7 @@
       </p:sp>
       <p:sp>
         <p:nvSpPr>
-          <p:cNvPr id="77" name="Legend done"/>
+          <p:cNvPr id="84" name="Legend done"/>
           <p:cNvSpPr txBox="1"/>
           <p:nvPr/>
         </p:nvSpPr>
@@ -7657,7 +7931,7 @@
       </p:sp>
       <p:sp>
         <p:nvSpPr>
-          <p:cNvPr id="78" name="Barrier leg"/>
+          <p:cNvPr id="85" name="Barrier leg"/>
           <p:cNvSpPr/>
           <p:nvPr/>
         </p:nvSpPr>
@@ -7679,7 +7953,7 @@
       </p:sp>
       <p:sp>
         <p:nvSpPr>
-          <p:cNvPr id="79" name="Barrier leg"/>
+          <p:cNvPr id="86" name="Barrier leg"/>
           <p:cNvSpPr/>
           <p:nvPr/>
         </p:nvSpPr>
@@ -7701,7 +7975,7 @@
       </p:sp>
       <p:sp>
         <p:nvSpPr>
-          <p:cNvPr id="80" name="Barrier board"/>
+          <p:cNvPr id="87" name="Barrier board"/>
           <p:cNvSpPr/>
           <p:nvPr/>
         </p:nvSpPr>
@@ -7723,7 +7997,7 @@
       </p:sp>
       <p:sp>
         <p:nvSpPr>
-          <p:cNvPr id="81" name="Barrier stripes"/>
+          <p:cNvPr id="88" name="Barrier stripes"/>
           <p:cNvSpPr/>
           <p:nvPr/>
         </p:nvSpPr>
@@ -7823,7 +8097,7 @@
       </p:sp>
       <p:sp>
         <p:nvSpPr>
-          <p:cNvPr id="82" name="Barrier outline"/>
+          <p:cNvPr id="89" name="Barrier outline"/>
           <p:cNvSpPr/>
           <p:nvPr/>
         </p:nvSpPr>
@@ -7867,7 +8141,7 @@
       </p:sp>
       <p:sp>
         <p:nvSpPr>
-          <p:cNvPr id="83" name="Legend open"/>
+          <p:cNvPr id="90" name="Legend open"/>
           <p:cNvSpPr txBox="1"/>
           <p:nvPr/>
         </p:nvSpPr>
@@ -7906,7 +8180,7 @@
       </p:sp>
       <p:sp>
         <p:nvSpPr>
-          <p:cNvPr id="84" name="Matrix note 1"/>
+          <p:cNvPr id="91" name="Matrix note 1"/>
           <p:cNvSpPr txBox="1"/>
           <p:nvPr/>
         </p:nvSpPr>
@@ -7945,7 +8219,7 @@
       </p:sp>
       <p:sp>
         <p:nvSpPr>
-          <p:cNvPr id="85" name="Matrix note 2"/>
+          <p:cNvPr id="92" name="Matrix note 2"/>
           <p:cNvSpPr txBox="1"/>
           <p:nvPr/>
         </p:nvSpPr>
@@ -7984,7 +8258,7 @@
       </p:sp>
       <p:sp>
         <p:nvSpPr>
-          <p:cNvPr id="86" name="Matrix note 3"/>
+          <p:cNvPr id="93" name="Matrix note 3"/>
           <p:cNvSpPr txBox="1"/>
           <p:nvPr/>
         </p:nvSpPr>
@@ -8023,7 +8297,7 @@
       </p:sp>
       <p:sp>
         <p:nvSpPr>
-          <p:cNvPr id="87" name="Matrix note 4"/>
+          <p:cNvPr id="94" name="Matrix note 4"/>
           <p:cNvSpPr txBox="1"/>
           <p:nvPr/>
         </p:nvSpPr>
@@ -8062,7 +8336,7 @@
       </p:sp>
       <p:sp>
         <p:nvSpPr>
-          <p:cNvPr id="88" name="Heading Embedding bags without maximum padding"/>
+          <p:cNvPr id="95" name="Heading Embedding bags without maximum padding"/>
           <p:cNvSpPr txBox="1"/>
           <p:nvPr/>
         </p:nvSpPr>
@@ -8111,7 +8385,7 @@
       </p:sp>
       <p:sp>
         <p:nvSpPr>
-          <p:cNvPr id="89" name="Subline Embedding bags without maximum padding"/>
+          <p:cNvPr id="96" name="Subline Embedding bags without maximum padding"/>
           <p:cNvSpPr txBox="1"/>
           <p:nvPr/>
         </p:nvSpPr>
@@ -8150,7 +8424,7 @@
       </p:sp>
       <p:sp>
         <p:nvSpPr>
-          <p:cNvPr id="90" name="Embedding motivation"/>
+          <p:cNvPr id="97" name="Embedding motivation"/>
           <p:cNvSpPr txBox="1"/>
           <p:nvPr/>
         </p:nvSpPr>
@@ -8192,7 +8466,7 @@
       </p:sp>
       <p:sp>
         <p:nvSpPr>
-          <p:cNvPr id="91" name="Import: embedding switch"/>
+          <p:cNvPr id="98" name="Import: embedding switch"/>
           <p:cNvSpPr txBox="1"/>
           <p:nvPr/>
         </p:nvSpPr>
@@ -8231,7 +8505,7 @@
       </p:sp>
       <p:sp>
         <p:nvSpPr>
-          <p:cNvPr id="92" name="Code: embedding_bag highlight"/>
+          <p:cNvPr id="99" name="Code: embedding_bag highlight"/>
           <p:cNvSpPr/>
           <p:nvPr/>
         </p:nvSpPr>
@@ -8253,7 +8527,7 @@
       </p:sp>
       <p:sp>
         <p:nvSpPr>
-          <p:cNvPr id="93" name="Code: embedding_bag marker"/>
+          <p:cNvPr id="100" name="Code: embedding_bag marker"/>
           <p:cNvSpPr/>
           <p:nvPr/>
         </p:nvSpPr>
@@ -8275,7 +8549,7 @@
       </p:sp>
       <p:sp>
         <p:nvSpPr>
-          <p:cNvPr id="94" name="Code: embedding_bag"/>
+          <p:cNvPr id="101" name="Code: embedding_bag"/>
           <p:cNvSpPr txBox="1"/>
           <p:nvPr/>
         </p:nvSpPr>
@@ -10116,7 +10390,7 @@
       </p:sp>
       <p:sp>
         <p:nvSpPr>
-          <p:cNvPr id="95" name="Embedding SWITCH"/>
+          <p:cNvPr id="102" name="Embedding SWITCH"/>
           <p:cNvSpPr/>
           <p:nvPr/>
         </p:nvSpPr>
@@ -10143,7 +10417,7 @@
       </p:sp>
       <p:sp>
         <p:nvSpPr>
-          <p:cNvPr id="96" name="Embedding SWITCH title"/>
+          <p:cNvPr id="103" name="Embedding SWITCH title"/>
           <p:cNvSpPr txBox="1"/>
           <p:nvPr/>
         </p:nvSpPr>
@@ -10182,7 +10456,7 @@
       </p:sp>
       <p:sp>
         <p:nvSpPr>
-          <p:cNvPr id="97" name="Embedding SWITCH handle"/>
+          <p:cNvPr id="104" name="Embedding SWITCH handle"/>
           <p:cNvSpPr txBox="1"/>
           <p:nvPr/>
         </p:nvSpPr>
@@ -10221,7 +10495,7 @@
       </p:sp>
       <p:sp>
         <p:nvSpPr>
-          <p:cNvPr id="98" name="Embedding bucket 32"/>
+          <p:cNvPr id="105" name="Embedding bucket 32"/>
           <p:cNvSpPr/>
           <p:nvPr/>
         </p:nvSpPr>
@@ -10270,7 +10544,7 @@
       </p:sp>
       <p:sp>
         <p:nvSpPr>
-          <p:cNvPr id="99" name="Embedding bucket 128"/>
+          <p:cNvPr id="106" name="Embedding bucket 128"/>
           <p:cNvSpPr/>
           <p:nvPr/>
         </p:nvSpPr>
@@ -10319,7 +10593,7 @@
       </p:sp>
       <p:sp>
         <p:nvSpPr>
-          <p:cNvPr id="100" name="Embedding bucket 512"/>
+          <p:cNvPr id="107" name="Embedding bucket 512"/>
           <p:cNvSpPr/>
           <p:nvPr/>
         </p:nvSpPr>
@@ -10368,7 +10642,7 @@
       </p:sp>
       <p:sp>
         <p:nvSpPr>
-          <p:cNvPr id="101" name="Embedding bucket 4096"/>
+          <p:cNvPr id="108" name="Embedding bucket 4096"/>
           <p:cNvSpPr/>
           <p:nvPr/>
         </p:nvSpPr>
@@ -10417,7 +10691,7 @@
       </p:sp>
       <p:sp>
         <p:nvSpPr>
-          <p:cNvPr id="102" name="Embedding bucket result"/>
+          <p:cNvPr id="109" name="Embedding bucket result"/>
           <p:cNvSpPr txBox="1"/>
           <p:nvPr/>
         </p:nvSpPr>
@@ -10456,7 +10730,7 @@
       </p:sp>
       <p:sp>
         <p:nvSpPr>
-          <p:cNvPr id="103" name="Embedding input contract"/>
+          <p:cNvPr id="110" name="Embedding input contract"/>
           <p:cNvSpPr txBox="1"/>
           <p:nvPr/>
         </p:nvSpPr>
@@ -10495,7 +10769,7 @@
       </p:sp>
       <p:sp>
         <p:nvSpPr>
-          <p:cNvPr id="104" name="Heading Lossless MoE routing with software backpressure"/>
+          <p:cNvPr id="111" name="Heading Lossless MoE routing with software backpressure"/>
           <p:cNvSpPr txBox="1"/>
           <p:nvPr/>
         </p:nvSpPr>
@@ -10544,7 +10818,7 @@
       </p:sp>
       <p:sp>
         <p:nvSpPr>
-          <p:cNvPr id="105" name="Subline Lossless MoE routing with software backpressure"/>
+          <p:cNvPr id="112" name="Subline Lossless MoE routing with software backpressure"/>
           <p:cNvSpPr txBox="1"/>
           <p:nvPr/>
         </p:nvSpPr>
@@ -10583,7 +10857,7 @@
       </p:sp>
       <p:sp>
         <p:nvSpPr>
-          <p:cNvPr id="106" name="MoE capacity"/>
+          <p:cNvPr id="113" name="MoE capacity"/>
           <p:cNvSpPr txBox="1"/>
           <p:nvPr/>
         </p:nvSpPr>
@@ -10622,7 +10896,7 @@
       </p:sp>
       <p:sp>
         <p:nvSpPr>
-          <p:cNvPr id="107" name="MoE rounds heading"/>
+          <p:cNvPr id="114" name="MoE rounds heading"/>
           <p:cNvSpPr txBox="1"/>
           <p:nvPr/>
         </p:nvSpPr>
@@ -10661,7 +10935,7 @@
       </p:sp>
       <p:sp>
         <p:nvSpPr>
-          <p:cNvPr id="108" name="Code: MoE rounds"/>
+          <p:cNvPr id="115" name="Code: MoE rounds"/>
           <p:cNvSpPr txBox="1"/>
           <p:nvPr/>
         </p:nvSpPr>
@@ -11001,7 +11275,7 @@
       </p:sp>
       <p:sp>
         <p:nvSpPr>
-          <p:cNvPr id="109" name="MoE GEMM heading"/>
+          <p:cNvPr id="116" name="MoE GEMM heading"/>
           <p:cNvSpPr txBox="1"/>
           <p:nvPr/>
         </p:nvSpPr>
@@ -11040,7 +11314,7 @@
       </p:sp>
       <p:sp>
         <p:nvSpPr>
-          <p:cNvPr id="110" name="Code: MoE grouped GEMM"/>
+          <p:cNvPr id="117" name="Code: MoE grouped GEMM"/>
           <p:cNvSpPr txBox="1"/>
           <p:nvPr/>
         </p:nvSpPr>
@@ -12112,7 +12386,7 @@
       </p:sp>
       <p:sp>
         <p:nvSpPr>
-          <p:cNvPr id="111" name="MoE loop heading"/>
+          <p:cNvPr id="118" name="MoE loop heading"/>
           <p:cNvSpPr txBox="1"/>
           <p:nvPr/>
         </p:nvSpPr>
@@ -12151,7 +12425,7 @@
       </p:sp>
       <p:sp>
         <p:nvSpPr>
-          <p:cNvPr id="112" name="Code: MoE while loop highlight"/>
+          <p:cNvPr id="119" name="Code: MoE while loop highlight"/>
           <p:cNvSpPr/>
           <p:nvPr/>
         </p:nvSpPr>
@@ -12173,7 +12447,7 @@
       </p:sp>
       <p:sp>
         <p:nvSpPr>
-          <p:cNvPr id="113" name="Code: MoE while loop marker"/>
+          <p:cNvPr id="120" name="Code: MoE while loop marker"/>
           <p:cNvSpPr/>
           <p:nvPr/>
         </p:nvSpPr>
@@ -12195,7 +12469,7 @@
       </p:sp>
       <p:sp>
         <p:nvSpPr>
-          <p:cNvPr id="114" name="Code: MoE while loop"/>
+          <p:cNvPr id="121" name="Code: MoE while loop"/>
           <p:cNvSpPr txBox="1"/>
           <p:nvPr/>
         </p:nvSpPr>
@@ -12615,7 +12889,7 @@
       </p:sp>
       <p:sp>
         <p:nvSpPr>
-          <p:cNvPr id="115" name="MoE excerpt note"/>
+          <p:cNvPr id="122" name="MoE excerpt note"/>
           <p:cNvSpPr txBox="1"/>
           <p:nvPr/>
         </p:nvSpPr>
@@ -12654,29 +12928,7 @@
       </p:sp>
       <p:sp>
         <p:nvSpPr>
-          <p:cNvPr id="116" name="Divider"/>
-          <p:cNvSpPr/>
-          <p:nvPr/>
-        </p:nvSpPr>
-        <p:spPr>
-          <a:xfrm>
-            <a:off x="11087100" y="12344400"/>
-            <a:ext cx="12700" cy="9245600"/>
-          </a:xfrm>
-          <a:prstGeom prst="rect">
-            <a:avLst/>
-          </a:prstGeom>
-          <a:solidFill>
-            <a:srgbClr val="D5D4D5"/>
-          </a:solidFill>
-          <a:ln>
-            <a:noFill/>
-          </a:ln>
-        </p:spPr>
-      </p:sp>
-      <p:sp>
-        <p:nvSpPr>
-          <p:cNvPr id="117" name="Divider"/>
+          <p:cNvPr id="123" name="Divider"/>
           <p:cNvSpPr/>
           <p:nvPr/>
         </p:nvSpPr>

</xml_diff>

<commit_message>
Various edits for clarity
</commit_message>
<xml_diff>
--- a/poster_rebuilt.pptx
+++ b/poster_rebuilt.pptx
@@ -3892,7 +3892,7 @@
             <a:r>
               <a:rPr lang="en-US" sz="3000" b="1" dirty="0">
                 <a:solidFill>
-                  <a:srgbClr val="727070"/>
+                  <a:srgbClr val="1A6E6F"/>
                 </a:solidFill>
                 <a:latin typeface="Arial"/>
                 <a:cs typeface="Arial"/>
@@ -3916,7 +3916,7 @@
                 <a:latin typeface="Arial"/>
                 <a:cs typeface="Arial"/>
               </a:rPr>
-              <a:t>CUDA graphs could not capture any data-dependent control flow in PyTorch because that involved synchronizing with the host. Though CUDA graph conditional nodes can run data-dependent control flow fully on the GPU, they were not yet expressible via PyTorch. Users had to split their workload into multiple CUDA graphs, which is intrusive and hard to maintain.</a:t>
+              <a:t>CUDA graphs could not capture any data-dependent control flow in PyTorch because that involved synchronizing with the host. Though CUDA graph conditional nodes can run data-dependent control flow fully on the GPU, they were not yet expressible via PyTorch. Users had to split their workload into multiple CUDA graphs, which is intrusive, hard to maintain, and causes GPU idle bubbles.</a:t>
             </a:r>
             <a:endParaRPr lang="en-US" sz="2500" dirty="0"/>
           </a:p>
@@ -3977,7 +3977,7 @@
                 <a:latin typeface="Arial"/>
                 <a:cs typeface="Arial"/>
               </a:rPr>
-              <a:t>Control flow expressed with torch.cond(), torch.while_loop(), or torch.switch() can now be lowered to a CUDA graph. Outputs must keep a fixed shape across branches and loop iterations. Within that constraint, data-dependent control flow is useful for real workloads, as the examples here demonstrate.</a:t>
+              <a:t>Control flow expressed with torch.cond(), torch.while_loop(), or torch.switch() can now be lowered to a CUDA graph automatically. Outputs must keep a fixed shape across branches and loop iterations. Within that constraint, data-dependent control flow is useful for several real workloads, as the examples here demonstrate.</a:t>
             </a:r>
             <a:endParaRPr lang="en-US" sz="2500" dirty="0"/>
           </a:p>
@@ -4064,7 +4064,7 @@
                 <a:latin typeface="Arial"/>
                 <a:cs typeface="Arial"/>
               </a:rPr>
-              <a:t>Further examples</a:t>
+              <a:t>Full example source code</a:t>
             </a:r>
             <a:endParaRPr lang="en-US" sz="3000" dirty="0"/>
           </a:p>
@@ -4103,7 +4103,7 @@
                 <a:latin typeface="Liberation Mono"/>
                 <a:cs typeface="Liberation Mono"/>
               </a:rPr>
-              <a:t>cond    </a:t>
+              <a:t>cond         </a:t>
             </a:r>
             <a:r>
               <a:rPr lang="en-US" sz="2100" b="0" dirty="0">
@@ -4152,7 +4152,7 @@
                 <a:latin typeface="Liberation Mono"/>
                 <a:cs typeface="Liberation Mono"/>
               </a:rPr>
-              <a:t>switch  </a:t>
+              <a:t>switch       </a:t>
             </a:r>
             <a:r>
               <a:rPr lang="en-US" sz="2100" b="0" dirty="0">
@@ -4201,7 +4201,7 @@
                 <a:latin typeface="Liberation Mono"/>
                 <a:cs typeface="Liberation Mono"/>
               </a:rPr>
-              <a:t>switch  </a:t>
+              <a:t>while_loop() </a:t>
             </a:r>
             <a:r>
               <a:rPr lang="en-US" sz="2100" b="0" dirty="0">
@@ -4211,7 +4211,7 @@
                 <a:latin typeface="Arial"/>
                 <a:cs typeface="Arial"/>
               </a:rPr>
-              <a:t>top-1 MoE</a:t>
+              <a:t>MoE</a:t>
             </a:r>
             <a:endParaRPr lang="en-US" sz="2100" dirty="0"/>
           </a:p>
@@ -5538,7 +5538,27 @@
                 <a:latin typeface="Arial"/>
                 <a:cs typeface="Arial"/>
               </a:rPr>
-              <a:t>The predicate never leaves the GPU: no .item(), no CPU sync.</a:t>
+              <a:t>The predicate </a:t>
+            </a:r>
+            <a:r>
+              <a:rPr lang="en-US" sz="2100" b="0" dirty="0">
+                <a:solidFill>
+                  <a:srgbClr val="222222"/>
+                </a:solidFill>
+                <a:latin typeface="Liberation Mono"/>
+                <a:cs typeface="Liberation Mono"/>
+              </a:rPr>
+              <a:t>finite</a:t>
+            </a:r>
+            <a:r>
+              <a:rPr lang="en-US" sz="2100" b="0" dirty="0">
+                <a:solidFill>
+                  <a:srgbClr val="222222"/>
+                </a:solidFill>
+                <a:latin typeface="Arial"/>
+                <a:cs typeface="Arial"/>
+              </a:rPr>
+              <a:t> never leaves the GPU: no .item(), no CPU sync.</a:t>
             </a:r>
             <a:endParaRPr lang="en-US" sz="2100" dirty="0"/>
           </a:p>
@@ -5616,7 +5636,27 @@
                 <a:latin typeface="Arial"/>
                 <a:cs typeface="Arial"/>
               </a:rPr>
-              <a:t>Before: a Python if on this flag forces a CPU sync and breaks capture.</a:t>
+              <a:t>Before a Python if on the </a:t>
+            </a:r>
+            <a:r>
+              <a:rPr lang="en-US" sz="2100" b="0" dirty="0">
+                <a:solidFill>
+                  <a:srgbClr val="727070"/>
+                </a:solidFill>
+                <a:latin typeface="Liberation Mono"/>
+                <a:cs typeface="Liberation Mono"/>
+              </a:rPr>
+              <a:t>finite</a:t>
+            </a:r>
+            <a:r>
+              <a:rPr lang="en-US" sz="2100" b="0" dirty="0">
+                <a:solidFill>
+                  <a:srgbClr val="727070"/>
+                </a:solidFill>
+                <a:latin typeface="Arial"/>
+                <a:cs typeface="Arial"/>
+              </a:rPr>
+              <a:t> flag forces a CPU sync and breaks capture.</a:t>
             </a:r>
             <a:endParaRPr lang="en-US" sz="2100" dirty="0"/>
           </a:p>
@@ -5670,7 +5710,7 @@
         <p:spPr>
           <a:xfrm>
             <a:off x="22098000" y="4572000"/>
-            <a:ext cx="10210800" cy="333375"/>
+            <a:ext cx="10210800" cy="301625"/>
           </a:xfrm>
           <a:prstGeom prst="rect">
             <a:avLst/>
@@ -5687,16 +5727,16 @@
               <a:buNone/>
             </a:pPr>
             <a:r>
-              <a:rPr lang="en-US" sz="2100" b="0" dirty="0">
+              <a:rPr lang="en-US" sz="1900" b="0" dirty="0">
                 <a:solidFill>
                   <a:srgbClr val="727070"/>
                 </a:solidFill>
                 <a:latin typeface="Arial"/>
                 <a:cs typeface="Arial"/>
               </a:rPr>
-              <a:t>What safe_sgd becomes: one graph, GPU-side branch</a:t>
-            </a:r>
-            <a:endParaRPr lang="en-US" sz="2100" dirty="0"/>
+              <a:t>What safe_sgd becomes: one graph, GPU-side branch, no CPU involvement</a:t>
+            </a:r>
+            <a:endParaRPr lang="en-US" sz="1900" dirty="0"/>
           </a:p>
         </p:txBody>
       </p:sp>
@@ -7438,14 +7478,80 @@
       </p:sp>
       <p:sp>
         <p:nvSpPr>
-          <p:cNvPr id="72" name="Tick"/>
+          <p:cNvPr id="72" name="Barrier leg"/>
           <p:cNvSpPr/>
           <p:nvPr/>
         </p:nvSpPr>
         <p:spPr>
           <a:xfrm>
-            <a:off x="9503833" y="16040100"/>
-            <a:ext cx="457200" cy="457200"/>
+            <a:off x="9538987" y="16307562"/>
+            <a:ext cx="43180" cy="138176"/>
+          </a:xfrm>
+          <a:prstGeom prst="rect">
+            <a:avLst/>
+          </a:prstGeom>
+          <a:solidFill>
+            <a:srgbClr val="3A3A3A"/>
+          </a:solidFill>
+          <a:ln>
+            <a:noFill/>
+          </a:ln>
+        </p:spPr>
+      </p:sp>
+      <p:sp>
+        <p:nvSpPr>
+          <p:cNvPr id="73" name="Barrier leg"/>
+          <p:cNvSpPr/>
+          <p:nvPr/>
+        </p:nvSpPr>
+        <p:spPr>
+          <a:xfrm>
+            <a:off x="9882700" y="16307562"/>
+            <a:ext cx="43180" cy="138176"/>
+          </a:xfrm>
+          <a:prstGeom prst="rect">
+            <a:avLst/>
+          </a:prstGeom>
+          <a:solidFill>
+            <a:srgbClr val="3A3A3A"/>
+          </a:solidFill>
+          <a:ln>
+            <a:noFill/>
+          </a:ln>
+        </p:spPr>
+      </p:sp>
+      <p:sp>
+        <p:nvSpPr>
+          <p:cNvPr id="74" name="Barrier board"/>
+          <p:cNvSpPr/>
+          <p:nvPr/>
+        </p:nvSpPr>
+        <p:spPr>
+          <a:xfrm>
+            <a:off x="9430173" y="16091662"/>
+            <a:ext cx="604520" cy="215900"/>
+          </a:xfrm>
+          <a:prstGeom prst="rect">
+            <a:avLst/>
+          </a:prstGeom>
+          <a:solidFill>
+            <a:srgbClr val="FFFFFF"/>
+          </a:solidFill>
+          <a:ln>
+            <a:noFill/>
+          </a:ln>
+        </p:spPr>
+      </p:sp>
+      <p:sp>
+        <p:nvSpPr>
+          <p:cNvPr id="75" name="Barrier stripes"/>
+          <p:cNvSpPr/>
+          <p:nvPr/>
+        </p:nvSpPr>
+        <p:spPr>
+          <a:xfrm>
+            <a:off x="9430173" y="16091662"/>
+            <a:ext cx="604520" cy="215900"/>
           </a:xfrm>
           <a:custGeom>
             <a:avLst/>
@@ -7454,23 +7560,127 @@
             <a:cxnLst/>
             <a:rect l="0" t="0" r="r" b="b"/>
             <a:pathLst>
-              <a:path w="457200" h="457200" fill="none">
+              <a:path w="604520" h="215900">
                 <a:moveTo>
-                  <a:pt x="45720" y="251460"/>
+                  <a:pt x="0" y="0"/>
                 </a:moveTo>
                 <a:lnTo>
-                  <a:pt x="182880" y="388620"/>
+                  <a:pt x="100753" y="0"/>
                 </a:lnTo>
                 <a:lnTo>
-                  <a:pt x="420624" y="82296"/>
+                  <a:pt x="0" y="100753"/>
                 </a:lnTo>
+                <a:close/>
+              </a:path>
+              <a:path w="604520" h="215900">
+                <a:moveTo>
+                  <a:pt x="201507" y="0"/>
+                </a:moveTo>
+                <a:lnTo>
+                  <a:pt x="302260" y="0"/>
+                </a:lnTo>
+                <a:lnTo>
+                  <a:pt x="86360" y="215900"/>
+                </a:lnTo>
+                <a:lnTo>
+                  <a:pt x="0" y="215900"/>
+                </a:lnTo>
+                <a:lnTo>
+                  <a:pt x="0" y="201507"/>
+                </a:lnTo>
+                <a:close/>
+              </a:path>
+              <a:path w="604520" h="215900">
+                <a:moveTo>
+                  <a:pt x="403013" y="0"/>
+                </a:moveTo>
+                <a:lnTo>
+                  <a:pt x="503767" y="0"/>
+                </a:lnTo>
+                <a:lnTo>
+                  <a:pt x="287867" y="215900"/>
+                </a:lnTo>
+                <a:lnTo>
+                  <a:pt x="187113" y="215900"/>
+                </a:lnTo>
+                <a:close/>
+              </a:path>
+              <a:path w="604520" h="215900">
+                <a:moveTo>
+                  <a:pt x="604520" y="0"/>
+                </a:moveTo>
+                <a:lnTo>
+                  <a:pt x="604520" y="100753"/>
+                </a:lnTo>
+                <a:lnTo>
+                  <a:pt x="489373" y="215900"/>
+                </a:lnTo>
+                <a:lnTo>
+                  <a:pt x="388620" y="215900"/>
+                </a:lnTo>
+                <a:close/>
+              </a:path>
+              <a:path w="604520" h="215900">
+                <a:moveTo>
+                  <a:pt x="604520" y="201507"/>
+                </a:moveTo>
+                <a:lnTo>
+                  <a:pt x="604520" y="215900"/>
+                </a:lnTo>
+                <a:lnTo>
+                  <a:pt x="590127" y="215900"/>
+                </a:lnTo>
+                <a:close/>
+              </a:path>
+            </a:pathLst>
+          </a:custGeom>
+          <a:solidFill>
+            <a:srgbClr val="E8710A"/>
+          </a:solidFill>
+          <a:ln>
+            <a:noFill/>
+          </a:ln>
+        </p:spPr>
+      </p:sp>
+      <p:sp>
+        <p:nvSpPr>
+          <p:cNvPr id="76" name="Barrier outline"/>
+          <p:cNvSpPr/>
+          <p:nvPr/>
+        </p:nvSpPr>
+        <p:spPr>
+          <a:xfrm>
+            <a:off x="9430173" y="16091662"/>
+            <a:ext cx="604520" cy="215900"/>
+          </a:xfrm>
+          <a:custGeom>
+            <a:avLst/>
+            <a:gdLst/>
+            <a:ahLst/>
+            <a:cxnLst/>
+            <a:rect l="0" t="0" r="r" b="b"/>
+            <a:pathLst>
+              <a:path w="604520" h="215900" fill="none">
+                <a:moveTo>
+                  <a:pt x="0" y="0"/>
+                </a:moveTo>
+                <a:lnTo>
+                  <a:pt x="604520" y="0"/>
+                </a:lnTo>
+                <a:lnTo>
+                  <a:pt x="604520" y="215900"/>
+                </a:lnTo>
+                <a:lnTo>
+                  <a:pt x="0" y="215900"/>
+                </a:lnTo>
+                <a:close/>
               </a:path>
             </a:pathLst>
           </a:custGeom>
           <a:noFill/>
-          <a:ln w="68580" cap="rnd">
+          <a:ln w="19050" cap="rnd">
             <a:solidFill>
-              <a:srgbClr val="2E7D32"/>
+              <a:srgbClr val="3A3A3A"/>
             </a:solidFill>
             <a:round/>
           </a:ln>
@@ -7478,7 +7688,7 @@
       </p:sp>
       <p:sp>
         <p:nvSpPr>
-          <p:cNvPr id="73" name="Matrix shade"/>
+          <p:cNvPr id="77" name="Matrix shade"/>
           <p:cNvSpPr/>
           <p:nvPr/>
         </p:nvSpPr>
@@ -7500,7 +7710,7 @@
       </p:sp>
       <p:sp>
         <p:nvSpPr>
-          <p:cNvPr id="74" name="Matrix row Minimum CUDA"/>
+          <p:cNvPr id="78" name="Matrix row Minimum CUDA"/>
           <p:cNvSpPr txBox="1"/>
           <p:nvPr/>
         </p:nvSpPr>
@@ -7539,7 +7749,7 @@
       </p:sp>
       <p:sp>
         <p:nvSpPr>
-          <p:cNvPr id="75" name="Matrix cell Minimum CUDA 0"/>
+          <p:cNvPr id="79" name="Matrix cell Minimum CUDA 0"/>
           <p:cNvSpPr txBox="1"/>
           <p:nvPr/>
         </p:nvSpPr>
@@ -7578,7 +7788,7 @@
       </p:sp>
       <p:sp>
         <p:nvSpPr>
-          <p:cNvPr id="76" name="Matrix cell Minimum CUDA 1"/>
+          <p:cNvPr id="80" name="Matrix cell Minimum CUDA 1"/>
           <p:cNvSpPr txBox="1"/>
           <p:nvPr/>
         </p:nvSpPr>
@@ -7617,7 +7827,7 @@
       </p:sp>
       <p:sp>
         <p:nvSpPr>
-          <p:cNvPr id="77" name="Matrix cell Minimum CUDA 2"/>
+          <p:cNvPr id="81" name="Matrix cell Minimum CUDA 2"/>
           <p:cNvSpPr txBox="1"/>
           <p:nvPr/>
         </p:nvSpPr>
@@ -7656,7 +7866,7 @@
       </p:sp>
       <p:sp>
         <p:nvSpPr>
-          <p:cNvPr id="78" name="Matrix row Inductor backend"/>
+          <p:cNvPr id="82" name="Matrix row Inductor backend"/>
           <p:cNvSpPr txBox="1"/>
           <p:nvPr/>
         </p:nvSpPr>
@@ -7695,7 +7905,7 @@
       </p:sp>
       <p:sp>
         <p:nvSpPr>
-          <p:cNvPr id="79" name="Unsupported X"/>
+          <p:cNvPr id="83" name="Unsupported X"/>
           <p:cNvSpPr/>
           <p:nvPr/>
         </p:nvSpPr>
@@ -7740,7 +7950,7 @@
       </p:sp>
       <p:sp>
         <p:nvSpPr>
-          <p:cNvPr id="80" name="Unsupported X"/>
+          <p:cNvPr id="84" name="Unsupported X"/>
           <p:cNvSpPr/>
           <p:nvPr/>
         </p:nvSpPr>
@@ -7785,7 +7995,7 @@
       </p:sp>
       <p:sp>
         <p:nvSpPr>
-          <p:cNvPr id="81" name="Unsupported X"/>
+          <p:cNvPr id="85" name="Unsupported X"/>
           <p:cNvSpPr/>
           <p:nvPr/>
         </p:nvSpPr>
@@ -7830,7 +8040,7 @@
       </p:sp>
       <p:sp>
         <p:nvSpPr>
-          <p:cNvPr id="82" name="Rule"/>
+          <p:cNvPr id="86" name="Rule"/>
           <p:cNvSpPr/>
           <p:nvPr/>
         </p:nvSpPr>
@@ -7852,7 +8062,7 @@
       </p:sp>
       <p:sp>
         <p:nvSpPr>
-          <p:cNvPr id="83" name="Tick"/>
+          <p:cNvPr id="87" name="Tick"/>
           <p:cNvSpPr/>
           <p:nvPr/>
         </p:nvSpPr>
@@ -7892,7 +8102,7 @@
       </p:sp>
       <p:sp>
         <p:nvSpPr>
-          <p:cNvPr id="84" name="Legend done"/>
+          <p:cNvPr id="88" name="Legend done"/>
           <p:cNvSpPr txBox="1"/>
           <p:nvPr/>
         </p:nvSpPr>
@@ -7931,7 +8141,7 @@
       </p:sp>
       <p:sp>
         <p:nvSpPr>
-          <p:cNvPr id="85" name="Barrier leg"/>
+          <p:cNvPr id="89" name="Barrier leg"/>
           <p:cNvSpPr/>
           <p:nvPr/>
         </p:nvSpPr>
@@ -7953,7 +8163,7 @@
       </p:sp>
       <p:sp>
         <p:nvSpPr>
-          <p:cNvPr id="86" name="Barrier leg"/>
+          <p:cNvPr id="90" name="Barrier leg"/>
           <p:cNvSpPr/>
           <p:nvPr/>
         </p:nvSpPr>
@@ -7975,7 +8185,7 @@
       </p:sp>
       <p:sp>
         <p:nvSpPr>
-          <p:cNvPr id="87" name="Barrier board"/>
+          <p:cNvPr id="91" name="Barrier board"/>
           <p:cNvSpPr/>
           <p:nvPr/>
         </p:nvSpPr>
@@ -7997,7 +8207,7 @@
       </p:sp>
       <p:sp>
         <p:nvSpPr>
-          <p:cNvPr id="88" name="Barrier stripes"/>
+          <p:cNvPr id="92" name="Barrier stripes"/>
           <p:cNvSpPr/>
           <p:nvPr/>
         </p:nvSpPr>
@@ -8097,7 +8307,7 @@
       </p:sp>
       <p:sp>
         <p:nvSpPr>
-          <p:cNvPr id="89" name="Barrier outline"/>
+          <p:cNvPr id="93" name="Barrier outline"/>
           <p:cNvSpPr/>
           <p:nvPr/>
         </p:nvSpPr>
@@ -8141,7 +8351,7 @@
       </p:sp>
       <p:sp>
         <p:nvSpPr>
-          <p:cNvPr id="90" name="Legend open"/>
+          <p:cNvPr id="94" name="Legend open"/>
           <p:cNvSpPr txBox="1"/>
           <p:nvPr/>
         </p:nvSpPr>
@@ -8180,7 +8390,7 @@
       </p:sp>
       <p:sp>
         <p:nvSpPr>
-          <p:cNvPr id="91" name="Matrix note 1"/>
+          <p:cNvPr id="95" name="Matrix note 1"/>
           <p:cNvSpPr txBox="1"/>
           <p:nvPr/>
         </p:nvSpPr>
@@ -8219,7 +8429,7 @@
       </p:sp>
       <p:sp>
         <p:nvSpPr>
-          <p:cNvPr id="92" name="Matrix note 2"/>
+          <p:cNvPr id="96" name="Matrix note 2"/>
           <p:cNvSpPr txBox="1"/>
           <p:nvPr/>
         </p:nvSpPr>
@@ -8258,7 +8468,7 @@
       </p:sp>
       <p:sp>
         <p:nvSpPr>
-          <p:cNvPr id="93" name="Matrix note 3"/>
+          <p:cNvPr id="97" name="Matrix note 3"/>
           <p:cNvSpPr txBox="1"/>
           <p:nvPr/>
         </p:nvSpPr>
@@ -8297,7 +8507,7 @@
       </p:sp>
       <p:sp>
         <p:nvSpPr>
-          <p:cNvPr id="94" name="Matrix note 4"/>
+          <p:cNvPr id="98" name="Matrix note 4"/>
           <p:cNvSpPr txBox="1"/>
           <p:nvPr/>
         </p:nvSpPr>
@@ -8336,7 +8546,7 @@
       </p:sp>
       <p:sp>
         <p:nvSpPr>
-          <p:cNvPr id="95" name="Heading Embedding bags without maximum padding"/>
+          <p:cNvPr id="99" name="Heading Embedding bags without maximum padding"/>
           <p:cNvSpPr txBox="1"/>
           <p:nvPr/>
         </p:nvSpPr>
@@ -8385,7 +8595,7 @@
       </p:sp>
       <p:sp>
         <p:nvSpPr>
-          <p:cNvPr id="96" name="Subline Embedding bags without maximum padding"/>
+          <p:cNvPr id="100" name="Subline Embedding bags without maximum padding"/>
           <p:cNvSpPr txBox="1"/>
           <p:nvPr/>
         </p:nvSpPr>
@@ -8424,7 +8634,7 @@
       </p:sp>
       <p:sp>
         <p:nvSpPr>
-          <p:cNvPr id="97" name="Embedding motivation"/>
+          <p:cNvPr id="101" name="Embedding motivation"/>
           <p:cNvSpPr txBox="1"/>
           <p:nvPr/>
         </p:nvSpPr>
@@ -8458,7 +8668,7 @@
                 <a:latin typeface="Arial"/>
                 <a:cs typeface="Arial"/>
               </a:rPr>
-              <a:t>Recommender system requests vary widely in token count, but each embedding bag returns a fixed-width vector. Select a token-count bucket on the GPU and pad only to that bucket's capacity.</a:t>
+              <a:t>Recommender system requests vary widely in token count, but each embedding bag returns a fixed-width vector. Select a token-count bucket on the GPU and pad only to that bucket's capacity for efficiency.</a:t>
             </a:r>
             <a:endParaRPr lang="en-US" sz="2300" dirty="0"/>
           </a:p>
@@ -8466,7 +8676,7 @@
       </p:sp>
       <p:sp>
         <p:nvSpPr>
-          <p:cNvPr id="98" name="Import: embedding switch"/>
+          <p:cNvPr id="102" name="Import: embedding switch"/>
           <p:cNvSpPr txBox="1"/>
           <p:nvPr/>
         </p:nvSpPr>
@@ -8505,7 +8715,7 @@
       </p:sp>
       <p:sp>
         <p:nvSpPr>
-          <p:cNvPr id="99" name="Code: embedding_bag highlight"/>
+          <p:cNvPr id="103" name="Code: embedding_bag highlight"/>
           <p:cNvSpPr/>
           <p:nvPr/>
         </p:nvSpPr>
@@ -8527,7 +8737,7 @@
       </p:sp>
       <p:sp>
         <p:nvSpPr>
-          <p:cNvPr id="100" name="Code: embedding_bag marker"/>
+          <p:cNvPr id="104" name="Code: embedding_bag marker"/>
           <p:cNvSpPr/>
           <p:nvPr/>
         </p:nvSpPr>
@@ -8549,7 +8759,7 @@
       </p:sp>
       <p:sp>
         <p:nvSpPr>
-          <p:cNvPr id="101" name="Code: embedding_bag"/>
+          <p:cNvPr id="105" name="Code: embedding_bag"/>
           <p:cNvSpPr txBox="1"/>
           <p:nvPr/>
         </p:nvSpPr>
@@ -10390,7 +10600,7 @@
       </p:sp>
       <p:sp>
         <p:nvSpPr>
-          <p:cNvPr id="102" name="Embedding SWITCH"/>
+          <p:cNvPr id="106" name="Embedding SWITCH"/>
           <p:cNvSpPr/>
           <p:nvPr/>
         </p:nvSpPr>
@@ -10417,7 +10627,7 @@
       </p:sp>
       <p:sp>
         <p:nvSpPr>
-          <p:cNvPr id="103" name="Embedding SWITCH title"/>
+          <p:cNvPr id="107" name="Embedding SWITCH title"/>
           <p:cNvSpPr txBox="1"/>
           <p:nvPr/>
         </p:nvSpPr>
@@ -10456,7 +10666,7 @@
       </p:sp>
       <p:sp>
         <p:nvSpPr>
-          <p:cNvPr id="104" name="Embedding SWITCH handle"/>
+          <p:cNvPr id="108" name="Embedding SWITCH handle"/>
           <p:cNvSpPr txBox="1"/>
           <p:nvPr/>
         </p:nvSpPr>
@@ -10495,7 +10705,7 @@
       </p:sp>
       <p:sp>
         <p:nvSpPr>
-          <p:cNvPr id="105" name="Embedding bucket 32"/>
+          <p:cNvPr id="109" name="Embedding bucket 32"/>
           <p:cNvSpPr/>
           <p:nvPr/>
         </p:nvSpPr>
@@ -10544,7 +10754,7 @@
       </p:sp>
       <p:sp>
         <p:nvSpPr>
-          <p:cNvPr id="106" name="Embedding bucket 128"/>
+          <p:cNvPr id="110" name="Embedding bucket 128"/>
           <p:cNvSpPr/>
           <p:nvPr/>
         </p:nvSpPr>
@@ -10593,7 +10803,7 @@
       </p:sp>
       <p:sp>
         <p:nvSpPr>
-          <p:cNvPr id="107" name="Embedding bucket 512"/>
+          <p:cNvPr id="111" name="Embedding bucket 512"/>
           <p:cNvSpPr/>
           <p:nvPr/>
         </p:nvSpPr>
@@ -10642,7 +10852,7 @@
       </p:sp>
       <p:sp>
         <p:nvSpPr>
-          <p:cNvPr id="108" name="Embedding bucket 4096"/>
+          <p:cNvPr id="112" name="Embedding bucket 4096"/>
           <p:cNvSpPr/>
           <p:nvPr/>
         </p:nvSpPr>
@@ -10691,7 +10901,7 @@
       </p:sp>
       <p:sp>
         <p:nvSpPr>
-          <p:cNvPr id="109" name="Embedding bucket result"/>
+          <p:cNvPr id="113" name="Embedding bucket result"/>
           <p:cNvSpPr txBox="1"/>
           <p:nvPr/>
         </p:nvSpPr>
@@ -10730,7 +10940,7 @@
       </p:sp>
       <p:sp>
         <p:nvSpPr>
-          <p:cNvPr id="110" name="Embedding input contract"/>
+          <p:cNvPr id="114" name="Embedding input contract"/>
           <p:cNvSpPr txBox="1"/>
           <p:nvPr/>
         </p:nvSpPr>
@@ -10769,7 +10979,7 @@
       </p:sp>
       <p:sp>
         <p:nvSpPr>
-          <p:cNvPr id="111" name="Heading Lossless MoE routing with software backpressure"/>
+          <p:cNvPr id="115" name="Heading Lossless MoE routing with software backpressure"/>
           <p:cNvSpPr txBox="1"/>
           <p:nvPr/>
         </p:nvSpPr>
@@ -10818,7 +11028,7 @@
       </p:sp>
       <p:sp>
         <p:nvSpPr>
-          <p:cNvPr id="112" name="Subline Lossless MoE routing with software backpressure"/>
+          <p:cNvPr id="116" name="Subline Lossless MoE routing with software backpressure"/>
           <p:cNvSpPr txBox="1"/>
           <p:nvPr/>
         </p:nvSpPr>
@@ -10857,7 +11067,7 @@
       </p:sp>
       <p:sp>
         <p:nvSpPr>
-          <p:cNvPr id="113" name="MoE capacity"/>
+          <p:cNvPr id="117" name="MoE capacity"/>
           <p:cNvSpPr txBox="1"/>
           <p:nvPr/>
         </p:nvSpPr>
@@ -10896,7 +11106,7 @@
       </p:sp>
       <p:sp>
         <p:nvSpPr>
-          <p:cNvPr id="114" name="MoE rounds heading"/>
+          <p:cNvPr id="118" name="MoE rounds heading"/>
           <p:cNvSpPr txBox="1"/>
           <p:nvPr/>
         </p:nvSpPr>
@@ -10935,13 +11145,2145 @@
       </p:sp>
       <p:sp>
         <p:nvSpPr>
-          <p:cNvPr id="115" name="Code: MoE rounds"/>
+          <p:cNvPr id="119" name="Code: MoE rounds"/>
           <p:cNvSpPr txBox="1"/>
           <p:nvPr/>
         </p:nvSpPr>
         <p:spPr>
           <a:xfrm>
             <a:off x="22098000" y="14300200"/>
+            <a:ext cx="10210800" cy="2628900"/>
+          </a:xfrm>
+          <a:prstGeom prst="rect">
+            <a:avLst/>
+          </a:prstGeom>
+          <a:noFill/>
+        </p:spPr>
+        <p:txBody>
+          <a:bodyPr wrap="none" lIns="0" tIns="0" rIns="0" bIns="0" anchor="t">
+            <a:noAutofit/>
+          </a:bodyPr>
+          <a:lstStyle/>
+          <a:p>
+            <a:pPr marL="0" indent="0" algn="l">
+              <a:lnSpc>
+                <a:spcPts val="2300"/>
+              </a:lnSpc>
+              <a:buNone/>
+            </a:pPr>
+            <a:r>
+              <a:rPr lang="en-US" sz="1900" b="0" dirty="0">
+                <a:solidFill>
+                  <a:srgbClr val="222222"/>
+                </a:solidFill>
+                <a:latin typeface="Liberation Mono"/>
+                <a:cs typeface="Liberation Mono"/>
+              </a:rPr>
+              <a:t>destinations</a:t>
+            </a:r>
+            <a:r>
+              <a:rPr lang="en-US" sz="1900" b="0" dirty="0">
+                <a:solidFill>
+                  <a:srgbClr val="222222"/>
+                </a:solidFill>
+                <a:latin typeface="Liberation Mono"/>
+                <a:cs typeface="Liberation Mono"/>
+              </a:rPr>
+              <a:t> </a:t>
+            </a:r>
+            <a:r>
+              <a:rPr lang="en-US" sz="1900" b="0" dirty="0">
+                <a:solidFill>
+                  <a:srgbClr val="222222"/>
+                </a:solidFill>
+                <a:latin typeface="Liberation Mono"/>
+                <a:cs typeface="Liberation Mono"/>
+              </a:rPr>
+              <a:t>=</a:t>
+            </a:r>
+            <a:r>
+              <a:rPr lang="en-US" sz="1900" b="0" dirty="0">
+                <a:solidFill>
+                  <a:srgbClr val="222222"/>
+                </a:solidFill>
+                <a:latin typeface="Liberation Mono"/>
+                <a:cs typeface="Liberation Mono"/>
+              </a:rPr>
+              <a:t> </a:t>
+            </a:r>
+            <a:r>
+              <a:rPr lang="en-US" sz="1900" b="0" dirty="0">
+                <a:solidFill>
+                  <a:srgbClr val="222222"/>
+                </a:solidFill>
+                <a:latin typeface="Liberation Mono"/>
+                <a:cs typeface="Liberation Mono"/>
+              </a:rPr>
+              <a:t>routes</a:t>
+            </a:r>
+            <a:r>
+              <a:rPr lang="en-US" sz="1900" b="0" dirty="0">
+                <a:solidFill>
+                  <a:srgbClr val="222222"/>
+                </a:solidFill>
+                <a:latin typeface="Liberation Mono"/>
+                <a:cs typeface="Liberation Mono"/>
+              </a:rPr>
+              <a:t> </a:t>
+            </a:r>
+            <a:r>
+              <a:rPr lang="en-US" sz="1900" b="0" dirty="0">
+                <a:solidFill>
+                  <a:srgbClr val="222222"/>
+                </a:solidFill>
+                <a:latin typeface="Liberation Mono"/>
+                <a:cs typeface="Liberation Mono"/>
+              </a:rPr>
+              <a:t>/</a:t>
+            </a:r>
+            <a:r>
+              <a:rPr lang="en-US" sz="1900" b="0" dirty="0">
+                <a:solidFill>
+                  <a:srgbClr val="222222"/>
+                </a:solidFill>
+                <a:latin typeface="Liberation Mono"/>
+                <a:cs typeface="Liberation Mono"/>
+              </a:rPr>
+              <a:t>/</a:t>
+            </a:r>
+            <a:r>
+              <a:rPr lang="en-US" sz="1900" b="0" dirty="0">
+                <a:solidFill>
+                  <a:srgbClr val="222222"/>
+                </a:solidFill>
+                <a:latin typeface="Liberation Mono"/>
+                <a:cs typeface="Liberation Mono"/>
+              </a:rPr>
+              <a:t> </a:t>
+            </a:r>
+            <a:r>
+              <a:rPr lang="en-US" sz="1900" b="0" dirty="0">
+                <a:solidFill>
+                  <a:srgbClr val="222222"/>
+                </a:solidFill>
+                <a:latin typeface="Liberation Mono"/>
+                <a:cs typeface="Liberation Mono"/>
+              </a:rPr>
+              <a:t>LOCAL_EXPERTS</a:t>
+            </a:r>
+            <a:endParaRPr lang="en-US" sz="1900" dirty="0"/>
+          </a:p>
+          <a:p>
+            <a:pPr marL="0" indent="0" algn="l">
+              <a:lnSpc>
+                <a:spcPts val="2300"/>
+              </a:lnSpc>
+              <a:buNone/>
+            </a:pPr>
+            <a:r>
+              <a:rPr lang="en-US" sz="1900" b="0" dirty="0">
+                <a:solidFill>
+                  <a:srgbClr val="222222"/>
+                </a:solidFill>
+                <a:latin typeface="Liberation Mono"/>
+                <a:cs typeface="Liberation Mono"/>
+              </a:rPr>
+              <a:t>tokens_per_destination</a:t>
+            </a:r>
+            <a:r>
+              <a:rPr lang="en-US" sz="1900" b="0" dirty="0">
+                <a:solidFill>
+                  <a:srgbClr val="222222"/>
+                </a:solidFill>
+                <a:latin typeface="Liberation Mono"/>
+                <a:cs typeface="Liberation Mono"/>
+              </a:rPr>
+              <a:t> </a:t>
+            </a:r>
+            <a:r>
+              <a:rPr lang="en-US" sz="1900" b="0" dirty="0">
+                <a:solidFill>
+                  <a:srgbClr val="222222"/>
+                </a:solidFill>
+                <a:latin typeface="Liberation Mono"/>
+                <a:cs typeface="Liberation Mono"/>
+              </a:rPr>
+              <a:t>=</a:t>
+            </a:r>
+            <a:r>
+              <a:rPr lang="en-US" sz="1900" b="0" dirty="0">
+                <a:solidFill>
+                  <a:srgbClr val="222222"/>
+                </a:solidFill>
+                <a:latin typeface="Liberation Mono"/>
+                <a:cs typeface="Liberation Mono"/>
+              </a:rPr>
+              <a:t> </a:t>
+            </a:r>
+            <a:r>
+              <a:rPr lang="en-US" sz="1900" b="0" dirty="0">
+                <a:solidFill>
+                  <a:srgbClr val="222222"/>
+                </a:solidFill>
+                <a:latin typeface="Liberation Mono"/>
+                <a:cs typeface="Liberation Mono"/>
+              </a:rPr>
+              <a:t>(</a:t>
+            </a:r>
+            <a:endParaRPr lang="en-US" sz="1900" dirty="0"/>
+          </a:p>
+          <a:p>
+            <a:pPr marL="0" indent="0" algn="l">
+              <a:lnSpc>
+                <a:spcPts val="2300"/>
+              </a:lnSpc>
+              <a:buNone/>
+            </a:pPr>
+            <a:r>
+              <a:rPr lang="en-US" sz="1900" b="0" dirty="0">
+                <a:solidFill>
+                  <a:srgbClr val="222222"/>
+                </a:solidFill>
+                <a:latin typeface="Liberation Mono"/>
+                <a:cs typeface="Liberation Mono"/>
+              </a:rPr>
+              <a:t>    </a:t>
+            </a:r>
+            <a:r>
+              <a:rPr lang="en-US" sz="1900" b="0" dirty="0">
+                <a:solidFill>
+                  <a:srgbClr val="222222"/>
+                </a:solidFill>
+                <a:latin typeface="Liberation Mono"/>
+                <a:cs typeface="Liberation Mono"/>
+              </a:rPr>
+              <a:t>destinations</a:t>
+            </a:r>
+            <a:r>
+              <a:rPr lang="en-US" sz="1900" b="0" dirty="0">
+                <a:solidFill>
+                  <a:srgbClr val="222222"/>
+                </a:solidFill>
+                <a:latin typeface="Liberation Mono"/>
+                <a:cs typeface="Liberation Mono"/>
+              </a:rPr>
+              <a:t>[</a:t>
+            </a:r>
+            <a:r>
+              <a:rPr lang="en-US" sz="1900" b="1" dirty="0">
+                <a:solidFill>
+                  <a:srgbClr val="295897"/>
+                </a:solidFill>
+                <a:latin typeface="Liberation Mono"/>
+                <a:cs typeface="Liberation Mono"/>
+              </a:rPr>
+              <a:t>None</a:t>
+            </a:r>
+            <a:r>
+              <a:rPr lang="en-US" sz="1900" b="0" dirty="0">
+                <a:solidFill>
+                  <a:srgbClr val="222222"/>
+                </a:solidFill>
+                <a:latin typeface="Liberation Mono"/>
+                <a:cs typeface="Liberation Mono"/>
+              </a:rPr>
+              <a:t>,</a:t>
+            </a:r>
+            <a:r>
+              <a:rPr lang="en-US" sz="1900" b="0" dirty="0">
+                <a:solidFill>
+                  <a:srgbClr val="222222"/>
+                </a:solidFill>
+                <a:latin typeface="Liberation Mono"/>
+                <a:cs typeface="Liberation Mono"/>
+              </a:rPr>
+              <a:t> </a:t>
+            </a:r>
+            <a:r>
+              <a:rPr lang="en-US" sz="1900" b="0" dirty="0">
+                <a:solidFill>
+                  <a:srgbClr val="222222"/>
+                </a:solidFill>
+                <a:latin typeface="Liberation Mono"/>
+                <a:cs typeface="Liberation Mono"/>
+              </a:rPr>
+              <a:t>:</a:t>
+            </a:r>
+            <a:r>
+              <a:rPr lang="en-US" sz="1900" b="0" dirty="0">
+                <a:solidFill>
+                  <a:srgbClr val="222222"/>
+                </a:solidFill>
+                <a:latin typeface="Liberation Mono"/>
+                <a:cs typeface="Liberation Mono"/>
+              </a:rPr>
+              <a:t>]</a:t>
+            </a:r>
+            <a:r>
+              <a:rPr lang="en-US" sz="1900" b="0" dirty="0">
+                <a:solidFill>
+                  <a:srgbClr val="222222"/>
+                </a:solidFill>
+                <a:latin typeface="Liberation Mono"/>
+                <a:cs typeface="Liberation Mono"/>
+              </a:rPr>
+              <a:t> </a:t>
+            </a:r>
+            <a:r>
+              <a:rPr lang="en-US" sz="1900" b="0" dirty="0">
+                <a:solidFill>
+                  <a:srgbClr val="222222"/>
+                </a:solidFill>
+                <a:latin typeface="Liberation Mono"/>
+                <a:cs typeface="Liberation Mono"/>
+              </a:rPr>
+              <a:t>==</a:t>
+            </a:r>
+            <a:r>
+              <a:rPr lang="en-US" sz="1900" b="0" dirty="0">
+                <a:solidFill>
+                  <a:srgbClr val="222222"/>
+                </a:solidFill>
+                <a:latin typeface="Liberation Mono"/>
+                <a:cs typeface="Liberation Mono"/>
+              </a:rPr>
+              <a:t> </a:t>
+            </a:r>
+            <a:r>
+              <a:rPr lang="en-US" sz="1900" b="0" dirty="0">
+                <a:solidFill>
+                  <a:srgbClr val="222222"/>
+                </a:solidFill>
+                <a:latin typeface="Liberation Mono"/>
+                <a:cs typeface="Liberation Mono"/>
+              </a:rPr>
+              <a:t>peers</a:t>
+            </a:r>
+            <a:r>
+              <a:rPr lang="en-US" sz="1900" b="0" dirty="0">
+                <a:solidFill>
+                  <a:srgbClr val="222222"/>
+                </a:solidFill>
+                <a:latin typeface="Liberation Mono"/>
+                <a:cs typeface="Liberation Mono"/>
+              </a:rPr>
+              <a:t>)</a:t>
+            </a:r>
+            <a:r>
+              <a:rPr lang="en-US" sz="1900" b="0" dirty="0">
+                <a:solidFill>
+                  <a:srgbClr val="222222"/>
+                </a:solidFill>
+                <a:latin typeface="Liberation Mono"/>
+                <a:cs typeface="Liberation Mono"/>
+              </a:rPr>
+              <a:t>.</a:t>
+            </a:r>
+            <a:r>
+              <a:rPr lang="en-US" sz="1900" b="0" dirty="0">
+                <a:solidFill>
+                  <a:srgbClr val="222222"/>
+                </a:solidFill>
+                <a:latin typeface="Liberation Mono"/>
+                <a:cs typeface="Liberation Mono"/>
+              </a:rPr>
+              <a:t>sum</a:t>
+            </a:r>
+            <a:r>
+              <a:rPr lang="en-US" sz="1900" b="0" dirty="0">
+                <a:solidFill>
+                  <a:srgbClr val="222222"/>
+                </a:solidFill>
+                <a:latin typeface="Liberation Mono"/>
+                <a:cs typeface="Liberation Mono"/>
+              </a:rPr>
+              <a:t>(</a:t>
+            </a:r>
+            <a:r>
+              <a:rPr lang="en-US" sz="1900" b="0" dirty="0">
+                <a:solidFill>
+                  <a:srgbClr val="1A6E6F"/>
+                </a:solidFill>
+                <a:latin typeface="Liberation Mono"/>
+                <a:cs typeface="Liberation Mono"/>
+              </a:rPr>
+              <a:t>1</a:t>
+            </a:r>
+            <a:r>
+              <a:rPr lang="en-US" sz="1900" b="0" dirty="0">
+                <a:solidFill>
+                  <a:srgbClr val="222222"/>
+                </a:solidFill>
+                <a:latin typeface="Liberation Mono"/>
+                <a:cs typeface="Liberation Mono"/>
+              </a:rPr>
+              <a:t>)</a:t>
+            </a:r>
+            <a:endParaRPr lang="en-US" sz="1900" dirty="0"/>
+          </a:p>
+          <a:p>
+            <a:pPr marL="0" indent="0" algn="l">
+              <a:lnSpc>
+                <a:spcPts val="2300"/>
+              </a:lnSpc>
+              <a:buNone/>
+            </a:pPr>
+            <a:r>
+              <a:rPr lang="en-US" sz="1900" b="0" dirty="0">
+                <a:solidFill>
+                  <a:srgbClr val="222222"/>
+                </a:solidFill>
+                <a:latin typeface="Liberation Mono"/>
+                <a:cs typeface="Liberation Mono"/>
+              </a:rPr>
+              <a:t>local_rounds</a:t>
+            </a:r>
+            <a:r>
+              <a:rPr lang="en-US" sz="1900" b="0" dirty="0">
+                <a:solidFill>
+                  <a:srgbClr val="222222"/>
+                </a:solidFill>
+                <a:latin typeface="Liberation Mono"/>
+                <a:cs typeface="Liberation Mono"/>
+              </a:rPr>
+              <a:t> </a:t>
+            </a:r>
+            <a:r>
+              <a:rPr lang="en-US" sz="1900" b="0" dirty="0">
+                <a:solidFill>
+                  <a:srgbClr val="222222"/>
+                </a:solidFill>
+                <a:latin typeface="Liberation Mono"/>
+                <a:cs typeface="Liberation Mono"/>
+              </a:rPr>
+              <a:t>=</a:t>
+            </a:r>
+            <a:r>
+              <a:rPr lang="en-US" sz="1900" b="0" dirty="0">
+                <a:solidFill>
+                  <a:srgbClr val="222222"/>
+                </a:solidFill>
+                <a:latin typeface="Liberation Mono"/>
+                <a:cs typeface="Liberation Mono"/>
+              </a:rPr>
+              <a:t> </a:t>
+            </a:r>
+            <a:r>
+              <a:rPr lang="en-US" sz="1900" b="0" dirty="0">
+                <a:solidFill>
+                  <a:srgbClr val="222222"/>
+                </a:solidFill>
+                <a:latin typeface="Liberation Mono"/>
+                <a:cs typeface="Liberation Mono"/>
+              </a:rPr>
+              <a:t>(</a:t>
+            </a:r>
+            <a:endParaRPr lang="en-US" sz="1900" dirty="0"/>
+          </a:p>
+          <a:p>
+            <a:pPr marL="0" indent="0" algn="l">
+              <a:lnSpc>
+                <a:spcPts val="2300"/>
+              </a:lnSpc>
+              <a:buNone/>
+            </a:pPr>
+            <a:r>
+              <a:rPr lang="en-US" sz="1900" b="0" dirty="0">
+                <a:solidFill>
+                  <a:srgbClr val="222222"/>
+                </a:solidFill>
+                <a:latin typeface="Liberation Mono"/>
+                <a:cs typeface="Liberation Mono"/>
+              </a:rPr>
+              <a:t>    </a:t>
+            </a:r>
+            <a:r>
+              <a:rPr lang="en-US" sz="1900" b="0" dirty="0">
+                <a:solidFill>
+                  <a:srgbClr val="222222"/>
+                </a:solidFill>
+                <a:latin typeface="Liberation Mono"/>
+                <a:cs typeface="Liberation Mono"/>
+              </a:rPr>
+              <a:t>(</a:t>
+            </a:r>
+            <a:r>
+              <a:rPr lang="en-US" sz="1900" b="0" dirty="0">
+                <a:solidFill>
+                  <a:srgbClr val="222222"/>
+                </a:solidFill>
+                <a:latin typeface="Liberation Mono"/>
+                <a:cs typeface="Liberation Mono"/>
+              </a:rPr>
+              <a:t>tokens_per_destination</a:t>
+            </a:r>
+            <a:r>
+              <a:rPr lang="en-US" sz="1900" b="0" dirty="0">
+                <a:solidFill>
+                  <a:srgbClr val="222222"/>
+                </a:solidFill>
+                <a:latin typeface="Liberation Mono"/>
+                <a:cs typeface="Liberation Mono"/>
+              </a:rPr>
+              <a:t> </a:t>
+            </a:r>
+            <a:r>
+              <a:rPr lang="en-US" sz="1900" b="0" dirty="0">
+                <a:solidFill>
+                  <a:srgbClr val="222222"/>
+                </a:solidFill>
+                <a:latin typeface="Liberation Mono"/>
+                <a:cs typeface="Liberation Mono"/>
+              </a:rPr>
+              <a:t>+</a:t>
+            </a:r>
+            <a:r>
+              <a:rPr lang="en-US" sz="1900" b="0" dirty="0">
+                <a:solidFill>
+                  <a:srgbClr val="222222"/>
+                </a:solidFill>
+                <a:latin typeface="Liberation Mono"/>
+                <a:cs typeface="Liberation Mono"/>
+              </a:rPr>
+              <a:t> </a:t>
+            </a:r>
+            <a:r>
+              <a:rPr lang="en-US" sz="1900" b="0" dirty="0">
+                <a:solidFill>
+                  <a:srgbClr val="222222"/>
+                </a:solidFill>
+                <a:latin typeface="Liberation Mono"/>
+                <a:cs typeface="Liberation Mono"/>
+              </a:rPr>
+              <a:t>PEER_CAPACITY</a:t>
+            </a:r>
+            <a:r>
+              <a:rPr lang="en-US" sz="1900" b="0" dirty="0">
+                <a:solidFill>
+                  <a:srgbClr val="222222"/>
+                </a:solidFill>
+                <a:latin typeface="Liberation Mono"/>
+                <a:cs typeface="Liberation Mono"/>
+              </a:rPr>
+              <a:t> </a:t>
+            </a:r>
+            <a:r>
+              <a:rPr lang="en-US" sz="1900" b="0" dirty="0">
+                <a:solidFill>
+                  <a:srgbClr val="222222"/>
+                </a:solidFill>
+                <a:latin typeface="Liberation Mono"/>
+                <a:cs typeface="Liberation Mono"/>
+              </a:rPr>
+              <a:t>-</a:t>
+            </a:r>
+            <a:r>
+              <a:rPr lang="en-US" sz="1900" b="0" dirty="0">
+                <a:solidFill>
+                  <a:srgbClr val="222222"/>
+                </a:solidFill>
+                <a:latin typeface="Liberation Mono"/>
+                <a:cs typeface="Liberation Mono"/>
+              </a:rPr>
+              <a:t> </a:t>
+            </a:r>
+            <a:r>
+              <a:rPr lang="en-US" sz="1900" b="0" dirty="0">
+                <a:solidFill>
+                  <a:srgbClr val="1A6E6F"/>
+                </a:solidFill>
+                <a:latin typeface="Liberation Mono"/>
+                <a:cs typeface="Liberation Mono"/>
+              </a:rPr>
+              <a:t>1</a:t>
+            </a:r>
+            <a:r>
+              <a:rPr lang="en-US" sz="1900" b="0" dirty="0">
+                <a:solidFill>
+                  <a:srgbClr val="222222"/>
+                </a:solidFill>
+                <a:latin typeface="Liberation Mono"/>
+                <a:cs typeface="Liberation Mono"/>
+              </a:rPr>
+              <a:t>)</a:t>
+            </a:r>
+            <a:endParaRPr lang="en-US" sz="1900" dirty="0"/>
+          </a:p>
+          <a:p>
+            <a:pPr marL="0" indent="0" algn="l">
+              <a:lnSpc>
+                <a:spcPts val="2300"/>
+              </a:lnSpc>
+              <a:buNone/>
+            </a:pPr>
+            <a:r>
+              <a:rPr lang="en-US" sz="1900" b="0" dirty="0">
+                <a:solidFill>
+                  <a:srgbClr val="222222"/>
+                </a:solidFill>
+                <a:latin typeface="Liberation Mono"/>
+                <a:cs typeface="Liberation Mono"/>
+              </a:rPr>
+              <a:t>    </a:t>
+            </a:r>
+            <a:r>
+              <a:rPr lang="en-US" sz="1900" b="0" dirty="0">
+                <a:solidFill>
+                  <a:srgbClr val="222222"/>
+                </a:solidFill>
+                <a:latin typeface="Liberation Mono"/>
+                <a:cs typeface="Liberation Mono"/>
+              </a:rPr>
+              <a:t>/</a:t>
+            </a:r>
+            <a:r>
+              <a:rPr lang="en-US" sz="1900" b="0" dirty="0">
+                <a:solidFill>
+                  <a:srgbClr val="222222"/>
+                </a:solidFill>
+                <a:latin typeface="Liberation Mono"/>
+                <a:cs typeface="Liberation Mono"/>
+              </a:rPr>
+              <a:t>/</a:t>
+            </a:r>
+            <a:r>
+              <a:rPr lang="en-US" sz="1900" b="0" dirty="0">
+                <a:solidFill>
+                  <a:srgbClr val="222222"/>
+                </a:solidFill>
+                <a:latin typeface="Liberation Mono"/>
+                <a:cs typeface="Liberation Mono"/>
+              </a:rPr>
+              <a:t> </a:t>
+            </a:r>
+            <a:r>
+              <a:rPr lang="en-US" sz="1900" b="0" dirty="0">
+                <a:solidFill>
+                  <a:srgbClr val="222222"/>
+                </a:solidFill>
+                <a:latin typeface="Liberation Mono"/>
+                <a:cs typeface="Liberation Mono"/>
+              </a:rPr>
+              <a:t>PEER_CAPACITY</a:t>
+            </a:r>
+            <a:r>
+              <a:rPr lang="en-US" sz="1900" b="0" dirty="0">
+                <a:solidFill>
+                  <a:srgbClr val="222222"/>
+                </a:solidFill>
+                <a:latin typeface="Liberation Mono"/>
+                <a:cs typeface="Liberation Mono"/>
+              </a:rPr>
+              <a:t>)</a:t>
+            </a:r>
+            <a:r>
+              <a:rPr lang="en-US" sz="1900" b="0" dirty="0">
+                <a:solidFill>
+                  <a:srgbClr val="222222"/>
+                </a:solidFill>
+                <a:latin typeface="Liberation Mono"/>
+                <a:cs typeface="Liberation Mono"/>
+              </a:rPr>
+              <a:t>.</a:t>
+            </a:r>
+            <a:r>
+              <a:rPr lang="en-US" sz="1900" b="0" dirty="0">
+                <a:solidFill>
+                  <a:srgbClr val="222222"/>
+                </a:solidFill>
+                <a:latin typeface="Liberation Mono"/>
+                <a:cs typeface="Liberation Mono"/>
+              </a:rPr>
+              <a:t>max</a:t>
+            </a:r>
+            <a:r>
+              <a:rPr lang="en-US" sz="1900" b="0" dirty="0">
+                <a:solidFill>
+                  <a:srgbClr val="222222"/>
+                </a:solidFill>
+                <a:latin typeface="Liberation Mono"/>
+                <a:cs typeface="Liberation Mono"/>
+              </a:rPr>
+              <a:t>(</a:t>
+            </a:r>
+            <a:r>
+              <a:rPr lang="en-US" sz="1900" b="0" dirty="0">
+                <a:solidFill>
+                  <a:srgbClr val="222222"/>
+                </a:solidFill>
+                <a:latin typeface="Liberation Mono"/>
+                <a:cs typeface="Liberation Mono"/>
+              </a:rPr>
+              <a:t>)</a:t>
+            </a:r>
+            <a:endParaRPr lang="en-US" sz="1900" dirty="0"/>
+          </a:p>
+          <a:p>
+            <a:pPr marL="0" indent="0" algn="l">
+              <a:lnSpc>
+                <a:spcPts val="2300"/>
+              </a:lnSpc>
+              <a:buNone/>
+            </a:pPr>
+            <a:r>
+              <a:rPr lang="en-US" sz="1900" b="0" dirty="0">
+                <a:solidFill>
+                  <a:srgbClr val="222222"/>
+                </a:solidFill>
+                <a:latin typeface="Liberation Mono"/>
+                <a:cs typeface="Liberation Mono"/>
+              </a:rPr>
+              <a:t>total_rounds</a:t>
+            </a:r>
+            <a:r>
+              <a:rPr lang="en-US" sz="1900" b="0" dirty="0">
+                <a:solidFill>
+                  <a:srgbClr val="222222"/>
+                </a:solidFill>
+                <a:latin typeface="Liberation Mono"/>
+                <a:cs typeface="Liberation Mono"/>
+              </a:rPr>
+              <a:t> </a:t>
+            </a:r>
+            <a:r>
+              <a:rPr lang="en-US" sz="1900" b="0" dirty="0">
+                <a:solidFill>
+                  <a:srgbClr val="222222"/>
+                </a:solidFill>
+                <a:latin typeface="Liberation Mono"/>
+                <a:cs typeface="Liberation Mono"/>
+              </a:rPr>
+              <a:t>=</a:t>
+            </a:r>
+            <a:r>
+              <a:rPr lang="en-US" sz="1900" b="0" dirty="0">
+                <a:solidFill>
+                  <a:srgbClr val="222222"/>
+                </a:solidFill>
+                <a:latin typeface="Liberation Mono"/>
+                <a:cs typeface="Liberation Mono"/>
+              </a:rPr>
+              <a:t> </a:t>
+            </a:r>
+            <a:r>
+              <a:rPr lang="en-US" sz="1900" b="0" dirty="0">
+                <a:solidFill>
+                  <a:srgbClr val="222222"/>
+                </a:solidFill>
+                <a:latin typeface="Liberation Mono"/>
+                <a:cs typeface="Liberation Mono"/>
+              </a:rPr>
+              <a:t>sync_all_reduce_max</a:t>
+            </a:r>
+            <a:r>
+              <a:rPr lang="en-US" sz="1900" b="0" dirty="0">
+                <a:solidFill>
+                  <a:srgbClr val="222222"/>
+                </a:solidFill>
+                <a:latin typeface="Liberation Mono"/>
+                <a:cs typeface="Liberation Mono"/>
+              </a:rPr>
+              <a:t>(</a:t>
+            </a:r>
+            <a:r>
+              <a:rPr lang="en-US" sz="1900" b="0" dirty="0">
+                <a:solidFill>
+                  <a:srgbClr val="222222"/>
+                </a:solidFill>
+                <a:latin typeface="Liberation Mono"/>
+                <a:cs typeface="Liberation Mono"/>
+              </a:rPr>
+              <a:t>local_rounds</a:t>
+            </a:r>
+            <a:r>
+              <a:rPr lang="en-US" sz="1900" b="0" dirty="0">
+                <a:solidFill>
+                  <a:srgbClr val="222222"/>
+                </a:solidFill>
+                <a:latin typeface="Liberation Mono"/>
+                <a:cs typeface="Liberation Mono"/>
+              </a:rPr>
+              <a:t>)</a:t>
+            </a:r>
+            <a:endParaRPr lang="en-US" sz="1900" dirty="0"/>
+          </a:p>
+          <a:p>
+            <a:pPr marL="0" indent="0" algn="l">
+              <a:lnSpc>
+                <a:spcPts val="2300"/>
+              </a:lnSpc>
+              <a:buNone/>
+            </a:pPr>
+            <a:r>
+              <a:rPr lang="en-US" sz="1900" b="1" dirty="0">
+                <a:solidFill>
+                  <a:srgbClr val="295897"/>
+                </a:solidFill>
+                <a:latin typeface="Liberation Mono"/>
+                <a:cs typeface="Liberation Mono"/>
+              </a:rPr>
+              <a:t>def</a:t>
+            </a:r>
+            <a:r>
+              <a:rPr lang="en-US" sz="1900" b="0" dirty="0">
+                <a:solidFill>
+                  <a:srgbClr val="222222"/>
+                </a:solidFill>
+                <a:latin typeface="Liberation Mono"/>
+                <a:cs typeface="Liberation Mono"/>
+              </a:rPr>
+              <a:t> </a:t>
+            </a:r>
+            <a:r>
+              <a:rPr lang="en-US" sz="1900" b="0" dirty="0">
+                <a:solidFill>
+                  <a:srgbClr val="222222"/>
+                </a:solidFill>
+                <a:latin typeface="Liberation Mono"/>
+                <a:cs typeface="Liberation Mono"/>
+              </a:rPr>
+              <a:t>cond</a:t>
+            </a:r>
+            <a:r>
+              <a:rPr lang="en-US" sz="1900" b="0" dirty="0">
+                <a:solidFill>
+                  <a:srgbClr val="222222"/>
+                </a:solidFill>
+                <a:latin typeface="Liberation Mono"/>
+                <a:cs typeface="Liberation Mono"/>
+              </a:rPr>
+              <a:t>(</a:t>
+            </a:r>
+            <a:r>
+              <a:rPr lang="en-US" sz="1900" b="0" dirty="0">
+                <a:solidFill>
+                  <a:srgbClr val="222222"/>
+                </a:solidFill>
+                <a:latin typeface="Liberation Mono"/>
+                <a:cs typeface="Liberation Mono"/>
+              </a:rPr>
+              <a:t>iteration</a:t>
+            </a:r>
+            <a:r>
+              <a:rPr lang="en-US" sz="1900" b="0" dirty="0">
+                <a:solidFill>
+                  <a:srgbClr val="222222"/>
+                </a:solidFill>
+                <a:latin typeface="Liberation Mono"/>
+                <a:cs typeface="Liberation Mono"/>
+              </a:rPr>
+              <a:t>,</a:t>
+            </a:r>
+            <a:r>
+              <a:rPr lang="en-US" sz="1900" b="0" dirty="0">
+                <a:solidFill>
+                  <a:srgbClr val="222222"/>
+                </a:solidFill>
+                <a:latin typeface="Liberation Mono"/>
+                <a:cs typeface="Liberation Mono"/>
+              </a:rPr>
+              <a:t> </a:t>
+            </a:r>
+            <a:r>
+              <a:rPr lang="en-US" sz="1900" b="0" dirty="0">
+                <a:solidFill>
+                  <a:srgbClr val="222222"/>
+                </a:solidFill>
+                <a:latin typeface="Liberation Mono"/>
+                <a:cs typeface="Liberation Mono"/>
+              </a:rPr>
+              <a:t>done</a:t>
+            </a:r>
+            <a:r>
+              <a:rPr lang="en-US" sz="1900" b="0" dirty="0">
+                <a:solidFill>
+                  <a:srgbClr val="222222"/>
+                </a:solidFill>
+                <a:latin typeface="Liberation Mono"/>
+                <a:cs typeface="Liberation Mono"/>
+              </a:rPr>
+              <a:t>,</a:t>
+            </a:r>
+            <a:r>
+              <a:rPr lang="en-US" sz="1900" b="0" dirty="0">
+                <a:solidFill>
+                  <a:srgbClr val="222222"/>
+                </a:solidFill>
+                <a:latin typeface="Liberation Mono"/>
+                <a:cs typeface="Liberation Mono"/>
+              </a:rPr>
+              <a:t> </a:t>
+            </a:r>
+            <a:r>
+              <a:rPr lang="en-US" sz="1900" b="0" dirty="0">
+                <a:solidFill>
+                  <a:srgbClr val="222222"/>
+                </a:solidFill>
+                <a:latin typeface="Liberation Mono"/>
+                <a:cs typeface="Liberation Mono"/>
+              </a:rPr>
+              <a:t>output</a:t>
+            </a:r>
+            <a:r>
+              <a:rPr lang="en-US" sz="1900" b="0" dirty="0">
+                <a:solidFill>
+                  <a:srgbClr val="222222"/>
+                </a:solidFill>
+                <a:latin typeface="Liberation Mono"/>
+                <a:cs typeface="Liberation Mono"/>
+              </a:rPr>
+              <a:t>)</a:t>
+            </a:r>
+            <a:r>
+              <a:rPr lang="en-US" sz="1900" b="0" dirty="0">
+                <a:solidFill>
+                  <a:srgbClr val="222222"/>
+                </a:solidFill>
+                <a:latin typeface="Liberation Mono"/>
+                <a:cs typeface="Liberation Mono"/>
+              </a:rPr>
+              <a:t>:</a:t>
+            </a:r>
+            <a:endParaRPr lang="en-US" sz="1900" dirty="0"/>
+          </a:p>
+          <a:p>
+            <a:pPr marL="0" indent="0" algn="l">
+              <a:lnSpc>
+                <a:spcPts val="2300"/>
+              </a:lnSpc>
+              <a:buNone/>
+            </a:pPr>
+            <a:r>
+              <a:rPr lang="en-US" sz="1900" b="0" dirty="0">
+                <a:solidFill>
+                  <a:srgbClr val="222222"/>
+                </a:solidFill>
+                <a:latin typeface="Liberation Mono"/>
+                <a:cs typeface="Liberation Mono"/>
+              </a:rPr>
+              <a:t>    </a:t>
+            </a:r>
+            <a:r>
+              <a:rPr lang="en-US" sz="1900" b="1" dirty="0">
+                <a:solidFill>
+                  <a:srgbClr val="295897"/>
+                </a:solidFill>
+                <a:latin typeface="Liberation Mono"/>
+                <a:cs typeface="Liberation Mono"/>
+              </a:rPr>
+              <a:t>return</a:t>
+            </a:r>
+            <a:r>
+              <a:rPr lang="en-US" sz="1900" b="0" dirty="0">
+                <a:solidFill>
+                  <a:srgbClr val="222222"/>
+                </a:solidFill>
+                <a:latin typeface="Liberation Mono"/>
+                <a:cs typeface="Liberation Mono"/>
+              </a:rPr>
+              <a:t> </a:t>
+            </a:r>
+            <a:r>
+              <a:rPr lang="en-US" sz="1900" b="0" dirty="0">
+                <a:solidFill>
+                  <a:srgbClr val="222222"/>
+                </a:solidFill>
+                <a:latin typeface="Liberation Mono"/>
+                <a:cs typeface="Liberation Mono"/>
+              </a:rPr>
+              <a:t>iteration</a:t>
+            </a:r>
+            <a:r>
+              <a:rPr lang="en-US" sz="1900" b="0" dirty="0">
+                <a:solidFill>
+                  <a:srgbClr val="222222"/>
+                </a:solidFill>
+                <a:latin typeface="Liberation Mono"/>
+                <a:cs typeface="Liberation Mono"/>
+              </a:rPr>
+              <a:t> </a:t>
+            </a:r>
+            <a:r>
+              <a:rPr lang="en-US" sz="1900" b="0" dirty="0">
+                <a:solidFill>
+                  <a:srgbClr val="222222"/>
+                </a:solidFill>
+                <a:latin typeface="Liberation Mono"/>
+                <a:cs typeface="Liberation Mono"/>
+              </a:rPr>
+              <a:t>&lt;</a:t>
+            </a:r>
+            <a:r>
+              <a:rPr lang="en-US" sz="1900" b="0" dirty="0">
+                <a:solidFill>
+                  <a:srgbClr val="222222"/>
+                </a:solidFill>
+                <a:latin typeface="Liberation Mono"/>
+                <a:cs typeface="Liberation Mono"/>
+              </a:rPr>
+              <a:t> </a:t>
+            </a:r>
+            <a:r>
+              <a:rPr lang="en-US" sz="1900" b="0" dirty="0">
+                <a:solidFill>
+                  <a:srgbClr val="222222"/>
+                </a:solidFill>
+                <a:latin typeface="Liberation Mono"/>
+                <a:cs typeface="Liberation Mono"/>
+              </a:rPr>
+              <a:t>total_rounds</a:t>
+            </a:r>
+            <a:endParaRPr lang="en-US" sz="1900" dirty="0"/>
+          </a:p>
+        </p:txBody>
+      </p:sp>
+      <p:sp>
+        <p:nvSpPr>
+          <p:cNvPr id="120" name="MoE GEMM heading"/>
+          <p:cNvSpPr txBox="1"/>
+          <p:nvPr/>
+        </p:nvSpPr>
+        <p:spPr>
+          <a:xfrm>
+            <a:off x="22098000" y="17183100"/>
+            <a:ext cx="10210800" cy="333375"/>
+          </a:xfrm>
+          <a:prstGeom prst="rect">
+            <a:avLst/>
+          </a:prstGeom>
+          <a:noFill/>
+        </p:spPr>
+        <p:txBody>
+          <a:bodyPr wrap="none" lIns="0" tIns="0" rIns="0" bIns="0" anchor="t">
+            <a:noAutofit/>
+          </a:bodyPr>
+          <a:lstStyle/>
+          <a:p>
+            <a:pPr marL="0" indent="0" algn="l">
+              <a:buNone/>
+            </a:pPr>
+            <a:r>
+              <a:rPr lang="en-US" sz="2100" b="1" dirty="0">
+                <a:solidFill>
+                  <a:srgbClr val="222222"/>
+                </a:solidFill>
+                <a:latin typeface="Arial"/>
+                <a:cs typeface="Arial"/>
+              </a:rPr>
+              <a:t>2. Group packed tokens by expert; run grouped GEMM</a:t>
+            </a:r>
+            <a:endParaRPr lang="en-US" sz="2100" dirty="0"/>
+          </a:p>
+        </p:txBody>
+      </p:sp>
+      <p:sp>
+        <p:nvSpPr>
+          <p:cNvPr id="121" name="Code: MoE grouped GEMM"/>
+          <p:cNvSpPr txBox="1"/>
+          <p:nvPr/>
+        </p:nvSpPr>
+        <p:spPr>
+          <a:xfrm>
+            <a:off x="22098000" y="17614900"/>
+            <a:ext cx="10210800" cy="2044700"/>
+          </a:xfrm>
+          <a:prstGeom prst="rect">
+            <a:avLst/>
+          </a:prstGeom>
+          <a:noFill/>
+        </p:spPr>
+        <p:txBody>
+          <a:bodyPr wrap="none" lIns="0" tIns="0" rIns="0" bIns="0" anchor="t">
+            <a:noAutofit/>
+          </a:bodyPr>
+          <a:lstStyle/>
+          <a:p>
+            <a:pPr marL="0" indent="0" algn="l">
+              <a:lnSpc>
+                <a:spcPts val="2300"/>
+              </a:lnSpc>
+              <a:buNone/>
+            </a:pPr>
+            <a:r>
+              <a:rPr lang="en-US" sz="1900" b="0" dirty="0">
+                <a:solidFill>
+                  <a:srgbClr val="222222"/>
+                </a:solidFill>
+                <a:latin typeface="Liberation Mono"/>
+                <a:cs typeface="Liberation Mono"/>
+              </a:rPr>
+              <a:t>counts</a:t>
+            </a:r>
+            <a:r>
+              <a:rPr lang="en-US" sz="1900" b="0" dirty="0">
+                <a:solidFill>
+                  <a:srgbClr val="222222"/>
+                </a:solidFill>
+                <a:latin typeface="Liberation Mono"/>
+                <a:cs typeface="Liberation Mono"/>
+              </a:rPr>
+              <a:t> </a:t>
+            </a:r>
+            <a:r>
+              <a:rPr lang="en-US" sz="1900" b="0" dirty="0">
+                <a:solidFill>
+                  <a:srgbClr val="222222"/>
+                </a:solidFill>
+                <a:latin typeface="Liberation Mono"/>
+                <a:cs typeface="Liberation Mono"/>
+              </a:rPr>
+              <a:t>=</a:t>
+            </a:r>
+            <a:r>
+              <a:rPr lang="en-US" sz="1900" b="0" dirty="0">
+                <a:solidFill>
+                  <a:srgbClr val="222222"/>
+                </a:solidFill>
+                <a:latin typeface="Liberation Mono"/>
+                <a:cs typeface="Liberation Mono"/>
+              </a:rPr>
+              <a:t> </a:t>
+            </a:r>
+            <a:r>
+              <a:rPr lang="en-US" sz="1900" b="0" dirty="0">
+                <a:solidFill>
+                  <a:srgbClr val="222222"/>
+                </a:solidFill>
+                <a:latin typeface="Liberation Mono"/>
+                <a:cs typeface="Liberation Mono"/>
+              </a:rPr>
+              <a:t>(</a:t>
+            </a:r>
+            <a:r>
+              <a:rPr lang="en-US" sz="1900" b="0" dirty="0">
+                <a:solidFill>
+                  <a:srgbClr val="222222"/>
+                </a:solidFill>
+                <a:latin typeface="Liberation Mono"/>
+                <a:cs typeface="Liberation Mono"/>
+              </a:rPr>
+              <a:t>(</a:t>
+            </a:r>
+            <a:r>
+              <a:rPr lang="en-US" sz="1900" b="0" dirty="0">
+                <a:solidFill>
+                  <a:srgbClr val="222222"/>
+                </a:solidFill>
+                <a:latin typeface="Liberation Mono"/>
+                <a:cs typeface="Liberation Mono"/>
+              </a:rPr>
+              <a:t>packed_experts</a:t>
+            </a:r>
+            <a:r>
+              <a:rPr lang="en-US" sz="1900" b="0" dirty="0">
+                <a:solidFill>
+                  <a:srgbClr val="222222"/>
+                </a:solidFill>
+                <a:latin typeface="Liberation Mono"/>
+                <a:cs typeface="Liberation Mono"/>
+              </a:rPr>
+              <a:t>[</a:t>
+            </a:r>
+            <a:r>
+              <a:rPr lang="en-US" sz="1900" b="0" dirty="0">
+                <a:solidFill>
+                  <a:srgbClr val="222222"/>
+                </a:solidFill>
+                <a:latin typeface="Liberation Mono"/>
+                <a:cs typeface="Liberation Mono"/>
+              </a:rPr>
+              <a:t>:</a:t>
+            </a:r>
+            <a:r>
+              <a:rPr lang="en-US" sz="1900" b="0" dirty="0">
+                <a:solidFill>
+                  <a:srgbClr val="222222"/>
+                </a:solidFill>
+                <a:latin typeface="Liberation Mono"/>
+                <a:cs typeface="Liberation Mono"/>
+              </a:rPr>
+              <a:t>,</a:t>
+            </a:r>
+            <a:r>
+              <a:rPr lang="en-US" sz="1900" b="0" dirty="0">
+                <a:solidFill>
+                  <a:srgbClr val="222222"/>
+                </a:solidFill>
+                <a:latin typeface="Liberation Mono"/>
+                <a:cs typeface="Liberation Mono"/>
+              </a:rPr>
+              <a:t> </a:t>
+            </a:r>
+            <a:r>
+              <a:rPr lang="en-US" sz="1900" b="1" dirty="0">
+                <a:solidFill>
+                  <a:srgbClr val="295897"/>
+                </a:solidFill>
+                <a:latin typeface="Liberation Mono"/>
+                <a:cs typeface="Liberation Mono"/>
+              </a:rPr>
+              <a:t>None</a:t>
+            </a:r>
+            <a:r>
+              <a:rPr lang="en-US" sz="1900" b="0" dirty="0">
+                <a:solidFill>
+                  <a:srgbClr val="222222"/>
+                </a:solidFill>
+                <a:latin typeface="Liberation Mono"/>
+                <a:cs typeface="Liberation Mono"/>
+              </a:rPr>
+              <a:t>]</a:t>
+            </a:r>
+            <a:r>
+              <a:rPr lang="en-US" sz="1900" b="0" dirty="0">
+                <a:solidFill>
+                  <a:srgbClr val="222222"/>
+                </a:solidFill>
+                <a:latin typeface="Liberation Mono"/>
+                <a:cs typeface="Liberation Mono"/>
+              </a:rPr>
+              <a:t> </a:t>
+            </a:r>
+            <a:r>
+              <a:rPr lang="en-US" sz="1900" b="0" dirty="0">
+                <a:solidFill>
+                  <a:srgbClr val="222222"/>
+                </a:solidFill>
+                <a:latin typeface="Liberation Mono"/>
+                <a:cs typeface="Liberation Mono"/>
+              </a:rPr>
+              <a:t>==</a:t>
+            </a:r>
+            <a:endParaRPr lang="en-US" sz="1900" dirty="0"/>
+          </a:p>
+          <a:p>
+            <a:pPr marL="0" indent="0" algn="l">
+              <a:lnSpc>
+                <a:spcPts val="2300"/>
+              </a:lnSpc>
+              <a:buNone/>
+            </a:pPr>
+            <a:r>
+              <a:rPr lang="en-US" sz="1900" b="0" dirty="0">
+                <a:solidFill>
+                  <a:srgbClr val="222222"/>
+                </a:solidFill>
+                <a:latin typeface="Liberation Mono"/>
+                <a:cs typeface="Liberation Mono"/>
+              </a:rPr>
+              <a:t>           </a:t>
+            </a:r>
+            <a:r>
+              <a:rPr lang="en-US" sz="1900" b="0" dirty="0">
+                <a:solidFill>
+                  <a:srgbClr val="222222"/>
+                </a:solidFill>
+                <a:latin typeface="Liberation Mono"/>
+                <a:cs typeface="Liberation Mono"/>
+              </a:rPr>
+              <a:t>local_expert_ids</a:t>
+            </a:r>
+            <a:r>
+              <a:rPr lang="en-US" sz="1900" b="0" dirty="0">
+                <a:solidFill>
+                  <a:srgbClr val="222222"/>
+                </a:solidFill>
+                <a:latin typeface="Liberation Mono"/>
+                <a:cs typeface="Liberation Mono"/>
+              </a:rPr>
+              <a:t>[</a:t>
+            </a:r>
+            <a:r>
+              <a:rPr lang="en-US" sz="1900" b="1" dirty="0">
+                <a:solidFill>
+                  <a:srgbClr val="295897"/>
+                </a:solidFill>
+                <a:latin typeface="Liberation Mono"/>
+                <a:cs typeface="Liberation Mono"/>
+              </a:rPr>
+              <a:t>None</a:t>
+            </a:r>
+            <a:r>
+              <a:rPr lang="en-US" sz="1900" b="0" dirty="0">
+                <a:solidFill>
+                  <a:srgbClr val="222222"/>
+                </a:solidFill>
+                <a:latin typeface="Liberation Mono"/>
+                <a:cs typeface="Liberation Mono"/>
+              </a:rPr>
+              <a:t>,</a:t>
+            </a:r>
+            <a:r>
+              <a:rPr lang="en-US" sz="1900" b="0" dirty="0">
+                <a:solidFill>
+                  <a:srgbClr val="222222"/>
+                </a:solidFill>
+                <a:latin typeface="Liberation Mono"/>
+                <a:cs typeface="Liberation Mono"/>
+              </a:rPr>
+              <a:t> </a:t>
+            </a:r>
+            <a:r>
+              <a:rPr lang="en-US" sz="1900" b="0" dirty="0">
+                <a:solidFill>
+                  <a:srgbClr val="222222"/>
+                </a:solidFill>
+                <a:latin typeface="Liberation Mono"/>
+                <a:cs typeface="Liberation Mono"/>
+              </a:rPr>
+              <a:t>:</a:t>
+            </a:r>
+            <a:r>
+              <a:rPr lang="en-US" sz="1900" b="0" dirty="0">
+                <a:solidFill>
+                  <a:srgbClr val="222222"/>
+                </a:solidFill>
+                <a:latin typeface="Liberation Mono"/>
+                <a:cs typeface="Liberation Mono"/>
+              </a:rPr>
+              <a:t>]</a:t>
+            </a:r>
+            <a:r>
+              <a:rPr lang="en-US" sz="1900" b="0" dirty="0">
+                <a:solidFill>
+                  <a:srgbClr val="222222"/>
+                </a:solidFill>
+                <a:latin typeface="Liberation Mono"/>
+                <a:cs typeface="Liberation Mono"/>
+              </a:rPr>
+              <a:t>)</a:t>
+            </a:r>
+            <a:endParaRPr lang="en-US" sz="1900" dirty="0"/>
+          </a:p>
+          <a:p>
+            <a:pPr marL="0" indent="0" algn="l">
+              <a:lnSpc>
+                <a:spcPts val="2300"/>
+              </a:lnSpc>
+              <a:buNone/>
+            </a:pPr>
+            <a:r>
+              <a:rPr lang="en-US" sz="1900" b="0" dirty="0">
+                <a:solidFill>
+                  <a:srgbClr val="222222"/>
+                </a:solidFill>
+                <a:latin typeface="Liberation Mono"/>
+                <a:cs typeface="Liberation Mono"/>
+              </a:rPr>
+              <a:t>          </a:t>
+            </a:r>
+            <a:r>
+              <a:rPr lang="en-US" sz="1900" b="0" dirty="0">
+                <a:solidFill>
+                  <a:srgbClr val="222222"/>
+                </a:solidFill>
+                <a:latin typeface="Liberation Mono"/>
+                <a:cs typeface="Liberation Mono"/>
+              </a:rPr>
+              <a:t>&amp;</a:t>
+            </a:r>
+            <a:r>
+              <a:rPr lang="en-US" sz="1900" b="0" dirty="0">
+                <a:solidFill>
+                  <a:srgbClr val="222222"/>
+                </a:solidFill>
+                <a:latin typeface="Liberation Mono"/>
+                <a:cs typeface="Liberation Mono"/>
+              </a:rPr>
+              <a:t> </a:t>
+            </a:r>
+            <a:r>
+              <a:rPr lang="en-US" sz="1900" b="0" dirty="0">
+                <a:solidFill>
+                  <a:srgbClr val="222222"/>
+                </a:solidFill>
+                <a:latin typeface="Liberation Mono"/>
+                <a:cs typeface="Liberation Mono"/>
+              </a:rPr>
+              <a:t>packed_valid</a:t>
+            </a:r>
+            <a:r>
+              <a:rPr lang="en-US" sz="1900" b="0" dirty="0">
+                <a:solidFill>
+                  <a:srgbClr val="222222"/>
+                </a:solidFill>
+                <a:latin typeface="Liberation Mono"/>
+                <a:cs typeface="Liberation Mono"/>
+              </a:rPr>
+              <a:t>[</a:t>
+            </a:r>
+            <a:r>
+              <a:rPr lang="en-US" sz="1900" b="0" dirty="0">
+                <a:solidFill>
+                  <a:srgbClr val="222222"/>
+                </a:solidFill>
+                <a:latin typeface="Liberation Mono"/>
+                <a:cs typeface="Liberation Mono"/>
+              </a:rPr>
+              <a:t>:</a:t>
+            </a:r>
+            <a:r>
+              <a:rPr lang="en-US" sz="1900" b="0" dirty="0">
+                <a:solidFill>
+                  <a:srgbClr val="222222"/>
+                </a:solidFill>
+                <a:latin typeface="Liberation Mono"/>
+                <a:cs typeface="Liberation Mono"/>
+              </a:rPr>
+              <a:t>,</a:t>
+            </a:r>
+            <a:r>
+              <a:rPr lang="en-US" sz="1900" b="0" dirty="0">
+                <a:solidFill>
+                  <a:srgbClr val="222222"/>
+                </a:solidFill>
+                <a:latin typeface="Liberation Mono"/>
+                <a:cs typeface="Liberation Mono"/>
+              </a:rPr>
+              <a:t> </a:t>
+            </a:r>
+            <a:r>
+              <a:rPr lang="en-US" sz="1900" b="1" dirty="0">
+                <a:solidFill>
+                  <a:srgbClr val="295897"/>
+                </a:solidFill>
+                <a:latin typeface="Liberation Mono"/>
+                <a:cs typeface="Liberation Mono"/>
+              </a:rPr>
+              <a:t>None</a:t>
+            </a:r>
+            <a:r>
+              <a:rPr lang="en-US" sz="1900" b="0" dirty="0">
+                <a:solidFill>
+                  <a:srgbClr val="222222"/>
+                </a:solidFill>
+                <a:latin typeface="Liberation Mono"/>
+                <a:cs typeface="Liberation Mono"/>
+              </a:rPr>
+              <a:t>]</a:t>
+            </a:r>
+            <a:r>
+              <a:rPr lang="en-US" sz="1900" b="0" dirty="0">
+                <a:solidFill>
+                  <a:srgbClr val="222222"/>
+                </a:solidFill>
+                <a:latin typeface="Liberation Mono"/>
+                <a:cs typeface="Liberation Mono"/>
+              </a:rPr>
+              <a:t>)</a:t>
+            </a:r>
+            <a:r>
+              <a:rPr lang="en-US" sz="1900" b="0" dirty="0">
+                <a:solidFill>
+                  <a:srgbClr val="222222"/>
+                </a:solidFill>
+                <a:latin typeface="Liberation Mono"/>
+                <a:cs typeface="Liberation Mono"/>
+              </a:rPr>
+              <a:t>.</a:t>
+            </a:r>
+            <a:r>
+              <a:rPr lang="en-US" sz="1900" b="0" dirty="0">
+                <a:solidFill>
+                  <a:srgbClr val="222222"/>
+                </a:solidFill>
+                <a:latin typeface="Liberation Mono"/>
+                <a:cs typeface="Liberation Mono"/>
+              </a:rPr>
+              <a:t>sum</a:t>
+            </a:r>
+            <a:r>
+              <a:rPr lang="en-US" sz="1900" b="0" dirty="0">
+                <a:solidFill>
+                  <a:srgbClr val="222222"/>
+                </a:solidFill>
+                <a:latin typeface="Liberation Mono"/>
+                <a:cs typeface="Liberation Mono"/>
+              </a:rPr>
+              <a:t>(</a:t>
+            </a:r>
+            <a:r>
+              <a:rPr lang="en-US" sz="1900" b="0" dirty="0">
+                <a:solidFill>
+                  <a:srgbClr val="1A6E6F"/>
+                </a:solidFill>
+                <a:latin typeface="Liberation Mono"/>
+                <a:cs typeface="Liberation Mono"/>
+              </a:rPr>
+              <a:t>0</a:t>
+            </a:r>
+            <a:r>
+              <a:rPr lang="en-US" sz="1900" b="0" dirty="0">
+                <a:solidFill>
+                  <a:srgbClr val="222222"/>
+                </a:solidFill>
+                <a:latin typeface="Liberation Mono"/>
+                <a:cs typeface="Liberation Mono"/>
+              </a:rPr>
+              <a:t>)</a:t>
+            </a:r>
+            <a:endParaRPr lang="en-US" sz="1900" dirty="0"/>
+          </a:p>
+          <a:p>
+            <a:pPr marL="0" indent="0" algn="l">
+              <a:lnSpc>
+                <a:spcPts val="2300"/>
+              </a:lnSpc>
+              <a:buNone/>
+            </a:pPr>
+            <a:r>
+              <a:rPr lang="en-US" sz="1900" b="0" dirty="0">
+                <a:solidFill>
+                  <a:srgbClr val="222222"/>
+                </a:solidFill>
+                <a:latin typeface="Liberation Mono"/>
+                <a:cs typeface="Liberation Mono"/>
+              </a:rPr>
+              <a:t>offsets</a:t>
+            </a:r>
+            <a:r>
+              <a:rPr lang="en-US" sz="1900" b="0" dirty="0">
+                <a:solidFill>
+                  <a:srgbClr val="222222"/>
+                </a:solidFill>
+                <a:latin typeface="Liberation Mono"/>
+                <a:cs typeface="Liberation Mono"/>
+              </a:rPr>
+              <a:t> </a:t>
+            </a:r>
+            <a:r>
+              <a:rPr lang="en-US" sz="1900" b="0" dirty="0">
+                <a:solidFill>
+                  <a:srgbClr val="222222"/>
+                </a:solidFill>
+                <a:latin typeface="Liberation Mono"/>
+                <a:cs typeface="Liberation Mono"/>
+              </a:rPr>
+              <a:t>=</a:t>
+            </a:r>
+            <a:r>
+              <a:rPr lang="en-US" sz="1900" b="0" dirty="0">
+                <a:solidFill>
+                  <a:srgbClr val="222222"/>
+                </a:solidFill>
+                <a:latin typeface="Liberation Mono"/>
+                <a:cs typeface="Liberation Mono"/>
+              </a:rPr>
+              <a:t> </a:t>
+            </a:r>
+            <a:r>
+              <a:rPr lang="en-US" sz="1900" b="0" dirty="0">
+                <a:solidFill>
+                  <a:srgbClr val="222222"/>
+                </a:solidFill>
+                <a:latin typeface="Liberation Mono"/>
+                <a:cs typeface="Liberation Mono"/>
+              </a:rPr>
+              <a:t>torch</a:t>
+            </a:r>
+            <a:r>
+              <a:rPr lang="en-US" sz="1900" b="0" dirty="0">
+                <a:solidFill>
+                  <a:srgbClr val="222222"/>
+                </a:solidFill>
+                <a:latin typeface="Liberation Mono"/>
+                <a:cs typeface="Liberation Mono"/>
+              </a:rPr>
+              <a:t>.</a:t>
+            </a:r>
+            <a:r>
+              <a:rPr lang="en-US" sz="1900" b="0" dirty="0">
+                <a:solidFill>
+                  <a:srgbClr val="222222"/>
+                </a:solidFill>
+                <a:latin typeface="Liberation Mono"/>
+                <a:cs typeface="Liberation Mono"/>
+              </a:rPr>
+              <a:t>cumsum</a:t>
+            </a:r>
+            <a:r>
+              <a:rPr lang="en-US" sz="1900" b="0" dirty="0">
+                <a:solidFill>
+                  <a:srgbClr val="222222"/>
+                </a:solidFill>
+                <a:latin typeface="Liberation Mono"/>
+                <a:cs typeface="Liberation Mono"/>
+              </a:rPr>
+              <a:t>(</a:t>
+            </a:r>
+            <a:r>
+              <a:rPr lang="en-US" sz="1900" b="0" dirty="0">
+                <a:solidFill>
+                  <a:srgbClr val="222222"/>
+                </a:solidFill>
+                <a:latin typeface="Liberation Mono"/>
+                <a:cs typeface="Liberation Mono"/>
+              </a:rPr>
+              <a:t>counts</a:t>
+            </a:r>
+            <a:r>
+              <a:rPr lang="en-US" sz="1900" b="0" dirty="0">
+                <a:solidFill>
+                  <a:srgbClr val="222222"/>
+                </a:solidFill>
+                <a:latin typeface="Liberation Mono"/>
+                <a:cs typeface="Liberation Mono"/>
+              </a:rPr>
+              <a:t>,</a:t>
+            </a:r>
+            <a:r>
+              <a:rPr lang="en-US" sz="1900" b="0" dirty="0">
+                <a:solidFill>
+                  <a:srgbClr val="222222"/>
+                </a:solidFill>
+                <a:latin typeface="Liberation Mono"/>
+                <a:cs typeface="Liberation Mono"/>
+              </a:rPr>
+              <a:t> </a:t>
+            </a:r>
+            <a:r>
+              <a:rPr lang="en-US" sz="1900" b="0" dirty="0">
+                <a:solidFill>
+                  <a:srgbClr val="1A6E6F"/>
+                </a:solidFill>
+                <a:latin typeface="Liberation Mono"/>
+                <a:cs typeface="Liberation Mono"/>
+              </a:rPr>
+              <a:t>0</a:t>
+            </a:r>
+            <a:r>
+              <a:rPr lang="en-US" sz="1900" b="0" dirty="0">
+                <a:solidFill>
+                  <a:srgbClr val="222222"/>
+                </a:solidFill>
+                <a:latin typeface="Liberation Mono"/>
+                <a:cs typeface="Liberation Mono"/>
+              </a:rPr>
+              <a:t>,</a:t>
+            </a:r>
+            <a:r>
+              <a:rPr lang="en-US" sz="1900" b="0" dirty="0">
+                <a:solidFill>
+                  <a:srgbClr val="222222"/>
+                </a:solidFill>
+                <a:latin typeface="Liberation Mono"/>
+                <a:cs typeface="Liberation Mono"/>
+              </a:rPr>
+              <a:t> </a:t>
+            </a:r>
+            <a:r>
+              <a:rPr lang="en-US" sz="1900" b="0" dirty="0">
+                <a:solidFill>
+                  <a:srgbClr val="222222"/>
+                </a:solidFill>
+                <a:latin typeface="Liberation Mono"/>
+                <a:cs typeface="Liberation Mono"/>
+              </a:rPr>
+              <a:t>dtype</a:t>
+            </a:r>
+            <a:r>
+              <a:rPr lang="en-US" sz="1900" b="0" dirty="0">
+                <a:solidFill>
+                  <a:srgbClr val="222222"/>
+                </a:solidFill>
+                <a:latin typeface="Liberation Mono"/>
+                <a:cs typeface="Liberation Mono"/>
+              </a:rPr>
+              <a:t>=</a:t>
+            </a:r>
+            <a:r>
+              <a:rPr lang="en-US" sz="1900" b="0" dirty="0">
+                <a:solidFill>
+                  <a:srgbClr val="222222"/>
+                </a:solidFill>
+                <a:latin typeface="Liberation Mono"/>
+                <a:cs typeface="Liberation Mono"/>
+              </a:rPr>
+              <a:t>torch</a:t>
+            </a:r>
+            <a:r>
+              <a:rPr lang="en-US" sz="1900" b="0" dirty="0">
+                <a:solidFill>
+                  <a:srgbClr val="222222"/>
+                </a:solidFill>
+                <a:latin typeface="Liberation Mono"/>
+                <a:cs typeface="Liberation Mono"/>
+              </a:rPr>
+              <a:t>.</a:t>
+            </a:r>
+            <a:r>
+              <a:rPr lang="en-US" sz="1900" b="0" dirty="0">
+                <a:solidFill>
+                  <a:srgbClr val="222222"/>
+                </a:solidFill>
+                <a:latin typeface="Liberation Mono"/>
+                <a:cs typeface="Liberation Mono"/>
+              </a:rPr>
+              <a:t>int32</a:t>
+            </a:r>
+            <a:r>
+              <a:rPr lang="en-US" sz="1900" b="0" dirty="0">
+                <a:solidFill>
+                  <a:srgbClr val="222222"/>
+                </a:solidFill>
+                <a:latin typeface="Liberation Mono"/>
+                <a:cs typeface="Liberation Mono"/>
+              </a:rPr>
+              <a:t>)</a:t>
+            </a:r>
+            <a:endParaRPr lang="en-US" sz="1900" dirty="0"/>
+          </a:p>
+          <a:p>
+            <a:pPr marL="0" indent="0" algn="l">
+              <a:lnSpc>
+                <a:spcPts val="2300"/>
+              </a:lnSpc>
+              <a:buNone/>
+            </a:pPr>
+            <a:r>
+              <a:rPr lang="en-US" sz="1900" b="0" dirty="0">
+                <a:solidFill>
+                  <a:srgbClr val="222222"/>
+                </a:solidFill>
+                <a:latin typeface="Liberation Mono"/>
+                <a:cs typeface="Liberation Mono"/>
+              </a:rPr>
+              <a:t>packed_output</a:t>
+            </a:r>
+            <a:r>
+              <a:rPr lang="en-US" sz="1900" b="0" dirty="0">
+                <a:solidFill>
+                  <a:srgbClr val="222222"/>
+                </a:solidFill>
+                <a:latin typeface="Liberation Mono"/>
+                <a:cs typeface="Liberation Mono"/>
+              </a:rPr>
+              <a:t> </a:t>
+            </a:r>
+            <a:r>
+              <a:rPr lang="en-US" sz="1900" b="0" dirty="0">
+                <a:solidFill>
+                  <a:srgbClr val="222222"/>
+                </a:solidFill>
+                <a:latin typeface="Liberation Mono"/>
+                <a:cs typeface="Liberation Mono"/>
+              </a:rPr>
+              <a:t>=</a:t>
+            </a:r>
+            <a:r>
+              <a:rPr lang="en-US" sz="1900" b="0" dirty="0">
+                <a:solidFill>
+                  <a:srgbClr val="222222"/>
+                </a:solidFill>
+                <a:latin typeface="Liberation Mono"/>
+                <a:cs typeface="Liberation Mono"/>
+              </a:rPr>
+              <a:t> </a:t>
+            </a:r>
+            <a:r>
+              <a:rPr lang="en-US" sz="1900" b="0" dirty="0">
+                <a:solidFill>
+                  <a:srgbClr val="222222"/>
+                </a:solidFill>
+                <a:latin typeface="Liberation Mono"/>
+                <a:cs typeface="Liberation Mono"/>
+              </a:rPr>
+              <a:t>torch</a:t>
+            </a:r>
+            <a:r>
+              <a:rPr lang="en-US" sz="1900" b="0" dirty="0">
+                <a:solidFill>
+                  <a:srgbClr val="222222"/>
+                </a:solidFill>
+                <a:latin typeface="Liberation Mono"/>
+                <a:cs typeface="Liberation Mono"/>
+              </a:rPr>
+              <a:t>.</a:t>
+            </a:r>
+            <a:r>
+              <a:rPr lang="en-US" sz="1900" b="0" dirty="0">
+                <a:solidFill>
+                  <a:srgbClr val="222222"/>
+                </a:solidFill>
+                <a:latin typeface="Liberation Mono"/>
+                <a:cs typeface="Liberation Mono"/>
+              </a:rPr>
+              <a:t>nn</a:t>
+            </a:r>
+            <a:r>
+              <a:rPr lang="en-US" sz="1900" b="0" dirty="0">
+                <a:solidFill>
+                  <a:srgbClr val="222222"/>
+                </a:solidFill>
+                <a:latin typeface="Liberation Mono"/>
+                <a:cs typeface="Liberation Mono"/>
+              </a:rPr>
+              <a:t>.</a:t>
+            </a:r>
+            <a:r>
+              <a:rPr lang="en-US" sz="1900" b="0" dirty="0">
+                <a:solidFill>
+                  <a:srgbClr val="222222"/>
+                </a:solidFill>
+                <a:latin typeface="Liberation Mono"/>
+                <a:cs typeface="Liberation Mono"/>
+              </a:rPr>
+              <a:t>functional</a:t>
+            </a:r>
+            <a:r>
+              <a:rPr lang="en-US" sz="1900" b="0" dirty="0">
+                <a:solidFill>
+                  <a:srgbClr val="222222"/>
+                </a:solidFill>
+                <a:latin typeface="Liberation Mono"/>
+                <a:cs typeface="Liberation Mono"/>
+              </a:rPr>
+              <a:t>.</a:t>
+            </a:r>
+            <a:r>
+              <a:rPr lang="en-US" sz="1900" b="0" dirty="0">
+                <a:solidFill>
+                  <a:srgbClr val="222222"/>
+                </a:solidFill>
+                <a:latin typeface="Liberation Mono"/>
+                <a:cs typeface="Liberation Mono"/>
+              </a:rPr>
+              <a:t>grouped_mm</a:t>
+            </a:r>
+            <a:r>
+              <a:rPr lang="en-US" sz="1900" b="0" dirty="0">
+                <a:solidFill>
+                  <a:srgbClr val="222222"/>
+                </a:solidFill>
+                <a:latin typeface="Liberation Mono"/>
+                <a:cs typeface="Liberation Mono"/>
+              </a:rPr>
+              <a:t>(</a:t>
+            </a:r>
+            <a:endParaRPr lang="en-US" sz="1900" dirty="0"/>
+          </a:p>
+          <a:p>
+            <a:pPr marL="0" indent="0" algn="l">
+              <a:lnSpc>
+                <a:spcPts val="2300"/>
+              </a:lnSpc>
+              <a:buNone/>
+            </a:pPr>
+            <a:r>
+              <a:rPr lang="en-US" sz="1900" b="0" dirty="0">
+                <a:solidFill>
+                  <a:srgbClr val="222222"/>
+                </a:solidFill>
+                <a:latin typeface="Liberation Mono"/>
+                <a:cs typeface="Liberation Mono"/>
+              </a:rPr>
+              <a:t>    </a:t>
+            </a:r>
+            <a:r>
+              <a:rPr lang="en-US" sz="1900" b="0" dirty="0">
+                <a:solidFill>
+                  <a:srgbClr val="222222"/>
+                </a:solidFill>
+                <a:latin typeface="Liberation Mono"/>
+                <a:cs typeface="Liberation Mono"/>
+              </a:rPr>
+              <a:t>packed_tokens</a:t>
+            </a:r>
+            <a:r>
+              <a:rPr lang="en-US" sz="1900" b="0" dirty="0">
+                <a:solidFill>
+                  <a:srgbClr val="222222"/>
+                </a:solidFill>
+                <a:latin typeface="Liberation Mono"/>
+                <a:cs typeface="Liberation Mono"/>
+              </a:rPr>
+              <a:t>,</a:t>
+            </a:r>
+            <a:r>
+              <a:rPr lang="en-US" sz="1900" b="0" dirty="0">
+                <a:solidFill>
+                  <a:srgbClr val="222222"/>
+                </a:solidFill>
+                <a:latin typeface="Liberation Mono"/>
+                <a:cs typeface="Liberation Mono"/>
+              </a:rPr>
+              <a:t> </a:t>
+            </a:r>
+            <a:r>
+              <a:rPr lang="en-US" sz="1900" b="0" dirty="0">
+                <a:solidFill>
+                  <a:srgbClr val="222222"/>
+                </a:solidFill>
+                <a:latin typeface="Liberation Mono"/>
+                <a:cs typeface="Liberation Mono"/>
+              </a:rPr>
+              <a:t>local_weights</a:t>
+            </a:r>
+            <a:r>
+              <a:rPr lang="en-US" sz="1900" b="0" dirty="0">
+                <a:solidFill>
+                  <a:srgbClr val="222222"/>
+                </a:solidFill>
+                <a:latin typeface="Liberation Mono"/>
+                <a:cs typeface="Liberation Mono"/>
+              </a:rPr>
+              <a:t>.</a:t>
+            </a:r>
+            <a:r>
+              <a:rPr lang="en-US" sz="1900" b="0" dirty="0">
+                <a:solidFill>
+                  <a:srgbClr val="222222"/>
+                </a:solidFill>
+                <a:latin typeface="Liberation Mono"/>
+                <a:cs typeface="Liberation Mono"/>
+              </a:rPr>
+              <a:t>transpose</a:t>
+            </a:r>
+            <a:r>
+              <a:rPr lang="en-US" sz="1900" b="0" dirty="0">
+                <a:solidFill>
+                  <a:srgbClr val="222222"/>
+                </a:solidFill>
+                <a:latin typeface="Liberation Mono"/>
+                <a:cs typeface="Liberation Mono"/>
+              </a:rPr>
+              <a:t>(</a:t>
+            </a:r>
+            <a:r>
+              <a:rPr lang="en-US" sz="1900" b="0" dirty="0">
+                <a:solidFill>
+                  <a:srgbClr val="222222"/>
+                </a:solidFill>
+                <a:latin typeface="Liberation Mono"/>
+                <a:cs typeface="Liberation Mono"/>
+              </a:rPr>
+              <a:t>-</a:t>
+            </a:r>
+            <a:r>
+              <a:rPr lang="en-US" sz="1900" b="0" dirty="0">
+                <a:solidFill>
+                  <a:srgbClr val="1A6E6F"/>
+                </a:solidFill>
+                <a:latin typeface="Liberation Mono"/>
+                <a:cs typeface="Liberation Mono"/>
+              </a:rPr>
+              <a:t>2</a:t>
+            </a:r>
+            <a:r>
+              <a:rPr lang="en-US" sz="1900" b="0" dirty="0">
+                <a:solidFill>
+                  <a:srgbClr val="222222"/>
+                </a:solidFill>
+                <a:latin typeface="Liberation Mono"/>
+                <a:cs typeface="Liberation Mono"/>
+              </a:rPr>
+              <a:t>,</a:t>
+            </a:r>
+            <a:r>
+              <a:rPr lang="en-US" sz="1900" b="0" dirty="0">
+                <a:solidFill>
+                  <a:srgbClr val="222222"/>
+                </a:solidFill>
+                <a:latin typeface="Liberation Mono"/>
+                <a:cs typeface="Liberation Mono"/>
+              </a:rPr>
+              <a:t> </a:t>
+            </a:r>
+            <a:r>
+              <a:rPr lang="en-US" sz="1900" b="0" dirty="0">
+                <a:solidFill>
+                  <a:srgbClr val="222222"/>
+                </a:solidFill>
+                <a:latin typeface="Liberation Mono"/>
+                <a:cs typeface="Liberation Mono"/>
+              </a:rPr>
+              <a:t>-</a:t>
+            </a:r>
+            <a:r>
+              <a:rPr lang="en-US" sz="1900" b="0" dirty="0">
+                <a:solidFill>
+                  <a:srgbClr val="1A6E6F"/>
+                </a:solidFill>
+                <a:latin typeface="Liberation Mono"/>
+                <a:cs typeface="Liberation Mono"/>
+              </a:rPr>
+              <a:t>1</a:t>
+            </a:r>
+            <a:r>
+              <a:rPr lang="en-US" sz="1900" b="0" dirty="0">
+                <a:solidFill>
+                  <a:srgbClr val="222222"/>
+                </a:solidFill>
+                <a:latin typeface="Liberation Mono"/>
+                <a:cs typeface="Liberation Mono"/>
+              </a:rPr>
+              <a:t>)</a:t>
+            </a:r>
+            <a:r>
+              <a:rPr lang="en-US" sz="1900" b="0" dirty="0">
+                <a:solidFill>
+                  <a:srgbClr val="222222"/>
+                </a:solidFill>
+                <a:latin typeface="Liberation Mono"/>
+                <a:cs typeface="Liberation Mono"/>
+              </a:rPr>
+              <a:t>,</a:t>
+            </a:r>
+            <a:endParaRPr lang="en-US" sz="1900" dirty="0"/>
+          </a:p>
+          <a:p>
+            <a:pPr marL="0" indent="0" algn="l">
+              <a:lnSpc>
+                <a:spcPts val="2300"/>
+              </a:lnSpc>
+              <a:buNone/>
+            </a:pPr>
+            <a:r>
+              <a:rPr lang="en-US" sz="1900" b="0" dirty="0">
+                <a:solidFill>
+                  <a:srgbClr val="222222"/>
+                </a:solidFill>
+                <a:latin typeface="Liberation Mono"/>
+                <a:cs typeface="Liberation Mono"/>
+              </a:rPr>
+              <a:t>    </a:t>
+            </a:r>
+            <a:r>
+              <a:rPr lang="en-US" sz="1900" b="0" dirty="0">
+                <a:solidFill>
+                  <a:srgbClr val="222222"/>
+                </a:solidFill>
+                <a:latin typeface="Liberation Mono"/>
+                <a:cs typeface="Liberation Mono"/>
+              </a:rPr>
+              <a:t>offs</a:t>
+            </a:r>
+            <a:r>
+              <a:rPr lang="en-US" sz="1900" b="0" dirty="0">
+                <a:solidFill>
+                  <a:srgbClr val="222222"/>
+                </a:solidFill>
+                <a:latin typeface="Liberation Mono"/>
+                <a:cs typeface="Liberation Mono"/>
+              </a:rPr>
+              <a:t>=</a:t>
+            </a:r>
+            <a:r>
+              <a:rPr lang="en-US" sz="1900" b="0" dirty="0">
+                <a:solidFill>
+                  <a:srgbClr val="222222"/>
+                </a:solidFill>
+                <a:latin typeface="Liberation Mono"/>
+                <a:cs typeface="Liberation Mono"/>
+              </a:rPr>
+              <a:t>offsets</a:t>
+            </a:r>
+            <a:r>
+              <a:rPr lang="en-US" sz="1900" b="0" dirty="0">
+                <a:solidFill>
+                  <a:srgbClr val="222222"/>
+                </a:solidFill>
+                <a:latin typeface="Liberation Mono"/>
+                <a:cs typeface="Liberation Mono"/>
+              </a:rPr>
+              <a:t>)</a:t>
+            </a:r>
+            <a:endParaRPr lang="en-US" sz="1900" dirty="0"/>
+          </a:p>
+        </p:txBody>
+      </p:sp>
+      <p:sp>
+        <p:nvSpPr>
+          <p:cNvPr id="122" name="MoE loop heading"/>
+          <p:cNvSpPr txBox="1"/>
+          <p:nvPr/>
+        </p:nvSpPr>
+        <p:spPr>
+          <a:xfrm>
+            <a:off x="22098000" y="19913600"/>
+            <a:ext cx="10210800" cy="333375"/>
+          </a:xfrm>
+          <a:prstGeom prst="rect">
+            <a:avLst/>
+          </a:prstGeom>
+          <a:noFill/>
+        </p:spPr>
+        <p:txBody>
+          <a:bodyPr wrap="none" lIns="0" tIns="0" rIns="0" bIns="0" anchor="t">
+            <a:noAutofit/>
+          </a:bodyPr>
+          <a:lstStyle/>
+          <a:p>
+            <a:pPr marL="0" indent="0" algn="l">
+              <a:buNone/>
+            </a:pPr>
+            <a:r>
+              <a:rPr lang="en-US" sz="2100" b="1" dirty="0">
+                <a:solidFill>
+                  <a:srgbClr val="222222"/>
+                </a:solidFill>
+                <a:latin typeface="Arial"/>
+                <a:cs typeface="Arial"/>
+              </a:rPr>
+              <a:t>3. Repeat bounded all-to-all rounds on the GPU</a:t>
+            </a:r>
+            <a:endParaRPr lang="en-US" sz="2100" dirty="0"/>
+          </a:p>
+        </p:txBody>
+      </p:sp>
+      <p:sp>
+        <p:nvSpPr>
+          <p:cNvPr id="123" name="Code: MoE while loop highlight"/>
+          <p:cNvSpPr/>
+          <p:nvPr/>
+        </p:nvSpPr>
+        <p:spPr>
+          <a:xfrm>
+            <a:off x="21996400" y="20332700"/>
+            <a:ext cx="10414000" cy="304800"/>
+          </a:xfrm>
+          <a:prstGeom prst="rect">
+            <a:avLst/>
+          </a:prstGeom>
+          <a:solidFill>
+            <a:srgbClr val="FEF1C8"/>
+          </a:solidFill>
+          <a:ln>
+            <a:noFill/>
+          </a:ln>
+        </p:spPr>
+      </p:sp>
+      <p:sp>
+        <p:nvSpPr>
+          <p:cNvPr id="124" name="Code: MoE while loop marker"/>
+          <p:cNvSpPr/>
+          <p:nvPr/>
+        </p:nvSpPr>
+        <p:spPr>
+          <a:xfrm>
+            <a:off x="21996400" y="20332700"/>
+            <a:ext cx="38100" cy="304800"/>
+          </a:xfrm>
+          <a:prstGeom prst="rect">
+            <a:avLst/>
+          </a:prstGeom>
+          <a:solidFill>
+            <a:srgbClr val="C44918"/>
+          </a:solidFill>
+          <a:ln>
+            <a:noFill/>
+          </a:ln>
+        </p:spPr>
+      </p:sp>
+      <p:sp>
+        <p:nvSpPr>
+          <p:cNvPr id="125" name="Code: MoE while loop"/>
+          <p:cNvSpPr txBox="1"/>
+          <p:nvPr/>
+        </p:nvSpPr>
+        <p:spPr>
+          <a:xfrm>
+            <a:off x="22098000" y="20345400"/>
             <a:ext cx="10210800" cy="876300"/>
           </a:xfrm>
           <a:prstGeom prst="rect">
@@ -10969,7 +13311,17 @@
                 <a:latin typeface="Liberation Mono"/>
                 <a:cs typeface="Liberation Mono"/>
               </a:rPr>
-              <a:t>total_rounds</a:t>
+              <a:t>iteration</a:t>
+            </a:r>
+            <a:r>
+              <a:rPr lang="en-US" sz="1900" b="0" dirty="0">
+                <a:solidFill>
+                  <a:srgbClr val="222222"/>
+                </a:solidFill>
+                <a:latin typeface="Liberation Mono"/>
+                <a:cs typeface="Liberation Mono"/>
+              </a:rPr>
+              <a:t>,</a:t>
             </a:r>
             <a:r>
               <a:rPr lang="en-US" sz="1900" b="0" dirty="0">
@@ -10989,6 +13341,56 @@
                 <a:latin typeface="Liberation Mono"/>
                 <a:cs typeface="Liberation Mono"/>
               </a:rPr>
+              <a:t>_</a:t>
+            </a:r>
+            <a:r>
+              <a:rPr lang="en-US" sz="1900" b="0" dirty="0">
+                <a:solidFill>
+                  <a:srgbClr val="222222"/>
+                </a:solidFill>
+                <a:latin typeface="Liberation Mono"/>
+                <a:cs typeface="Liberation Mono"/>
+              </a:rPr>
+              <a:t>,</a:t>
+            </a:r>
+            <a:r>
+              <a:rPr lang="en-US" sz="1900" b="0" dirty="0">
+                <a:solidFill>
+                  <a:srgbClr val="222222"/>
+                </a:solidFill>
+                <a:latin typeface="Liberation Mono"/>
+                <a:cs typeface="Liberation Mono"/>
+              </a:rPr>
+              <a:t> </a:t>
+            </a:r>
+            <a:r>
+              <a:rPr lang="en-US" sz="1900" b="0" dirty="0">
+                <a:solidFill>
+                  <a:srgbClr val="222222"/>
+                </a:solidFill>
+                <a:latin typeface="Liberation Mono"/>
+                <a:cs typeface="Liberation Mono"/>
+              </a:rPr>
+              <a:t>output</a:t>
+            </a:r>
+            <a:r>
+              <a:rPr lang="en-US" sz="1900" b="0" dirty="0">
+                <a:solidFill>
+                  <a:srgbClr val="222222"/>
+                </a:solidFill>
+                <a:latin typeface="Liberation Mono"/>
+                <a:cs typeface="Liberation Mono"/>
+              </a:rPr>
+              <a:t> </a:t>
+            </a:r>
+            <a:r>
+              <a:rPr lang="en-US" sz="1900" b="0" dirty="0">
+                <a:solidFill>
+                  <a:srgbClr val="222222"/>
+                </a:solidFill>
+                <a:latin typeface="Liberation Mono"/>
+                <a:cs typeface="Liberation Mono"/>
+              </a:rPr>
               <a:t>=</a:t>
             </a:r>
             <a:r>
@@ -11002,14 +13404,34 @@
               <a:t> </a:t>
             </a:r>
             <a:r>
-              <a:rPr lang="en-US" sz="1900" b="0" dirty="0">
-                <a:solidFill>
-                  <a:srgbClr val="222222"/>
-                </a:solidFill>
-                <a:latin typeface="Liberation Mono"/>
-                <a:cs typeface="Liberation Mono"/>
-              </a:rPr>
-              <a:t>sync_all_reduce_max</a:t>
+              <a:rPr lang="en-US" sz="1900" b="1" dirty="0">
+                <a:solidFill>
+                  <a:srgbClr val="C44918"/>
+                </a:solidFill>
+                <a:latin typeface="Liberation Mono"/>
+                <a:cs typeface="Liberation Mono"/>
+              </a:rPr>
+              <a:t>torch</a:t>
+            </a:r>
+            <a:r>
+              <a:rPr lang="en-US" sz="1900" b="1" dirty="0">
+                <a:solidFill>
+                  <a:srgbClr val="C44918"/>
+                </a:solidFill>
+                <a:latin typeface="Liberation Mono"/>
+                <a:cs typeface="Liberation Mono"/>
+              </a:rPr>
+              <a:t>.</a:t>
+            </a:r>
+            <a:r>
+              <a:rPr lang="en-US" sz="1900" b="1" dirty="0">
+                <a:solidFill>
+                  <a:srgbClr val="C44918"/>
+                </a:solidFill>
+                <a:latin typeface="Liberation Mono"/>
+                <a:cs typeface="Liberation Mono"/>
+              </a:rPr>
+              <a:t>while_loop</a:t>
             </a:r>
             <a:r>
               <a:rPr lang="en-US" sz="1900" b="0" dirty="0">
@@ -11020,26 +13442,6 @@
                 <a:cs typeface="Liberation Mono"/>
               </a:rPr>
               <a:t>(</a:t>
-            </a:r>
-            <a:r>
-              <a:rPr lang="en-US" sz="1900" b="0" dirty="0">
-                <a:solidFill>
-                  <a:srgbClr val="222222"/>
-                </a:solidFill>
-                <a:latin typeface="Liberation Mono"/>
-                <a:cs typeface="Liberation Mono"/>
-              </a:rPr>
-              <a:t>local_rounds</a:t>
-            </a:r>
-            <a:r>
-              <a:rPr lang="en-US" sz="1900" b="0" dirty="0">
-                <a:solidFill>
-                  <a:srgbClr val="222222"/>
-                </a:solidFill>
-                <a:latin typeface="Liberation Mono"/>
-                <a:cs typeface="Liberation Mono"/>
-              </a:rPr>
-              <a:t>)</a:t>
             </a:r>
             <a:endParaRPr lang="en-US" sz="1900" dirty="0"/>
           </a:p>
@@ -11051,14 +13453,34 @@
               <a:buNone/>
             </a:pPr>
             <a:r>
-              <a:rPr lang="en-US" sz="1900" b="1" dirty="0">
-                <a:solidFill>
-                  <a:srgbClr val="295897"/>
-                </a:solidFill>
-                <a:latin typeface="Liberation Mono"/>
-                <a:cs typeface="Liberation Mono"/>
-              </a:rPr>
-              <a:t>def</a:t>
+              <a:rPr lang="en-US" sz="1900" b="0" dirty="0">
+                <a:solidFill>
+                  <a:srgbClr val="222222"/>
+                </a:solidFill>
+                <a:latin typeface="Liberation Mono"/>
+                <a:cs typeface="Liberation Mono"/>
+              </a:rPr>
+              <a:t>    </a:t>
+            </a:r>
+            <a:r>
+              <a:rPr lang="en-US" sz="1900" b="0" dirty="0">
+                <a:solidFill>
+                  <a:srgbClr val="222222"/>
+                </a:solidFill>
+                <a:latin typeface="Liberation Mono"/>
+                <a:cs typeface="Liberation Mono"/>
+              </a:rPr>
+              <a:t>cond</a:t>
+            </a:r>
+            <a:r>
+              <a:rPr lang="en-US" sz="1900" b="0" dirty="0">
+                <a:solidFill>
+                  <a:srgbClr val="222222"/>
+                </a:solidFill>
+                <a:latin typeface="Liberation Mono"/>
+                <a:cs typeface="Liberation Mono"/>
+              </a:rPr>
+              <a:t>,</a:t>
             </a:r>
             <a:r>
               <a:rPr lang="en-US" sz="1900" b="0" dirty="0">
@@ -11078,7 +13500,27 @@
                 <a:latin typeface="Liberation Mono"/>
                 <a:cs typeface="Liberation Mono"/>
               </a:rPr>
-              <a:t>cond</a:t>
+              <a:t>body</a:t>
+            </a:r>
+            <a:r>
+              <a:rPr lang="en-US" sz="1900" b="0" dirty="0">
+                <a:solidFill>
+                  <a:srgbClr val="222222"/>
+                </a:solidFill>
+                <a:latin typeface="Liberation Mono"/>
+                <a:cs typeface="Liberation Mono"/>
+              </a:rPr>
+              <a:t>,</a:t>
+            </a:r>
+            <a:r>
+              <a:rPr lang="en-US" sz="1900" b="0" dirty="0">
+                <a:solidFill>
+                  <a:srgbClr val="222222"/>
+                </a:solidFill>
+                <a:latin typeface="Liberation Mono"/>
+                <a:cs typeface="Liberation Mono"/>
+              </a:rPr>
+              <a:t> </a:t>
             </a:r>
             <a:r>
               <a:rPr lang="en-US" sz="1900" b="0" dirty="0">
@@ -11178,7 +13620,7 @@
                 <a:latin typeface="Liberation Mono"/>
                 <a:cs typeface="Liberation Mono"/>
               </a:rPr>
-              <a:t>:</a:t>
+              <a:t>)</a:t>
             </a:r>
             <a:endParaRPr lang="en-US" sz="1900" dirty="0"/>
           </a:p>
@@ -11190,16 +13632,6 @@
               <a:buNone/>
             </a:pPr>
             <a:r>
-              <a:rPr lang="en-US" sz="1900" b="0" dirty="0">
-                <a:solidFill>
-                  <a:srgbClr val="222222"/>
-                </a:solidFill>
-                <a:latin typeface="Liberation Mono"/>
-                <a:cs typeface="Liberation Mono"/>
-              </a:rPr>
-              <a:t>    </a:t>
-            </a:r>
-            <a:r>
               <a:rPr lang="en-US" sz="1900" b="1" dirty="0">
                 <a:solidFill>
                   <a:srgbClr val="295897"/>
@@ -11227,47 +13659,37 @@
                 <a:latin typeface="Liberation Mono"/>
                 <a:cs typeface="Liberation Mono"/>
               </a:rPr>
+              <a:t>output</a:t>
+            </a:r>
+            <a:r>
+              <a:rPr lang="en-US" sz="1900" b="0" dirty="0">
+                <a:solidFill>
+                  <a:srgbClr val="222222"/>
+                </a:solidFill>
+                <a:latin typeface="Liberation Mono"/>
+                <a:cs typeface="Liberation Mono"/>
+              </a:rPr>
+              <a:t>,</a:t>
+            </a:r>
+            <a:r>
+              <a:rPr lang="en-US" sz="1900" b="0" dirty="0">
+                <a:solidFill>
+                  <a:srgbClr val="222222"/>
+                </a:solidFill>
+                <a:latin typeface="Liberation Mono"/>
+                <a:cs typeface="Liberation Mono"/>
+              </a:rPr>
+              <a:t> </a:t>
+            </a:r>
+            <a:r>
+              <a:rPr lang="en-US" sz="1900" b="0" dirty="0">
+                <a:solidFill>
+                  <a:srgbClr val="222222"/>
+                </a:solidFill>
+                <a:latin typeface="Liberation Mono"/>
+                <a:cs typeface="Liberation Mono"/>
+              </a:rPr>
               <a:t>iteration</a:t>
-            </a:r>
-            <a:r>
-              <a:rPr lang="en-US" sz="1900" b="0" dirty="0">
-                <a:solidFill>
-                  <a:srgbClr val="222222"/>
-                </a:solidFill>
-                <a:latin typeface="Liberation Mono"/>
-                <a:cs typeface="Liberation Mono"/>
-              </a:rPr>
-              <a:t> </a:t>
-            </a:r>
-            <a:r>
-              <a:rPr lang="en-US" sz="1900" b="0" dirty="0">
-                <a:solidFill>
-                  <a:srgbClr val="222222"/>
-                </a:solidFill>
-                <a:latin typeface="Liberation Mono"/>
-                <a:cs typeface="Liberation Mono"/>
-              </a:rPr>
-              <a:t>&lt;</a:t>
-            </a:r>
-            <a:r>
-              <a:rPr lang="en-US" sz="1900" b="0" dirty="0">
-                <a:solidFill>
-                  <a:srgbClr val="222222"/>
-                </a:solidFill>
-                <a:latin typeface="Liberation Mono"/>
-                <a:cs typeface="Liberation Mono"/>
-              </a:rPr>
-              <a:t> </a:t>
-            </a:r>
-            <a:r>
-              <a:rPr lang="en-US" sz="1900" b="0" dirty="0">
-                <a:solidFill>
-                  <a:srgbClr val="222222"/>
-                </a:solidFill>
-                <a:latin typeface="Liberation Mono"/>
-                <a:cs typeface="Liberation Mono"/>
-              </a:rPr>
-              <a:t>total_rounds</a:t>
             </a:r>
             <a:endParaRPr lang="en-US" sz="1900" dirty="0"/>
           </a:p>
@@ -11275,1660 +13697,7 @@
       </p:sp>
       <p:sp>
         <p:nvSpPr>
-          <p:cNvPr id="116" name="MoE GEMM heading"/>
-          <p:cNvSpPr txBox="1"/>
-          <p:nvPr/>
-        </p:nvSpPr>
-        <p:spPr>
-          <a:xfrm>
-            <a:off x="22098000" y="15430500"/>
-            <a:ext cx="10210800" cy="333375"/>
-          </a:xfrm>
-          <a:prstGeom prst="rect">
-            <a:avLst/>
-          </a:prstGeom>
-          <a:noFill/>
-        </p:spPr>
-        <p:txBody>
-          <a:bodyPr wrap="none" lIns="0" tIns="0" rIns="0" bIns="0" anchor="t">
-            <a:noAutofit/>
-          </a:bodyPr>
-          <a:lstStyle/>
-          <a:p>
-            <a:pPr marL="0" indent="0" algn="l">
-              <a:buNone/>
-            </a:pPr>
-            <a:r>
-              <a:rPr lang="en-US" sz="2100" b="1" dirty="0">
-                <a:solidFill>
-                  <a:srgbClr val="222222"/>
-                </a:solidFill>
-                <a:latin typeface="Arial"/>
-                <a:cs typeface="Arial"/>
-              </a:rPr>
-              <a:t>2. Group packed tokens by expert; run grouped GEMM</a:t>
-            </a:r>
-            <a:endParaRPr lang="en-US" sz="2100" dirty="0"/>
-          </a:p>
-        </p:txBody>
-      </p:sp>
-      <p:sp>
-        <p:nvSpPr>
-          <p:cNvPr id="117" name="Code: MoE grouped GEMM"/>
-          <p:cNvSpPr txBox="1"/>
-          <p:nvPr/>
-        </p:nvSpPr>
-        <p:spPr>
-          <a:xfrm>
-            <a:off x="22098000" y="15862300"/>
-            <a:ext cx="10210800" cy="3213100"/>
-          </a:xfrm>
-          <a:prstGeom prst="rect">
-            <a:avLst/>
-          </a:prstGeom>
-          <a:noFill/>
-        </p:spPr>
-        <p:txBody>
-          <a:bodyPr wrap="none" lIns="0" tIns="0" rIns="0" bIns="0" anchor="t">
-            <a:noAutofit/>
-          </a:bodyPr>
-          <a:lstStyle/>
-          <a:p>
-            <a:pPr marL="0" indent="0" algn="l">
-              <a:lnSpc>
-                <a:spcPts val="2300"/>
-              </a:lnSpc>
-              <a:buNone/>
-            </a:pPr>
-            <a:r>
-              <a:rPr lang="en-US" sz="1900" b="0" dirty="0">
-                <a:solidFill>
-                  <a:srgbClr val="222222"/>
-                </a:solidFill>
-                <a:latin typeface="Liberation Mono"/>
-                <a:cs typeface="Liberation Mono"/>
-              </a:rPr>
-              <a:t>counts</a:t>
-            </a:r>
-            <a:r>
-              <a:rPr lang="en-US" sz="1900" b="0" dirty="0">
-                <a:solidFill>
-                  <a:srgbClr val="222222"/>
-                </a:solidFill>
-                <a:latin typeface="Liberation Mono"/>
-                <a:cs typeface="Liberation Mono"/>
-              </a:rPr>
-              <a:t> </a:t>
-            </a:r>
-            <a:r>
-              <a:rPr lang="en-US" sz="1900" b="0" dirty="0">
-                <a:solidFill>
-                  <a:srgbClr val="222222"/>
-                </a:solidFill>
-                <a:latin typeface="Liberation Mono"/>
-                <a:cs typeface="Liberation Mono"/>
-              </a:rPr>
-              <a:t>=</a:t>
-            </a:r>
-            <a:r>
-              <a:rPr lang="en-US" sz="1900" b="0" dirty="0">
-                <a:solidFill>
-                  <a:srgbClr val="222222"/>
-                </a:solidFill>
-                <a:latin typeface="Liberation Mono"/>
-                <a:cs typeface="Liberation Mono"/>
-              </a:rPr>
-              <a:t> </a:t>
-            </a:r>
-            <a:r>
-              <a:rPr lang="en-US" sz="1900" b="0" dirty="0">
-                <a:solidFill>
-                  <a:srgbClr val="222222"/>
-                </a:solidFill>
-                <a:latin typeface="Liberation Mono"/>
-                <a:cs typeface="Liberation Mono"/>
-              </a:rPr>
-              <a:t>(</a:t>
-            </a:r>
-            <a:endParaRPr lang="en-US" sz="1900" dirty="0"/>
-          </a:p>
-          <a:p>
-            <a:pPr marL="0" indent="0" algn="l">
-              <a:lnSpc>
-                <a:spcPts val="2300"/>
-              </a:lnSpc>
-              <a:buNone/>
-            </a:pPr>
-            <a:r>
-              <a:rPr lang="en-US" sz="1900" b="0" dirty="0">
-                <a:solidFill>
-                  <a:srgbClr val="222222"/>
-                </a:solidFill>
-                <a:latin typeface="Liberation Mono"/>
-                <a:cs typeface="Liberation Mono"/>
-              </a:rPr>
-              <a:t>    </a:t>
-            </a:r>
-            <a:r>
-              <a:rPr lang="en-US" sz="1900" b="0" dirty="0">
-                <a:solidFill>
-                  <a:srgbClr val="222222"/>
-                </a:solidFill>
-                <a:latin typeface="Liberation Mono"/>
-                <a:cs typeface="Liberation Mono"/>
-              </a:rPr>
-              <a:t>(</a:t>
-            </a:r>
-            <a:r>
-              <a:rPr lang="en-US" sz="1900" b="0" dirty="0">
-                <a:solidFill>
-                  <a:srgbClr val="222222"/>
-                </a:solidFill>
-                <a:latin typeface="Liberation Mono"/>
-                <a:cs typeface="Liberation Mono"/>
-              </a:rPr>
-              <a:t>packed_experts</a:t>
-            </a:r>
-            <a:r>
-              <a:rPr lang="en-US" sz="1900" b="0" dirty="0">
-                <a:solidFill>
-                  <a:srgbClr val="222222"/>
-                </a:solidFill>
-                <a:latin typeface="Liberation Mono"/>
-                <a:cs typeface="Liberation Mono"/>
-              </a:rPr>
-              <a:t>[</a:t>
-            </a:r>
-            <a:r>
-              <a:rPr lang="en-US" sz="1900" b="0" dirty="0">
-                <a:solidFill>
-                  <a:srgbClr val="222222"/>
-                </a:solidFill>
-                <a:latin typeface="Liberation Mono"/>
-                <a:cs typeface="Liberation Mono"/>
-              </a:rPr>
-              <a:t>:</a:t>
-            </a:r>
-            <a:r>
-              <a:rPr lang="en-US" sz="1900" b="0" dirty="0">
-                <a:solidFill>
-                  <a:srgbClr val="222222"/>
-                </a:solidFill>
-                <a:latin typeface="Liberation Mono"/>
-                <a:cs typeface="Liberation Mono"/>
-              </a:rPr>
-              <a:t>,</a:t>
-            </a:r>
-            <a:r>
-              <a:rPr lang="en-US" sz="1900" b="0" dirty="0">
-                <a:solidFill>
-                  <a:srgbClr val="222222"/>
-                </a:solidFill>
-                <a:latin typeface="Liberation Mono"/>
-                <a:cs typeface="Liberation Mono"/>
-              </a:rPr>
-              <a:t> </a:t>
-            </a:r>
-            <a:r>
-              <a:rPr lang="en-US" sz="1900" b="1" dirty="0">
-                <a:solidFill>
-                  <a:srgbClr val="295897"/>
-                </a:solidFill>
-                <a:latin typeface="Liberation Mono"/>
-                <a:cs typeface="Liberation Mono"/>
-              </a:rPr>
-              <a:t>None</a:t>
-            </a:r>
-            <a:r>
-              <a:rPr lang="en-US" sz="1900" b="0" dirty="0">
-                <a:solidFill>
-                  <a:srgbClr val="222222"/>
-                </a:solidFill>
-                <a:latin typeface="Liberation Mono"/>
-                <a:cs typeface="Liberation Mono"/>
-              </a:rPr>
-              <a:t>]</a:t>
-            </a:r>
-            <a:endParaRPr lang="en-US" sz="1900" dirty="0"/>
-          </a:p>
-          <a:p>
-            <a:pPr marL="0" indent="0" algn="l">
-              <a:lnSpc>
-                <a:spcPts val="2300"/>
-              </a:lnSpc>
-              <a:buNone/>
-            </a:pPr>
-            <a:r>
-              <a:rPr lang="en-US" sz="1900" b="0" dirty="0">
-                <a:solidFill>
-                  <a:srgbClr val="222222"/>
-                </a:solidFill>
-                <a:latin typeface="Liberation Mono"/>
-                <a:cs typeface="Liberation Mono"/>
-              </a:rPr>
-              <a:t>     </a:t>
-            </a:r>
-            <a:r>
-              <a:rPr lang="en-US" sz="1900" b="0" dirty="0">
-                <a:solidFill>
-                  <a:srgbClr val="222222"/>
-                </a:solidFill>
-                <a:latin typeface="Liberation Mono"/>
-                <a:cs typeface="Liberation Mono"/>
-              </a:rPr>
-              <a:t>==</a:t>
-            </a:r>
-            <a:r>
-              <a:rPr lang="en-US" sz="1900" b="0" dirty="0">
-                <a:solidFill>
-                  <a:srgbClr val="222222"/>
-                </a:solidFill>
-                <a:latin typeface="Liberation Mono"/>
-                <a:cs typeface="Liberation Mono"/>
-              </a:rPr>
-              <a:t> </a:t>
-            </a:r>
-            <a:r>
-              <a:rPr lang="en-US" sz="1900" b="0" dirty="0">
-                <a:solidFill>
-                  <a:srgbClr val="222222"/>
-                </a:solidFill>
-                <a:latin typeface="Liberation Mono"/>
-                <a:cs typeface="Liberation Mono"/>
-              </a:rPr>
-              <a:t>local_expert_ids</a:t>
-            </a:r>
-            <a:r>
-              <a:rPr lang="en-US" sz="1900" b="0" dirty="0">
-                <a:solidFill>
-                  <a:srgbClr val="222222"/>
-                </a:solidFill>
-                <a:latin typeface="Liberation Mono"/>
-                <a:cs typeface="Liberation Mono"/>
-              </a:rPr>
-              <a:t>[</a:t>
-            </a:r>
-            <a:r>
-              <a:rPr lang="en-US" sz="1900" b="1" dirty="0">
-                <a:solidFill>
-                  <a:srgbClr val="295897"/>
-                </a:solidFill>
-                <a:latin typeface="Liberation Mono"/>
-                <a:cs typeface="Liberation Mono"/>
-              </a:rPr>
-              <a:t>None</a:t>
-            </a:r>
-            <a:r>
-              <a:rPr lang="en-US" sz="1900" b="0" dirty="0">
-                <a:solidFill>
-                  <a:srgbClr val="222222"/>
-                </a:solidFill>
-                <a:latin typeface="Liberation Mono"/>
-                <a:cs typeface="Liberation Mono"/>
-              </a:rPr>
-              <a:t>,</a:t>
-            </a:r>
-            <a:r>
-              <a:rPr lang="en-US" sz="1900" b="0" dirty="0">
-                <a:solidFill>
-                  <a:srgbClr val="222222"/>
-                </a:solidFill>
-                <a:latin typeface="Liberation Mono"/>
-                <a:cs typeface="Liberation Mono"/>
-              </a:rPr>
-              <a:t> </a:t>
-            </a:r>
-            <a:r>
-              <a:rPr lang="en-US" sz="1900" b="0" dirty="0">
-                <a:solidFill>
-                  <a:srgbClr val="222222"/>
-                </a:solidFill>
-                <a:latin typeface="Liberation Mono"/>
-                <a:cs typeface="Liberation Mono"/>
-              </a:rPr>
-              <a:t>:</a:t>
-            </a:r>
-            <a:r>
-              <a:rPr lang="en-US" sz="1900" b="0" dirty="0">
-                <a:solidFill>
-                  <a:srgbClr val="222222"/>
-                </a:solidFill>
-                <a:latin typeface="Liberation Mono"/>
-                <a:cs typeface="Liberation Mono"/>
-              </a:rPr>
-              <a:t>]</a:t>
-            </a:r>
-            <a:r>
-              <a:rPr lang="en-US" sz="1900" b="0" dirty="0">
-                <a:solidFill>
-                  <a:srgbClr val="222222"/>
-                </a:solidFill>
-                <a:latin typeface="Liberation Mono"/>
-                <a:cs typeface="Liberation Mono"/>
-              </a:rPr>
-              <a:t>)</a:t>
-            </a:r>
-            <a:endParaRPr lang="en-US" sz="1900" dirty="0"/>
-          </a:p>
-          <a:p>
-            <a:pPr marL="0" indent="0" algn="l">
-              <a:lnSpc>
-                <a:spcPts val="2300"/>
-              </a:lnSpc>
-              <a:buNone/>
-            </a:pPr>
-            <a:r>
-              <a:rPr lang="en-US" sz="1900" b="0" dirty="0">
-                <a:solidFill>
-                  <a:srgbClr val="222222"/>
-                </a:solidFill>
-                <a:latin typeface="Liberation Mono"/>
-                <a:cs typeface="Liberation Mono"/>
-              </a:rPr>
-              <a:t>    </a:t>
-            </a:r>
-            <a:r>
-              <a:rPr lang="en-US" sz="1900" b="0" dirty="0">
-                <a:solidFill>
-                  <a:srgbClr val="222222"/>
-                </a:solidFill>
-                <a:latin typeface="Liberation Mono"/>
-                <a:cs typeface="Liberation Mono"/>
-              </a:rPr>
-              <a:t>&amp;</a:t>
-            </a:r>
-            <a:r>
-              <a:rPr lang="en-US" sz="1900" b="0" dirty="0">
-                <a:solidFill>
-                  <a:srgbClr val="222222"/>
-                </a:solidFill>
-                <a:latin typeface="Liberation Mono"/>
-                <a:cs typeface="Liberation Mono"/>
-              </a:rPr>
-              <a:t> </a:t>
-            </a:r>
-            <a:r>
-              <a:rPr lang="en-US" sz="1900" b="0" dirty="0">
-                <a:solidFill>
-                  <a:srgbClr val="222222"/>
-                </a:solidFill>
-                <a:latin typeface="Liberation Mono"/>
-                <a:cs typeface="Liberation Mono"/>
-              </a:rPr>
-              <a:t>packed_valid</a:t>
-            </a:r>
-            <a:r>
-              <a:rPr lang="en-US" sz="1900" b="0" dirty="0">
-                <a:solidFill>
-                  <a:srgbClr val="222222"/>
-                </a:solidFill>
-                <a:latin typeface="Liberation Mono"/>
-                <a:cs typeface="Liberation Mono"/>
-              </a:rPr>
-              <a:t>[</a:t>
-            </a:r>
-            <a:r>
-              <a:rPr lang="en-US" sz="1900" b="0" dirty="0">
-                <a:solidFill>
-                  <a:srgbClr val="222222"/>
-                </a:solidFill>
-                <a:latin typeface="Liberation Mono"/>
-                <a:cs typeface="Liberation Mono"/>
-              </a:rPr>
-              <a:t>:</a:t>
-            </a:r>
-            <a:r>
-              <a:rPr lang="en-US" sz="1900" b="0" dirty="0">
-                <a:solidFill>
-                  <a:srgbClr val="222222"/>
-                </a:solidFill>
-                <a:latin typeface="Liberation Mono"/>
-                <a:cs typeface="Liberation Mono"/>
-              </a:rPr>
-              <a:t>,</a:t>
-            </a:r>
-            <a:r>
-              <a:rPr lang="en-US" sz="1900" b="0" dirty="0">
-                <a:solidFill>
-                  <a:srgbClr val="222222"/>
-                </a:solidFill>
-                <a:latin typeface="Liberation Mono"/>
-                <a:cs typeface="Liberation Mono"/>
-              </a:rPr>
-              <a:t> </a:t>
-            </a:r>
-            <a:r>
-              <a:rPr lang="en-US" sz="1900" b="1" dirty="0">
-                <a:solidFill>
-                  <a:srgbClr val="295897"/>
-                </a:solidFill>
-                <a:latin typeface="Liberation Mono"/>
-                <a:cs typeface="Liberation Mono"/>
-              </a:rPr>
-              <a:t>None</a:t>
-            </a:r>
-            <a:r>
-              <a:rPr lang="en-US" sz="1900" b="0" dirty="0">
-                <a:solidFill>
-                  <a:srgbClr val="222222"/>
-                </a:solidFill>
-                <a:latin typeface="Liberation Mono"/>
-                <a:cs typeface="Liberation Mono"/>
-              </a:rPr>
-              <a:t>]</a:t>
-            </a:r>
-            <a:endParaRPr lang="en-US" sz="1900" dirty="0"/>
-          </a:p>
-          <a:p>
-            <a:pPr marL="0" indent="0" algn="l">
-              <a:lnSpc>
-                <a:spcPts val="2300"/>
-              </a:lnSpc>
-              <a:buNone/>
-            </a:pPr>
-            <a:r>
-              <a:rPr lang="en-US" sz="1900" b="0" dirty="0">
-                <a:solidFill>
-                  <a:srgbClr val="222222"/>
-                </a:solidFill>
-                <a:latin typeface="Liberation Mono"/>
-                <a:cs typeface="Liberation Mono"/>
-              </a:rPr>
-              <a:t>)</a:t>
-            </a:r>
-            <a:r>
-              <a:rPr lang="en-US" sz="1900" b="0" dirty="0">
-                <a:solidFill>
-                  <a:srgbClr val="222222"/>
-                </a:solidFill>
-                <a:latin typeface="Liberation Mono"/>
-                <a:cs typeface="Liberation Mono"/>
-              </a:rPr>
-              <a:t>.</a:t>
-            </a:r>
-            <a:r>
-              <a:rPr lang="en-US" sz="1900" b="0" dirty="0">
-                <a:solidFill>
-                  <a:srgbClr val="222222"/>
-                </a:solidFill>
-                <a:latin typeface="Liberation Mono"/>
-                <a:cs typeface="Liberation Mono"/>
-              </a:rPr>
-              <a:t>sum</a:t>
-            </a:r>
-            <a:r>
-              <a:rPr lang="en-US" sz="1900" b="0" dirty="0">
-                <a:solidFill>
-                  <a:srgbClr val="222222"/>
-                </a:solidFill>
-                <a:latin typeface="Liberation Mono"/>
-                <a:cs typeface="Liberation Mono"/>
-              </a:rPr>
-              <a:t>(</a:t>
-            </a:r>
-            <a:r>
-              <a:rPr lang="en-US" sz="1900" b="0" dirty="0">
-                <a:solidFill>
-                  <a:srgbClr val="1A6E6F"/>
-                </a:solidFill>
-                <a:latin typeface="Liberation Mono"/>
-                <a:cs typeface="Liberation Mono"/>
-              </a:rPr>
-              <a:t>0</a:t>
-            </a:r>
-            <a:r>
-              <a:rPr lang="en-US" sz="1900" b="0" dirty="0">
-                <a:solidFill>
-                  <a:srgbClr val="222222"/>
-                </a:solidFill>
-                <a:latin typeface="Liberation Mono"/>
-                <a:cs typeface="Liberation Mono"/>
-              </a:rPr>
-              <a:t>)</a:t>
-            </a:r>
-            <a:endParaRPr lang="en-US" sz="1900" dirty="0"/>
-          </a:p>
-          <a:p>
-            <a:pPr marL="0" indent="0" algn="l">
-              <a:lnSpc>
-                <a:spcPts val="2300"/>
-              </a:lnSpc>
-              <a:buNone/>
-            </a:pPr>
-            <a:r>
-              <a:rPr lang="en-US" sz="1900" b="0" dirty="0">
-                <a:solidFill>
-                  <a:srgbClr val="222222"/>
-                </a:solidFill>
-                <a:latin typeface="Liberation Mono"/>
-                <a:cs typeface="Liberation Mono"/>
-              </a:rPr>
-              <a:t>offsets</a:t>
-            </a:r>
-            <a:r>
-              <a:rPr lang="en-US" sz="1900" b="0" dirty="0">
-                <a:solidFill>
-                  <a:srgbClr val="222222"/>
-                </a:solidFill>
-                <a:latin typeface="Liberation Mono"/>
-                <a:cs typeface="Liberation Mono"/>
-              </a:rPr>
-              <a:t> </a:t>
-            </a:r>
-            <a:r>
-              <a:rPr lang="en-US" sz="1900" b="0" dirty="0">
-                <a:solidFill>
-                  <a:srgbClr val="222222"/>
-                </a:solidFill>
-                <a:latin typeface="Liberation Mono"/>
-                <a:cs typeface="Liberation Mono"/>
-              </a:rPr>
-              <a:t>=</a:t>
-            </a:r>
-            <a:r>
-              <a:rPr lang="en-US" sz="1900" b="0" dirty="0">
-                <a:solidFill>
-                  <a:srgbClr val="222222"/>
-                </a:solidFill>
-                <a:latin typeface="Liberation Mono"/>
-                <a:cs typeface="Liberation Mono"/>
-              </a:rPr>
-              <a:t> </a:t>
-            </a:r>
-            <a:r>
-              <a:rPr lang="en-US" sz="1900" b="0" dirty="0">
-                <a:solidFill>
-                  <a:srgbClr val="222222"/>
-                </a:solidFill>
-                <a:latin typeface="Liberation Mono"/>
-                <a:cs typeface="Liberation Mono"/>
-              </a:rPr>
-              <a:t>torch</a:t>
-            </a:r>
-            <a:r>
-              <a:rPr lang="en-US" sz="1900" b="0" dirty="0">
-                <a:solidFill>
-                  <a:srgbClr val="222222"/>
-                </a:solidFill>
-                <a:latin typeface="Liberation Mono"/>
-                <a:cs typeface="Liberation Mono"/>
-              </a:rPr>
-              <a:t>.</a:t>
-            </a:r>
-            <a:r>
-              <a:rPr lang="en-US" sz="1900" b="0" dirty="0">
-                <a:solidFill>
-                  <a:srgbClr val="222222"/>
-                </a:solidFill>
-                <a:latin typeface="Liberation Mono"/>
-                <a:cs typeface="Liberation Mono"/>
-              </a:rPr>
-              <a:t>cumsum</a:t>
-            </a:r>
-            <a:r>
-              <a:rPr lang="en-US" sz="1900" b="0" dirty="0">
-                <a:solidFill>
-                  <a:srgbClr val="222222"/>
-                </a:solidFill>
-                <a:latin typeface="Liberation Mono"/>
-                <a:cs typeface="Liberation Mono"/>
-              </a:rPr>
-              <a:t>(</a:t>
-            </a:r>
-            <a:r>
-              <a:rPr lang="en-US" sz="1900" b="0" dirty="0">
-                <a:solidFill>
-                  <a:srgbClr val="222222"/>
-                </a:solidFill>
-                <a:latin typeface="Liberation Mono"/>
-                <a:cs typeface="Liberation Mono"/>
-              </a:rPr>
-              <a:t>counts</a:t>
-            </a:r>
-            <a:r>
-              <a:rPr lang="en-US" sz="1900" b="0" dirty="0">
-                <a:solidFill>
-                  <a:srgbClr val="222222"/>
-                </a:solidFill>
-                <a:latin typeface="Liberation Mono"/>
-                <a:cs typeface="Liberation Mono"/>
-              </a:rPr>
-              <a:t>,</a:t>
-            </a:r>
-            <a:r>
-              <a:rPr lang="en-US" sz="1900" b="0" dirty="0">
-                <a:solidFill>
-                  <a:srgbClr val="222222"/>
-                </a:solidFill>
-                <a:latin typeface="Liberation Mono"/>
-                <a:cs typeface="Liberation Mono"/>
-              </a:rPr>
-              <a:t> </a:t>
-            </a:r>
-            <a:r>
-              <a:rPr lang="en-US" sz="1900" b="0" dirty="0">
-                <a:solidFill>
-                  <a:srgbClr val="1A6E6F"/>
-                </a:solidFill>
-                <a:latin typeface="Liberation Mono"/>
-                <a:cs typeface="Liberation Mono"/>
-              </a:rPr>
-              <a:t>0</a:t>
-            </a:r>
-            <a:r>
-              <a:rPr lang="en-US" sz="1900" b="0" dirty="0">
-                <a:solidFill>
-                  <a:srgbClr val="222222"/>
-                </a:solidFill>
-                <a:latin typeface="Liberation Mono"/>
-                <a:cs typeface="Liberation Mono"/>
-              </a:rPr>
-              <a:t>,</a:t>
-            </a:r>
-            <a:r>
-              <a:rPr lang="en-US" sz="1900" b="0" dirty="0">
-                <a:solidFill>
-                  <a:srgbClr val="222222"/>
-                </a:solidFill>
-                <a:latin typeface="Liberation Mono"/>
-                <a:cs typeface="Liberation Mono"/>
-              </a:rPr>
-              <a:t> </a:t>
-            </a:r>
-            <a:r>
-              <a:rPr lang="en-US" sz="1900" b="0" dirty="0">
-                <a:solidFill>
-                  <a:srgbClr val="222222"/>
-                </a:solidFill>
-                <a:latin typeface="Liberation Mono"/>
-                <a:cs typeface="Liberation Mono"/>
-              </a:rPr>
-              <a:t>dtype</a:t>
-            </a:r>
-            <a:r>
-              <a:rPr lang="en-US" sz="1900" b="0" dirty="0">
-                <a:solidFill>
-                  <a:srgbClr val="222222"/>
-                </a:solidFill>
-                <a:latin typeface="Liberation Mono"/>
-                <a:cs typeface="Liberation Mono"/>
-              </a:rPr>
-              <a:t>=</a:t>
-            </a:r>
-            <a:r>
-              <a:rPr lang="en-US" sz="1900" b="0" dirty="0">
-                <a:solidFill>
-                  <a:srgbClr val="222222"/>
-                </a:solidFill>
-                <a:latin typeface="Liberation Mono"/>
-                <a:cs typeface="Liberation Mono"/>
-              </a:rPr>
-              <a:t>torch</a:t>
-            </a:r>
-            <a:r>
-              <a:rPr lang="en-US" sz="1900" b="0" dirty="0">
-                <a:solidFill>
-                  <a:srgbClr val="222222"/>
-                </a:solidFill>
-                <a:latin typeface="Liberation Mono"/>
-                <a:cs typeface="Liberation Mono"/>
-              </a:rPr>
-              <a:t>.</a:t>
-            </a:r>
-            <a:r>
-              <a:rPr lang="en-US" sz="1900" b="0" dirty="0">
-                <a:solidFill>
-                  <a:srgbClr val="222222"/>
-                </a:solidFill>
-                <a:latin typeface="Liberation Mono"/>
-                <a:cs typeface="Liberation Mono"/>
-              </a:rPr>
-              <a:t>int32</a:t>
-            </a:r>
-            <a:r>
-              <a:rPr lang="en-US" sz="1900" b="0" dirty="0">
-                <a:solidFill>
-                  <a:srgbClr val="222222"/>
-                </a:solidFill>
-                <a:latin typeface="Liberation Mono"/>
-                <a:cs typeface="Liberation Mono"/>
-              </a:rPr>
-              <a:t>)</a:t>
-            </a:r>
-            <a:endParaRPr lang="en-US" sz="1900" dirty="0"/>
-          </a:p>
-          <a:p>
-            <a:pPr marL="0" indent="0" algn="l">
-              <a:lnSpc>
-                <a:spcPts val="2300"/>
-              </a:lnSpc>
-              <a:buNone/>
-            </a:pPr>
-            <a:r>
-              <a:rPr lang="en-US" sz="1900" b="0" dirty="0">
-                <a:solidFill>
-                  <a:srgbClr val="222222"/>
-                </a:solidFill>
-                <a:latin typeface="Liberation Mono"/>
-                <a:cs typeface="Liberation Mono"/>
-              </a:rPr>
-              <a:t>packed_output</a:t>
-            </a:r>
-            <a:r>
-              <a:rPr lang="en-US" sz="1900" b="0" dirty="0">
-                <a:solidFill>
-                  <a:srgbClr val="222222"/>
-                </a:solidFill>
-                <a:latin typeface="Liberation Mono"/>
-                <a:cs typeface="Liberation Mono"/>
-              </a:rPr>
-              <a:t> </a:t>
-            </a:r>
-            <a:r>
-              <a:rPr lang="en-US" sz="1900" b="0" dirty="0">
-                <a:solidFill>
-                  <a:srgbClr val="222222"/>
-                </a:solidFill>
-                <a:latin typeface="Liberation Mono"/>
-                <a:cs typeface="Liberation Mono"/>
-              </a:rPr>
-              <a:t>=</a:t>
-            </a:r>
-            <a:r>
-              <a:rPr lang="en-US" sz="1900" b="0" dirty="0">
-                <a:solidFill>
-                  <a:srgbClr val="222222"/>
-                </a:solidFill>
-                <a:latin typeface="Liberation Mono"/>
-                <a:cs typeface="Liberation Mono"/>
-              </a:rPr>
-              <a:t> </a:t>
-            </a:r>
-            <a:r>
-              <a:rPr lang="en-US" sz="1900" b="0" dirty="0">
-                <a:solidFill>
-                  <a:srgbClr val="222222"/>
-                </a:solidFill>
-                <a:latin typeface="Liberation Mono"/>
-                <a:cs typeface="Liberation Mono"/>
-              </a:rPr>
-              <a:t>torch</a:t>
-            </a:r>
-            <a:r>
-              <a:rPr lang="en-US" sz="1900" b="0" dirty="0">
-                <a:solidFill>
-                  <a:srgbClr val="222222"/>
-                </a:solidFill>
-                <a:latin typeface="Liberation Mono"/>
-                <a:cs typeface="Liberation Mono"/>
-              </a:rPr>
-              <a:t>.</a:t>
-            </a:r>
-            <a:r>
-              <a:rPr lang="en-US" sz="1900" b="0" dirty="0">
-                <a:solidFill>
-                  <a:srgbClr val="222222"/>
-                </a:solidFill>
-                <a:latin typeface="Liberation Mono"/>
-                <a:cs typeface="Liberation Mono"/>
-              </a:rPr>
-              <a:t>nn</a:t>
-            </a:r>
-            <a:r>
-              <a:rPr lang="en-US" sz="1900" b="0" dirty="0">
-                <a:solidFill>
-                  <a:srgbClr val="222222"/>
-                </a:solidFill>
-                <a:latin typeface="Liberation Mono"/>
-                <a:cs typeface="Liberation Mono"/>
-              </a:rPr>
-              <a:t>.</a:t>
-            </a:r>
-            <a:r>
-              <a:rPr lang="en-US" sz="1900" b="0" dirty="0">
-                <a:solidFill>
-                  <a:srgbClr val="222222"/>
-                </a:solidFill>
-                <a:latin typeface="Liberation Mono"/>
-                <a:cs typeface="Liberation Mono"/>
-              </a:rPr>
-              <a:t>functional</a:t>
-            </a:r>
-            <a:r>
-              <a:rPr lang="en-US" sz="1900" b="0" dirty="0">
-                <a:solidFill>
-                  <a:srgbClr val="222222"/>
-                </a:solidFill>
-                <a:latin typeface="Liberation Mono"/>
-                <a:cs typeface="Liberation Mono"/>
-              </a:rPr>
-              <a:t>.</a:t>
-            </a:r>
-            <a:r>
-              <a:rPr lang="en-US" sz="1900" b="0" dirty="0">
-                <a:solidFill>
-                  <a:srgbClr val="222222"/>
-                </a:solidFill>
-                <a:latin typeface="Liberation Mono"/>
-                <a:cs typeface="Liberation Mono"/>
-              </a:rPr>
-              <a:t>grouped_mm</a:t>
-            </a:r>
-            <a:r>
-              <a:rPr lang="en-US" sz="1900" b="0" dirty="0">
-                <a:solidFill>
-                  <a:srgbClr val="222222"/>
-                </a:solidFill>
-                <a:latin typeface="Liberation Mono"/>
-                <a:cs typeface="Liberation Mono"/>
-              </a:rPr>
-              <a:t>(</a:t>
-            </a:r>
-            <a:endParaRPr lang="en-US" sz="1900" dirty="0"/>
-          </a:p>
-          <a:p>
-            <a:pPr marL="0" indent="0" algn="l">
-              <a:lnSpc>
-                <a:spcPts val="2300"/>
-              </a:lnSpc>
-              <a:buNone/>
-            </a:pPr>
-            <a:r>
-              <a:rPr lang="en-US" sz="1900" b="0" dirty="0">
-                <a:solidFill>
-                  <a:srgbClr val="222222"/>
-                </a:solidFill>
-                <a:latin typeface="Liberation Mono"/>
-                <a:cs typeface="Liberation Mono"/>
-              </a:rPr>
-              <a:t>    </a:t>
-            </a:r>
-            <a:r>
-              <a:rPr lang="en-US" sz="1900" b="0" dirty="0">
-                <a:solidFill>
-                  <a:srgbClr val="222222"/>
-                </a:solidFill>
-                <a:latin typeface="Liberation Mono"/>
-                <a:cs typeface="Liberation Mono"/>
-              </a:rPr>
-              <a:t>packed_tokens</a:t>
-            </a:r>
-            <a:r>
-              <a:rPr lang="en-US" sz="1900" b="0" dirty="0">
-                <a:solidFill>
-                  <a:srgbClr val="222222"/>
-                </a:solidFill>
-                <a:latin typeface="Liberation Mono"/>
-                <a:cs typeface="Liberation Mono"/>
-              </a:rPr>
-              <a:t>,</a:t>
-            </a:r>
-            <a:endParaRPr lang="en-US" sz="1900" dirty="0"/>
-          </a:p>
-          <a:p>
-            <a:pPr marL="0" indent="0" algn="l">
-              <a:lnSpc>
-                <a:spcPts val="2300"/>
-              </a:lnSpc>
-              <a:buNone/>
-            </a:pPr>
-            <a:r>
-              <a:rPr lang="en-US" sz="1900" b="0" dirty="0">
-                <a:solidFill>
-                  <a:srgbClr val="222222"/>
-                </a:solidFill>
-                <a:latin typeface="Liberation Mono"/>
-                <a:cs typeface="Liberation Mono"/>
-              </a:rPr>
-              <a:t>    </a:t>
-            </a:r>
-            <a:r>
-              <a:rPr lang="en-US" sz="1900" b="0" dirty="0">
-                <a:solidFill>
-                  <a:srgbClr val="222222"/>
-                </a:solidFill>
-                <a:latin typeface="Liberation Mono"/>
-                <a:cs typeface="Liberation Mono"/>
-              </a:rPr>
-              <a:t>local_weights</a:t>
-            </a:r>
-            <a:r>
-              <a:rPr lang="en-US" sz="1900" b="0" dirty="0">
-                <a:solidFill>
-                  <a:srgbClr val="222222"/>
-                </a:solidFill>
-                <a:latin typeface="Liberation Mono"/>
-                <a:cs typeface="Liberation Mono"/>
-              </a:rPr>
-              <a:t>.</a:t>
-            </a:r>
-            <a:r>
-              <a:rPr lang="en-US" sz="1900" b="0" dirty="0">
-                <a:solidFill>
-                  <a:srgbClr val="222222"/>
-                </a:solidFill>
-                <a:latin typeface="Liberation Mono"/>
-                <a:cs typeface="Liberation Mono"/>
-              </a:rPr>
-              <a:t>transpose</a:t>
-            </a:r>
-            <a:r>
-              <a:rPr lang="en-US" sz="1900" b="0" dirty="0">
-                <a:solidFill>
-                  <a:srgbClr val="222222"/>
-                </a:solidFill>
-                <a:latin typeface="Liberation Mono"/>
-                <a:cs typeface="Liberation Mono"/>
-              </a:rPr>
-              <a:t>(</a:t>
-            </a:r>
-            <a:r>
-              <a:rPr lang="en-US" sz="1900" b="0" dirty="0">
-                <a:solidFill>
-                  <a:srgbClr val="222222"/>
-                </a:solidFill>
-                <a:latin typeface="Liberation Mono"/>
-                <a:cs typeface="Liberation Mono"/>
-              </a:rPr>
-              <a:t>-</a:t>
-            </a:r>
-            <a:r>
-              <a:rPr lang="en-US" sz="1900" b="0" dirty="0">
-                <a:solidFill>
-                  <a:srgbClr val="1A6E6F"/>
-                </a:solidFill>
-                <a:latin typeface="Liberation Mono"/>
-                <a:cs typeface="Liberation Mono"/>
-              </a:rPr>
-              <a:t>2</a:t>
-            </a:r>
-            <a:r>
-              <a:rPr lang="en-US" sz="1900" b="0" dirty="0">
-                <a:solidFill>
-                  <a:srgbClr val="222222"/>
-                </a:solidFill>
-                <a:latin typeface="Liberation Mono"/>
-                <a:cs typeface="Liberation Mono"/>
-              </a:rPr>
-              <a:t>,</a:t>
-            </a:r>
-            <a:r>
-              <a:rPr lang="en-US" sz="1900" b="0" dirty="0">
-                <a:solidFill>
-                  <a:srgbClr val="222222"/>
-                </a:solidFill>
-                <a:latin typeface="Liberation Mono"/>
-                <a:cs typeface="Liberation Mono"/>
-              </a:rPr>
-              <a:t> </a:t>
-            </a:r>
-            <a:r>
-              <a:rPr lang="en-US" sz="1900" b="0" dirty="0">
-                <a:solidFill>
-                  <a:srgbClr val="222222"/>
-                </a:solidFill>
-                <a:latin typeface="Liberation Mono"/>
-                <a:cs typeface="Liberation Mono"/>
-              </a:rPr>
-              <a:t>-</a:t>
-            </a:r>
-            <a:r>
-              <a:rPr lang="en-US" sz="1900" b="0" dirty="0">
-                <a:solidFill>
-                  <a:srgbClr val="1A6E6F"/>
-                </a:solidFill>
-                <a:latin typeface="Liberation Mono"/>
-                <a:cs typeface="Liberation Mono"/>
-              </a:rPr>
-              <a:t>1</a:t>
-            </a:r>
-            <a:r>
-              <a:rPr lang="en-US" sz="1900" b="0" dirty="0">
-                <a:solidFill>
-                  <a:srgbClr val="222222"/>
-                </a:solidFill>
-                <a:latin typeface="Liberation Mono"/>
-                <a:cs typeface="Liberation Mono"/>
-              </a:rPr>
-              <a:t>)</a:t>
-            </a:r>
-            <a:r>
-              <a:rPr lang="en-US" sz="1900" b="0" dirty="0">
-                <a:solidFill>
-                  <a:srgbClr val="222222"/>
-                </a:solidFill>
-                <a:latin typeface="Liberation Mono"/>
-                <a:cs typeface="Liberation Mono"/>
-              </a:rPr>
-              <a:t>,</a:t>
-            </a:r>
-            <a:endParaRPr lang="en-US" sz="1900" dirty="0"/>
-          </a:p>
-          <a:p>
-            <a:pPr marL="0" indent="0" algn="l">
-              <a:lnSpc>
-                <a:spcPts val="2300"/>
-              </a:lnSpc>
-              <a:buNone/>
-            </a:pPr>
-            <a:r>
-              <a:rPr lang="en-US" sz="1900" b="0" dirty="0">
-                <a:solidFill>
-                  <a:srgbClr val="222222"/>
-                </a:solidFill>
-                <a:latin typeface="Liberation Mono"/>
-                <a:cs typeface="Liberation Mono"/>
-              </a:rPr>
-              <a:t>    </a:t>
-            </a:r>
-            <a:r>
-              <a:rPr lang="en-US" sz="1900" b="0" dirty="0">
-                <a:solidFill>
-                  <a:srgbClr val="222222"/>
-                </a:solidFill>
-                <a:latin typeface="Liberation Mono"/>
-                <a:cs typeface="Liberation Mono"/>
-              </a:rPr>
-              <a:t>offs</a:t>
-            </a:r>
-            <a:r>
-              <a:rPr lang="en-US" sz="1900" b="0" dirty="0">
-                <a:solidFill>
-                  <a:srgbClr val="222222"/>
-                </a:solidFill>
-                <a:latin typeface="Liberation Mono"/>
-                <a:cs typeface="Liberation Mono"/>
-              </a:rPr>
-              <a:t>=</a:t>
-            </a:r>
-            <a:r>
-              <a:rPr lang="en-US" sz="1900" b="0" dirty="0">
-                <a:solidFill>
-                  <a:srgbClr val="222222"/>
-                </a:solidFill>
-                <a:latin typeface="Liberation Mono"/>
-                <a:cs typeface="Liberation Mono"/>
-              </a:rPr>
-              <a:t>offsets</a:t>
-            </a:r>
-            <a:r>
-              <a:rPr lang="en-US" sz="1900" b="0" dirty="0">
-                <a:solidFill>
-                  <a:srgbClr val="222222"/>
-                </a:solidFill>
-                <a:latin typeface="Liberation Mono"/>
-                <a:cs typeface="Liberation Mono"/>
-              </a:rPr>
-              <a:t>,</a:t>
-            </a:r>
-            <a:endParaRPr lang="en-US" sz="1900" dirty="0"/>
-          </a:p>
-          <a:p>
-            <a:pPr marL="0" indent="0" algn="l">
-              <a:lnSpc>
-                <a:spcPts val="2300"/>
-              </a:lnSpc>
-              <a:buNone/>
-            </a:pPr>
-            <a:r>
-              <a:rPr lang="en-US" sz="1900" b="0" dirty="0">
-                <a:solidFill>
-                  <a:srgbClr val="222222"/>
-                </a:solidFill>
-                <a:latin typeface="Liberation Mono"/>
-                <a:cs typeface="Liberation Mono"/>
-              </a:rPr>
-              <a:t>)</a:t>
-            </a:r>
-            <a:endParaRPr lang="en-US" sz="1900" dirty="0"/>
-          </a:p>
-        </p:txBody>
-      </p:sp>
-      <p:sp>
-        <p:nvSpPr>
-          <p:cNvPr id="118" name="MoE loop heading"/>
-          <p:cNvSpPr txBox="1"/>
-          <p:nvPr/>
-        </p:nvSpPr>
-        <p:spPr>
-          <a:xfrm>
-            <a:off x="22098000" y="19329400"/>
-            <a:ext cx="10210800" cy="333375"/>
-          </a:xfrm>
-          <a:prstGeom prst="rect">
-            <a:avLst/>
-          </a:prstGeom>
-          <a:noFill/>
-        </p:spPr>
-        <p:txBody>
-          <a:bodyPr wrap="none" lIns="0" tIns="0" rIns="0" bIns="0" anchor="t">
-            <a:noAutofit/>
-          </a:bodyPr>
-          <a:lstStyle/>
-          <a:p>
-            <a:pPr marL="0" indent="0" algn="l">
-              <a:buNone/>
-            </a:pPr>
-            <a:r>
-              <a:rPr lang="en-US" sz="2100" b="1" dirty="0">
-                <a:solidFill>
-                  <a:srgbClr val="222222"/>
-                </a:solidFill>
-                <a:latin typeface="Arial"/>
-                <a:cs typeface="Arial"/>
-              </a:rPr>
-              <a:t>3. Repeat bounded all-to-all rounds on the GPU</a:t>
-            </a:r>
-            <a:endParaRPr lang="en-US" sz="2100" dirty="0"/>
-          </a:p>
-        </p:txBody>
-      </p:sp>
-      <p:sp>
-        <p:nvSpPr>
-          <p:cNvPr id="119" name="Code: MoE while loop highlight"/>
-          <p:cNvSpPr/>
-          <p:nvPr/>
-        </p:nvSpPr>
-        <p:spPr>
-          <a:xfrm>
-            <a:off x="21996400" y="19748500"/>
-            <a:ext cx="10414000" cy="304800"/>
-          </a:xfrm>
-          <a:prstGeom prst="rect">
-            <a:avLst/>
-          </a:prstGeom>
-          <a:solidFill>
-            <a:srgbClr val="FEF1C8"/>
-          </a:solidFill>
-          <a:ln>
-            <a:noFill/>
-          </a:ln>
-        </p:spPr>
-      </p:sp>
-      <p:sp>
-        <p:nvSpPr>
-          <p:cNvPr id="120" name="Code: MoE while loop marker"/>
-          <p:cNvSpPr/>
-          <p:nvPr/>
-        </p:nvSpPr>
-        <p:spPr>
-          <a:xfrm>
-            <a:off x="21996400" y="19748500"/>
-            <a:ext cx="38100" cy="304800"/>
-          </a:xfrm>
-          <a:prstGeom prst="rect">
-            <a:avLst/>
-          </a:prstGeom>
-          <a:solidFill>
-            <a:srgbClr val="C44918"/>
-          </a:solidFill>
-          <a:ln>
-            <a:noFill/>
-          </a:ln>
-        </p:spPr>
-      </p:sp>
-      <p:sp>
-        <p:nvSpPr>
-          <p:cNvPr id="121" name="Code: MoE while loop"/>
-          <p:cNvSpPr txBox="1"/>
-          <p:nvPr/>
-        </p:nvSpPr>
-        <p:spPr>
-          <a:xfrm>
-            <a:off x="22098000" y="19761200"/>
-            <a:ext cx="10210800" cy="876300"/>
-          </a:xfrm>
-          <a:prstGeom prst="rect">
-            <a:avLst/>
-          </a:prstGeom>
-          <a:noFill/>
-        </p:spPr>
-        <p:txBody>
-          <a:bodyPr wrap="none" lIns="0" tIns="0" rIns="0" bIns="0" anchor="t">
-            <a:noAutofit/>
-          </a:bodyPr>
-          <a:lstStyle/>
-          <a:p>
-            <a:pPr marL="0" indent="0" algn="l">
-              <a:lnSpc>
-                <a:spcPts val="2300"/>
-              </a:lnSpc>
-              <a:buNone/>
-            </a:pPr>
-            <a:r>
-              <a:rPr lang="en-US" sz="1900" b="0" dirty="0">
-                <a:solidFill>
-                  <a:srgbClr val="222222"/>
-                </a:solidFill>
-                <a:latin typeface="Liberation Mono"/>
-                <a:cs typeface="Liberation Mono"/>
-              </a:rPr>
-              <a:t>iteration</a:t>
-            </a:r>
-            <a:r>
-              <a:rPr lang="en-US" sz="1900" b="0" dirty="0">
-                <a:solidFill>
-                  <a:srgbClr val="222222"/>
-                </a:solidFill>
-                <a:latin typeface="Liberation Mono"/>
-                <a:cs typeface="Liberation Mono"/>
-              </a:rPr>
-              <a:t>,</a:t>
-            </a:r>
-            <a:r>
-              <a:rPr lang="en-US" sz="1900" b="0" dirty="0">
-                <a:solidFill>
-                  <a:srgbClr val="222222"/>
-                </a:solidFill>
-                <a:latin typeface="Liberation Mono"/>
-                <a:cs typeface="Liberation Mono"/>
-              </a:rPr>
-              <a:t> </a:t>
-            </a:r>
-            <a:r>
-              <a:rPr lang="en-US" sz="1900" b="0" dirty="0">
-                <a:solidFill>
-                  <a:srgbClr val="222222"/>
-                </a:solidFill>
-                <a:latin typeface="Liberation Mono"/>
-                <a:cs typeface="Liberation Mono"/>
-              </a:rPr>
-              <a:t>_</a:t>
-            </a:r>
-            <a:r>
-              <a:rPr lang="en-US" sz="1900" b="0" dirty="0">
-                <a:solidFill>
-                  <a:srgbClr val="222222"/>
-                </a:solidFill>
-                <a:latin typeface="Liberation Mono"/>
-                <a:cs typeface="Liberation Mono"/>
-              </a:rPr>
-              <a:t>,</a:t>
-            </a:r>
-            <a:r>
-              <a:rPr lang="en-US" sz="1900" b="0" dirty="0">
-                <a:solidFill>
-                  <a:srgbClr val="222222"/>
-                </a:solidFill>
-                <a:latin typeface="Liberation Mono"/>
-                <a:cs typeface="Liberation Mono"/>
-              </a:rPr>
-              <a:t> </a:t>
-            </a:r>
-            <a:r>
-              <a:rPr lang="en-US" sz="1900" b="0" dirty="0">
-                <a:solidFill>
-                  <a:srgbClr val="222222"/>
-                </a:solidFill>
-                <a:latin typeface="Liberation Mono"/>
-                <a:cs typeface="Liberation Mono"/>
-              </a:rPr>
-              <a:t>output</a:t>
-            </a:r>
-            <a:r>
-              <a:rPr lang="en-US" sz="1900" b="0" dirty="0">
-                <a:solidFill>
-                  <a:srgbClr val="222222"/>
-                </a:solidFill>
-                <a:latin typeface="Liberation Mono"/>
-                <a:cs typeface="Liberation Mono"/>
-              </a:rPr>
-              <a:t> </a:t>
-            </a:r>
-            <a:r>
-              <a:rPr lang="en-US" sz="1900" b="0" dirty="0">
-                <a:solidFill>
-                  <a:srgbClr val="222222"/>
-                </a:solidFill>
-                <a:latin typeface="Liberation Mono"/>
-                <a:cs typeface="Liberation Mono"/>
-              </a:rPr>
-              <a:t>=</a:t>
-            </a:r>
-            <a:r>
-              <a:rPr lang="en-US" sz="1900" b="0" dirty="0">
-                <a:solidFill>
-                  <a:srgbClr val="222222"/>
-                </a:solidFill>
-                <a:latin typeface="Liberation Mono"/>
-                <a:cs typeface="Liberation Mono"/>
-              </a:rPr>
-              <a:t> </a:t>
-            </a:r>
-            <a:r>
-              <a:rPr lang="en-US" sz="1900" b="1" dirty="0">
-                <a:solidFill>
-                  <a:srgbClr val="C44918"/>
-                </a:solidFill>
-                <a:latin typeface="Liberation Mono"/>
-                <a:cs typeface="Liberation Mono"/>
-              </a:rPr>
-              <a:t>torch</a:t>
-            </a:r>
-            <a:r>
-              <a:rPr lang="en-US" sz="1900" b="1" dirty="0">
-                <a:solidFill>
-                  <a:srgbClr val="C44918"/>
-                </a:solidFill>
-                <a:latin typeface="Liberation Mono"/>
-                <a:cs typeface="Liberation Mono"/>
-              </a:rPr>
-              <a:t>.</a:t>
-            </a:r>
-            <a:r>
-              <a:rPr lang="en-US" sz="1900" b="1" dirty="0">
-                <a:solidFill>
-                  <a:srgbClr val="C44918"/>
-                </a:solidFill>
-                <a:latin typeface="Liberation Mono"/>
-                <a:cs typeface="Liberation Mono"/>
-              </a:rPr>
-              <a:t>while_loop</a:t>
-            </a:r>
-            <a:r>
-              <a:rPr lang="en-US" sz="1900" b="0" dirty="0">
-                <a:solidFill>
-                  <a:srgbClr val="222222"/>
-                </a:solidFill>
-                <a:latin typeface="Liberation Mono"/>
-                <a:cs typeface="Liberation Mono"/>
-              </a:rPr>
-              <a:t>(</a:t>
-            </a:r>
-            <a:endParaRPr lang="en-US" sz="1900" dirty="0"/>
-          </a:p>
-          <a:p>
-            <a:pPr marL="0" indent="0" algn="l">
-              <a:lnSpc>
-                <a:spcPts val="2300"/>
-              </a:lnSpc>
-              <a:buNone/>
-            </a:pPr>
-            <a:r>
-              <a:rPr lang="en-US" sz="1900" b="0" dirty="0">
-                <a:solidFill>
-                  <a:srgbClr val="222222"/>
-                </a:solidFill>
-                <a:latin typeface="Liberation Mono"/>
-                <a:cs typeface="Liberation Mono"/>
-              </a:rPr>
-              <a:t>    </a:t>
-            </a:r>
-            <a:r>
-              <a:rPr lang="en-US" sz="1900" b="0" dirty="0">
-                <a:solidFill>
-                  <a:srgbClr val="222222"/>
-                </a:solidFill>
-                <a:latin typeface="Liberation Mono"/>
-                <a:cs typeface="Liberation Mono"/>
-              </a:rPr>
-              <a:t>cond</a:t>
-            </a:r>
-            <a:r>
-              <a:rPr lang="en-US" sz="1900" b="0" dirty="0">
-                <a:solidFill>
-                  <a:srgbClr val="222222"/>
-                </a:solidFill>
-                <a:latin typeface="Liberation Mono"/>
-                <a:cs typeface="Liberation Mono"/>
-              </a:rPr>
-              <a:t>,</a:t>
-            </a:r>
-            <a:r>
-              <a:rPr lang="en-US" sz="1900" b="0" dirty="0">
-                <a:solidFill>
-                  <a:srgbClr val="222222"/>
-                </a:solidFill>
-                <a:latin typeface="Liberation Mono"/>
-                <a:cs typeface="Liberation Mono"/>
-              </a:rPr>
-              <a:t> </a:t>
-            </a:r>
-            <a:r>
-              <a:rPr lang="en-US" sz="1900" b="0" dirty="0">
-                <a:solidFill>
-                  <a:srgbClr val="222222"/>
-                </a:solidFill>
-                <a:latin typeface="Liberation Mono"/>
-                <a:cs typeface="Liberation Mono"/>
-              </a:rPr>
-              <a:t>body</a:t>
-            </a:r>
-            <a:r>
-              <a:rPr lang="en-US" sz="1900" b="0" dirty="0">
-                <a:solidFill>
-                  <a:srgbClr val="222222"/>
-                </a:solidFill>
-                <a:latin typeface="Liberation Mono"/>
-                <a:cs typeface="Liberation Mono"/>
-              </a:rPr>
-              <a:t>,</a:t>
-            </a:r>
-            <a:r>
-              <a:rPr lang="en-US" sz="1900" b="0" dirty="0">
-                <a:solidFill>
-                  <a:srgbClr val="222222"/>
-                </a:solidFill>
-                <a:latin typeface="Liberation Mono"/>
-                <a:cs typeface="Liberation Mono"/>
-              </a:rPr>
-              <a:t> </a:t>
-            </a:r>
-            <a:r>
-              <a:rPr lang="en-US" sz="1900" b="0" dirty="0">
-                <a:solidFill>
-                  <a:srgbClr val="222222"/>
-                </a:solidFill>
-                <a:latin typeface="Liberation Mono"/>
-                <a:cs typeface="Liberation Mono"/>
-              </a:rPr>
-              <a:t>(</a:t>
-            </a:r>
-            <a:r>
-              <a:rPr lang="en-US" sz="1900" b="0" dirty="0">
-                <a:solidFill>
-                  <a:srgbClr val="222222"/>
-                </a:solidFill>
-                <a:latin typeface="Liberation Mono"/>
-                <a:cs typeface="Liberation Mono"/>
-              </a:rPr>
-              <a:t>iteration</a:t>
-            </a:r>
-            <a:r>
-              <a:rPr lang="en-US" sz="1900" b="0" dirty="0">
-                <a:solidFill>
-                  <a:srgbClr val="222222"/>
-                </a:solidFill>
-                <a:latin typeface="Liberation Mono"/>
-                <a:cs typeface="Liberation Mono"/>
-              </a:rPr>
-              <a:t>,</a:t>
-            </a:r>
-            <a:r>
-              <a:rPr lang="en-US" sz="1900" b="0" dirty="0">
-                <a:solidFill>
-                  <a:srgbClr val="222222"/>
-                </a:solidFill>
-                <a:latin typeface="Liberation Mono"/>
-                <a:cs typeface="Liberation Mono"/>
-              </a:rPr>
-              <a:t> </a:t>
-            </a:r>
-            <a:r>
-              <a:rPr lang="en-US" sz="1900" b="0" dirty="0">
-                <a:solidFill>
-                  <a:srgbClr val="222222"/>
-                </a:solidFill>
-                <a:latin typeface="Liberation Mono"/>
-                <a:cs typeface="Liberation Mono"/>
-              </a:rPr>
-              <a:t>done</a:t>
-            </a:r>
-            <a:r>
-              <a:rPr lang="en-US" sz="1900" b="0" dirty="0">
-                <a:solidFill>
-                  <a:srgbClr val="222222"/>
-                </a:solidFill>
-                <a:latin typeface="Liberation Mono"/>
-                <a:cs typeface="Liberation Mono"/>
-              </a:rPr>
-              <a:t>,</a:t>
-            </a:r>
-            <a:r>
-              <a:rPr lang="en-US" sz="1900" b="0" dirty="0">
-                <a:solidFill>
-                  <a:srgbClr val="222222"/>
-                </a:solidFill>
-                <a:latin typeface="Liberation Mono"/>
-                <a:cs typeface="Liberation Mono"/>
-              </a:rPr>
-              <a:t> </a:t>
-            </a:r>
-            <a:r>
-              <a:rPr lang="en-US" sz="1900" b="0" dirty="0">
-                <a:solidFill>
-                  <a:srgbClr val="222222"/>
-                </a:solidFill>
-                <a:latin typeface="Liberation Mono"/>
-                <a:cs typeface="Liberation Mono"/>
-              </a:rPr>
-              <a:t>output</a:t>
-            </a:r>
-            <a:r>
-              <a:rPr lang="en-US" sz="1900" b="0" dirty="0">
-                <a:solidFill>
-                  <a:srgbClr val="222222"/>
-                </a:solidFill>
-                <a:latin typeface="Liberation Mono"/>
-                <a:cs typeface="Liberation Mono"/>
-              </a:rPr>
-              <a:t>)</a:t>
-            </a:r>
-            <a:r>
-              <a:rPr lang="en-US" sz="1900" b="0" dirty="0">
-                <a:solidFill>
-                  <a:srgbClr val="222222"/>
-                </a:solidFill>
-                <a:latin typeface="Liberation Mono"/>
-                <a:cs typeface="Liberation Mono"/>
-              </a:rPr>
-              <a:t>)</a:t>
-            </a:r>
-            <a:endParaRPr lang="en-US" sz="1900" dirty="0"/>
-          </a:p>
-          <a:p>
-            <a:pPr marL="0" indent="0" algn="l">
-              <a:lnSpc>
-                <a:spcPts val="2300"/>
-              </a:lnSpc>
-              <a:buNone/>
-            </a:pPr>
-            <a:r>
-              <a:rPr lang="en-US" sz="1900" b="1" dirty="0">
-                <a:solidFill>
-                  <a:srgbClr val="295897"/>
-                </a:solidFill>
-                <a:latin typeface="Liberation Mono"/>
-                <a:cs typeface="Liberation Mono"/>
-              </a:rPr>
-              <a:t>return</a:t>
-            </a:r>
-            <a:r>
-              <a:rPr lang="en-US" sz="1900" b="0" dirty="0">
-                <a:solidFill>
-                  <a:srgbClr val="222222"/>
-                </a:solidFill>
-                <a:latin typeface="Liberation Mono"/>
-                <a:cs typeface="Liberation Mono"/>
-              </a:rPr>
-              <a:t> </a:t>
-            </a:r>
-            <a:r>
-              <a:rPr lang="en-US" sz="1900" b="0" dirty="0">
-                <a:solidFill>
-                  <a:srgbClr val="222222"/>
-                </a:solidFill>
-                <a:latin typeface="Liberation Mono"/>
-                <a:cs typeface="Liberation Mono"/>
-              </a:rPr>
-              <a:t>output</a:t>
-            </a:r>
-            <a:r>
-              <a:rPr lang="en-US" sz="1900" b="0" dirty="0">
-                <a:solidFill>
-                  <a:srgbClr val="222222"/>
-                </a:solidFill>
-                <a:latin typeface="Liberation Mono"/>
-                <a:cs typeface="Liberation Mono"/>
-              </a:rPr>
-              <a:t>,</a:t>
-            </a:r>
-            <a:r>
-              <a:rPr lang="en-US" sz="1900" b="0" dirty="0">
-                <a:solidFill>
-                  <a:srgbClr val="222222"/>
-                </a:solidFill>
-                <a:latin typeface="Liberation Mono"/>
-                <a:cs typeface="Liberation Mono"/>
-              </a:rPr>
-              <a:t> </a:t>
-            </a:r>
-            <a:r>
-              <a:rPr lang="en-US" sz="1900" b="0" dirty="0">
-                <a:solidFill>
-                  <a:srgbClr val="222222"/>
-                </a:solidFill>
-                <a:latin typeface="Liberation Mono"/>
-                <a:cs typeface="Liberation Mono"/>
-              </a:rPr>
-              <a:t>iteration</a:t>
-            </a:r>
-            <a:endParaRPr lang="en-US" sz="1900" dirty="0"/>
-          </a:p>
-        </p:txBody>
-      </p:sp>
-      <p:sp>
-        <p:nvSpPr>
-          <p:cNvPr id="122" name="MoE excerpt note"/>
-          <p:cNvSpPr txBox="1"/>
-          <p:nvPr/>
-        </p:nvSpPr>
-        <p:spPr>
-          <a:xfrm>
-            <a:off x="22098000" y="20891500"/>
-            <a:ext cx="10210800" cy="285750"/>
-          </a:xfrm>
-          <a:prstGeom prst="rect">
-            <a:avLst/>
-          </a:prstGeom>
-          <a:noFill/>
-        </p:spPr>
-        <p:txBody>
-          <a:bodyPr wrap="none" lIns="0" tIns="0" rIns="0" bIns="0" anchor="t">
-            <a:noAutofit/>
-          </a:bodyPr>
-          <a:lstStyle/>
-          <a:p>
-            <a:pPr marL="0" indent="0" algn="l">
-              <a:buNone/>
-            </a:pPr>
-            <a:r>
-              <a:rPr lang="en-US" sz="1800" b="0" dirty="0">
-                <a:solidFill>
-                  <a:srgbClr val="727070"/>
-                </a:solidFill>
-                <a:latin typeface="Arial"/>
-                <a:cs typeface="Arial"/>
-              </a:rPr>
-              <a:t>Excerpts: routing, packing, returns, and capture helpers omitted.</a:t>
-            </a:r>
-            <a:endParaRPr lang="en-US" sz="1800" dirty="0"/>
-          </a:p>
-        </p:txBody>
-      </p:sp>
-      <p:sp>
-        <p:nvSpPr>
-          <p:cNvPr id="123" name="Divider"/>
+          <p:cNvPr id="126" name="Divider"/>
           <p:cNvSpPr/>
           <p:nvPr/>
         </p:nvSpPr>

</xml_diff>